<commit_message>
Fill public-source slide materials
</commit_message>
<xml_diff>
--- a/deck/should-you-trust-an-ai-mathematician.pptx
+++ b/deck/should-you-trust-an-ai-mathematician.pptx
@@ -5002,13 +5002,15 @@
         <p:spPr>
           <a:xfrm>
             <a:off x="868680" y="1325880"/>
-            <a:ext cx="6400800" cy="4114800"/>
+            <a:ext cx="6903720" cy="4114800"/>
           </a:xfrm>
           <a:prstGeom prst="roundRect">
-            <a:avLst/>
+            <a:avLst>
+              <a:gd name="adj" fmla="val 1333"/>
+            </a:avLst>
           </a:prstGeom>
           <a:solidFill>
-            <a:srgbClr val="E7EEF2"/>
+            <a:srgbClr val="FFFFFF"/>
           </a:solidFill>
           <a:ln w="12700">
             <a:solidFill>
@@ -5026,49 +5028,868 @@
         </p:nvSpPr>
         <p:spPr>
           <a:xfrm>
-            <a:off x="1033272" y="1527048"/>
-            <a:ext cx="6071616" cy="3712464"/>
-          </a:xfrm>
-          <a:prstGeom prst="rect">
-            <a:avLst/>
-          </a:prstGeom>
-          <a:noFill/>
-          <a:ln/>
-        </p:spPr>
-        <p:txBody>
-          <a:bodyPr wrap="square" lIns="635" tIns="635" rIns="635" bIns="635" rtlCol="0" anchor="ctr">
+            <a:off x="1033272" y="1472184"/>
+            <a:ext cx="6574536" cy="457200"/>
+          </a:xfrm>
+          <a:prstGeom prst="rect">
+            <a:avLst/>
+          </a:prstGeom>
+          <a:noFill/>
+          <a:ln/>
+        </p:spPr>
+        <p:txBody>
+          <a:bodyPr wrap="square" lIns="0" tIns="0" rIns="0" bIns="0" rtlCol="0" anchor="ctr"/>
+          <a:lstStyle/>
+          <a:p>
+            <a:pPr indent="0" marL="0">
+              <a:buNone/>
+            </a:pPr>
+            <a:r>
+              <a:rPr lang="en-US" sz="1400" dirty="0">
+                <a:solidFill>
+                  <a:srgbClr val="6B7280"/>
+                </a:solidFill>
+                <a:latin typeface="Arial" pitchFamily="34" charset="0"/>
+                <a:ea typeface="Arial" pitchFamily="34" charset="-122"/>
+                <a:cs typeface="Arial" pitchFamily="34" charset="-120"/>
+              </a:rPr>
+              <a:t>Epoch AI Tier 4 leaderboard</a:t>
+            </a:r>
+            <a:endParaRPr lang="en-US" sz="1400" dirty="0"/>
+          </a:p>
+          <a:p>
+            <a:pPr indent="0" marL="0">
+              <a:buNone/>
+            </a:pPr>
+            <a:r>
+              <a:rPr lang="en-US" sz="1400" dirty="0">
+                <a:solidFill>
+                  <a:srgbClr val="6B7280"/>
+                </a:solidFill>
+                <a:latin typeface="Arial" pitchFamily="34" charset="0"/>
+                <a:ea typeface="Arial" pitchFamily="34" charset="-122"/>
+                <a:cs typeface="Arial" pitchFamily="34" charset="-120"/>
+              </a:rPr>
+              <a:t>Snapshot: March 9, 2026</a:t>
+            </a:r>
+            <a:endParaRPr lang="en-US" sz="1400" dirty="0"/>
+          </a:p>
+        </p:txBody>
+      </p:sp>
+      <p:sp>
+        <p:nvSpPr>
+          <p:cNvPr id="7" name="Text 5"/>
+          <p:cNvSpPr/>
+          <p:nvPr/>
+        </p:nvSpPr>
+        <p:spPr>
+          <a:xfrm>
+            <a:off x="1033272" y="2039112"/>
+            <a:ext cx="2697480" cy="164592"/>
+          </a:xfrm>
+          <a:prstGeom prst="rect">
+            <a:avLst/>
+          </a:prstGeom>
+          <a:noFill/>
+          <a:ln/>
+        </p:spPr>
+        <p:txBody>
+          <a:bodyPr wrap="square" lIns="0" tIns="0" rIns="0" bIns="0" rtlCol="0" anchor="ctr">
             <a:normAutofit/>
           </a:bodyPr>
           <a:lstStyle/>
           <a:p>
-            <a:pPr algn="ctr" indent="0" marL="0">
-              <a:buNone/>
-            </a:pPr>
-            <a:r>
-              <a:rPr lang="en-US" sz="1600" i="1" dirty="0">
-                <a:solidFill>
-                  <a:srgbClr val="6B7280"/>
-                </a:solidFill>
-                <a:latin typeface="Arial" pitchFamily="34" charset="0"/>
-                <a:ea typeface="Arial" pitchFamily="34" charset="-122"/>
-                <a:cs typeface="Arial" pitchFamily="34" charset="-120"/>
-              </a:rPr>
-              <a:t>Insert FrontierMath Tier 4 leaderboard</a:t>
-            </a:r>
-            <a:endParaRPr lang="en-US" sz="1600" dirty="0"/>
-          </a:p>
-        </p:txBody>
-      </p:sp>
-      <p:sp>
-        <p:nvSpPr>
-          <p:cNvPr id="7" name="Text 5"/>
-          <p:cNvSpPr/>
-          <p:nvPr/>
-        </p:nvSpPr>
-        <p:spPr>
-          <a:xfrm>
-            <a:off x="7498080" y="1508760"/>
-            <a:ext cx="3749040" cy="2560320"/>
+            <a:pPr indent="0" marL="0">
+              <a:buNone/>
+            </a:pPr>
+            <a:r>
+              <a:rPr lang="en-US" sz="1250" dirty="0">
+                <a:solidFill>
+                  <a:srgbClr val="1D232B"/>
+                </a:solidFill>
+                <a:latin typeface="Arial" pitchFamily="34" charset="0"/>
+                <a:ea typeface="Arial" pitchFamily="34" charset="-122"/>
+                <a:cs typeface="Arial" pitchFamily="34" charset="-120"/>
+              </a:rPr>
+              <a:t>GPT-5.4 Pro (web)</a:t>
+            </a:r>
+            <a:endParaRPr lang="en-US" sz="1250" dirty="0"/>
+          </a:p>
+        </p:txBody>
+      </p:sp>
+      <p:sp>
+        <p:nvSpPr>
+          <p:cNvPr id="8" name="Shape 6"/>
+          <p:cNvSpPr/>
+          <p:nvPr/>
+        </p:nvSpPr>
+        <p:spPr>
+          <a:xfrm>
+            <a:off x="3776472" y="2057400"/>
+            <a:ext cx="3154680" cy="201168"/>
+          </a:xfrm>
+          <a:prstGeom prst="roundRect">
+            <a:avLst>
+              <a:gd name="adj" fmla="val 13636"/>
+            </a:avLst>
+          </a:prstGeom>
+          <a:solidFill>
+            <a:srgbClr val="ECE7DC"/>
+          </a:solidFill>
+          <a:ln w="12700">
+            <a:solidFill>
+              <a:srgbClr val="ECE7DC"/>
+            </a:solidFill>
+            <a:prstDash val="solid"/>
+          </a:ln>
+        </p:spPr>
+      </p:sp>
+      <p:sp>
+        <p:nvSpPr>
+          <p:cNvPr id="9" name="Shape 7"/>
+          <p:cNvSpPr/>
+          <p:nvPr/>
+        </p:nvSpPr>
+        <p:spPr>
+          <a:xfrm>
+            <a:off x="3776472" y="2057400"/>
+            <a:ext cx="3108960" cy="201168"/>
+          </a:xfrm>
+          <a:prstGeom prst="roundRect">
+            <a:avLst>
+              <a:gd name="adj" fmla="val 13636"/>
+            </a:avLst>
+          </a:prstGeom>
+          <a:solidFill>
+            <a:srgbClr val="3F5C6E"/>
+          </a:solidFill>
+          <a:ln w="12700">
+            <a:solidFill>
+              <a:srgbClr val="3F5C6E"/>
+            </a:solidFill>
+            <a:prstDash val="solid"/>
+          </a:ln>
+        </p:spPr>
+      </p:sp>
+      <p:sp>
+        <p:nvSpPr>
+          <p:cNvPr id="10" name="Text 8"/>
+          <p:cNvSpPr/>
+          <p:nvPr/>
+        </p:nvSpPr>
+        <p:spPr>
+          <a:xfrm>
+            <a:off x="7050024" y="2039112"/>
+            <a:ext cx="640080" cy="164592"/>
+          </a:xfrm>
+          <a:prstGeom prst="rect">
+            <a:avLst/>
+          </a:prstGeom>
+          <a:noFill/>
+          <a:ln/>
+        </p:spPr>
+        <p:txBody>
+          <a:bodyPr wrap="square" lIns="0" tIns="0" rIns="0" bIns="0" rtlCol="0" anchor="ctr"/>
+          <a:lstStyle/>
+          <a:p>
+            <a:pPr algn="r" indent="0" marL="0">
+              <a:buNone/>
+            </a:pPr>
+            <a:r>
+              <a:rPr lang="en-US" sz="1250" dirty="0">
+                <a:solidFill>
+                  <a:srgbClr val="1D232B"/>
+                </a:solidFill>
+                <a:latin typeface="Arial" pitchFamily="34" charset="0"/>
+                <a:ea typeface="Arial" pitchFamily="34" charset="-122"/>
+                <a:cs typeface="Arial" pitchFamily="34" charset="-120"/>
+              </a:rPr>
+              <a:t>37.5%</a:t>
+            </a:r>
+            <a:endParaRPr lang="en-US" sz="1250" dirty="0"/>
+          </a:p>
+        </p:txBody>
+      </p:sp>
+      <p:sp>
+        <p:nvSpPr>
+          <p:cNvPr id="11" name="Text 9"/>
+          <p:cNvSpPr/>
+          <p:nvPr/>
+        </p:nvSpPr>
+        <p:spPr>
+          <a:xfrm>
+            <a:off x="1033272" y="2569464"/>
+            <a:ext cx="2697480" cy="164592"/>
+          </a:xfrm>
+          <a:prstGeom prst="rect">
+            <a:avLst/>
+          </a:prstGeom>
+          <a:noFill/>
+          <a:ln/>
+        </p:spPr>
+        <p:txBody>
+          <a:bodyPr wrap="square" lIns="0" tIns="0" rIns="0" bIns="0" rtlCol="0" anchor="ctr">
+            <a:normAutofit/>
+          </a:bodyPr>
+          <a:lstStyle/>
+          <a:p>
+            <a:pPr indent="0" marL="0">
+              <a:buNone/>
+            </a:pPr>
+            <a:r>
+              <a:rPr lang="en-US" sz="1250" dirty="0">
+                <a:solidFill>
+                  <a:srgbClr val="1D232B"/>
+                </a:solidFill>
+                <a:latin typeface="Arial" pitchFamily="34" charset="0"/>
+                <a:ea typeface="Arial" pitchFamily="34" charset="-122"/>
+                <a:cs typeface="Arial" pitchFamily="34" charset="-120"/>
+              </a:rPr>
+              <a:t>GPT-5.2 (Pro, Web App)</a:t>
+            </a:r>
+            <a:endParaRPr lang="en-US" sz="1250" dirty="0"/>
+          </a:p>
+        </p:txBody>
+      </p:sp>
+      <p:sp>
+        <p:nvSpPr>
+          <p:cNvPr id="12" name="Shape 10"/>
+          <p:cNvSpPr/>
+          <p:nvPr/>
+        </p:nvSpPr>
+        <p:spPr>
+          <a:xfrm>
+            <a:off x="3776472" y="2587752"/>
+            <a:ext cx="3154680" cy="201168"/>
+          </a:xfrm>
+          <a:prstGeom prst="roundRect">
+            <a:avLst>
+              <a:gd name="adj" fmla="val 13636"/>
+            </a:avLst>
+          </a:prstGeom>
+          <a:solidFill>
+            <a:srgbClr val="ECE7DC"/>
+          </a:solidFill>
+          <a:ln w="12700">
+            <a:solidFill>
+              <a:srgbClr val="ECE7DC"/>
+            </a:solidFill>
+            <a:prstDash val="solid"/>
+          </a:ln>
+        </p:spPr>
+      </p:sp>
+      <p:sp>
+        <p:nvSpPr>
+          <p:cNvPr id="13" name="Shape 11"/>
+          <p:cNvSpPr/>
+          <p:nvPr/>
+        </p:nvSpPr>
+        <p:spPr>
+          <a:xfrm>
+            <a:off x="3776472" y="2587752"/>
+            <a:ext cx="2594945" cy="201168"/>
+          </a:xfrm>
+          <a:prstGeom prst="roundRect">
+            <a:avLst>
+              <a:gd name="adj" fmla="val 13636"/>
+            </a:avLst>
+          </a:prstGeom>
+          <a:solidFill>
+            <a:srgbClr val="3F5C6E"/>
+          </a:solidFill>
+          <a:ln w="12700">
+            <a:solidFill>
+              <a:srgbClr val="3F5C6E"/>
+            </a:solidFill>
+            <a:prstDash val="solid"/>
+          </a:ln>
+        </p:spPr>
+      </p:sp>
+      <p:sp>
+        <p:nvSpPr>
+          <p:cNvPr id="14" name="Text 12"/>
+          <p:cNvSpPr/>
+          <p:nvPr/>
+        </p:nvSpPr>
+        <p:spPr>
+          <a:xfrm>
+            <a:off x="7050024" y="2569464"/>
+            <a:ext cx="640080" cy="164592"/>
+          </a:xfrm>
+          <a:prstGeom prst="rect">
+            <a:avLst/>
+          </a:prstGeom>
+          <a:noFill/>
+          <a:ln/>
+        </p:spPr>
+        <p:txBody>
+          <a:bodyPr wrap="square" lIns="0" tIns="0" rIns="0" bIns="0" rtlCol="0" anchor="ctr"/>
+          <a:lstStyle/>
+          <a:p>
+            <a:pPr algn="r" indent="0" marL="0">
+              <a:buNone/>
+            </a:pPr>
+            <a:r>
+              <a:rPr lang="en-US" sz="1250" dirty="0">
+                <a:solidFill>
+                  <a:srgbClr val="1D232B"/>
+                </a:solidFill>
+                <a:latin typeface="Arial" pitchFamily="34" charset="0"/>
+                <a:ea typeface="Arial" pitchFamily="34" charset="-122"/>
+                <a:cs typeface="Arial" pitchFamily="34" charset="-120"/>
+              </a:rPr>
+              <a:t>31.3%</a:t>
+            </a:r>
+            <a:endParaRPr lang="en-US" sz="1250" dirty="0"/>
+          </a:p>
+        </p:txBody>
+      </p:sp>
+      <p:sp>
+        <p:nvSpPr>
+          <p:cNvPr id="15" name="Text 13"/>
+          <p:cNvSpPr/>
+          <p:nvPr/>
+        </p:nvSpPr>
+        <p:spPr>
+          <a:xfrm>
+            <a:off x="1033272" y="3099816"/>
+            <a:ext cx="2697480" cy="164592"/>
+          </a:xfrm>
+          <a:prstGeom prst="rect">
+            <a:avLst/>
+          </a:prstGeom>
+          <a:noFill/>
+          <a:ln/>
+        </p:spPr>
+        <p:txBody>
+          <a:bodyPr wrap="square" lIns="0" tIns="0" rIns="0" bIns="0" rtlCol="0" anchor="ctr">
+            <a:normAutofit/>
+          </a:bodyPr>
+          <a:lstStyle/>
+          <a:p>
+            <a:pPr indent="0" marL="0">
+              <a:buNone/>
+            </a:pPr>
+            <a:r>
+              <a:rPr lang="en-US" sz="1250" dirty="0">
+                <a:solidFill>
+                  <a:srgbClr val="1D232B"/>
+                </a:solidFill>
+                <a:latin typeface="Arial" pitchFamily="34" charset="0"/>
+                <a:ea typeface="Arial" pitchFamily="34" charset="-122"/>
+                <a:cs typeface="Arial" pitchFamily="34" charset="-120"/>
+              </a:rPr>
+              <a:t>GPT-5.4 (xhigh)</a:t>
+            </a:r>
+            <a:endParaRPr lang="en-US" sz="1250" dirty="0"/>
+          </a:p>
+        </p:txBody>
+      </p:sp>
+      <p:sp>
+        <p:nvSpPr>
+          <p:cNvPr id="16" name="Shape 14"/>
+          <p:cNvSpPr/>
+          <p:nvPr/>
+        </p:nvSpPr>
+        <p:spPr>
+          <a:xfrm>
+            <a:off x="3776472" y="3118104"/>
+            <a:ext cx="3154680" cy="201168"/>
+          </a:xfrm>
+          <a:prstGeom prst="roundRect">
+            <a:avLst>
+              <a:gd name="adj" fmla="val 13636"/>
+            </a:avLst>
+          </a:prstGeom>
+          <a:solidFill>
+            <a:srgbClr val="ECE7DC"/>
+          </a:solidFill>
+          <a:ln w="12700">
+            <a:solidFill>
+              <a:srgbClr val="ECE7DC"/>
+            </a:solidFill>
+            <a:prstDash val="solid"/>
+          </a:ln>
+        </p:spPr>
+      </p:sp>
+      <p:sp>
+        <p:nvSpPr>
+          <p:cNvPr id="17" name="Shape 15"/>
+          <p:cNvSpPr/>
+          <p:nvPr/>
+        </p:nvSpPr>
+        <p:spPr>
+          <a:xfrm>
+            <a:off x="3776472" y="3118104"/>
+            <a:ext cx="2246742" cy="201168"/>
+          </a:xfrm>
+          <a:prstGeom prst="roundRect">
+            <a:avLst>
+              <a:gd name="adj" fmla="val 13636"/>
+            </a:avLst>
+          </a:prstGeom>
+          <a:solidFill>
+            <a:srgbClr val="3F5C6E"/>
+          </a:solidFill>
+          <a:ln w="12700">
+            <a:solidFill>
+              <a:srgbClr val="3F5C6E"/>
+            </a:solidFill>
+            <a:prstDash val="solid"/>
+          </a:ln>
+        </p:spPr>
+      </p:sp>
+      <p:sp>
+        <p:nvSpPr>
+          <p:cNvPr id="18" name="Text 16"/>
+          <p:cNvSpPr/>
+          <p:nvPr/>
+        </p:nvSpPr>
+        <p:spPr>
+          <a:xfrm>
+            <a:off x="7050024" y="3099816"/>
+            <a:ext cx="640080" cy="164592"/>
+          </a:xfrm>
+          <a:prstGeom prst="rect">
+            <a:avLst/>
+          </a:prstGeom>
+          <a:noFill/>
+          <a:ln/>
+        </p:spPr>
+        <p:txBody>
+          <a:bodyPr wrap="square" lIns="0" tIns="0" rIns="0" bIns="0" rtlCol="0" anchor="ctr"/>
+          <a:lstStyle/>
+          <a:p>
+            <a:pPr algn="r" indent="0" marL="0">
+              <a:buNone/>
+            </a:pPr>
+            <a:r>
+              <a:rPr lang="en-US" sz="1250" dirty="0">
+                <a:solidFill>
+                  <a:srgbClr val="1D232B"/>
+                </a:solidFill>
+                <a:latin typeface="Arial" pitchFamily="34" charset="0"/>
+                <a:ea typeface="Arial" pitchFamily="34" charset="-122"/>
+                <a:cs typeface="Arial" pitchFamily="34" charset="-120"/>
+              </a:rPr>
+              <a:t>27.1%</a:t>
+            </a:r>
+            <a:endParaRPr lang="en-US" sz="1250" dirty="0"/>
+          </a:p>
+        </p:txBody>
+      </p:sp>
+      <p:sp>
+        <p:nvSpPr>
+          <p:cNvPr id="19" name="Text 17"/>
+          <p:cNvSpPr/>
+          <p:nvPr/>
+        </p:nvSpPr>
+        <p:spPr>
+          <a:xfrm>
+            <a:off x="1033272" y="3630168"/>
+            <a:ext cx="2697480" cy="164592"/>
+          </a:xfrm>
+          <a:prstGeom prst="rect">
+            <a:avLst/>
+          </a:prstGeom>
+          <a:noFill/>
+          <a:ln/>
+        </p:spPr>
+        <p:txBody>
+          <a:bodyPr wrap="square" lIns="0" tIns="0" rIns="0" bIns="0" rtlCol="0" anchor="ctr">
+            <a:normAutofit/>
+          </a:bodyPr>
+          <a:lstStyle/>
+          <a:p>
+            <a:pPr indent="0" marL="0">
+              <a:buNone/>
+            </a:pPr>
+            <a:r>
+              <a:rPr lang="en-US" sz="1250" dirty="0">
+                <a:solidFill>
+                  <a:srgbClr val="1D232B"/>
+                </a:solidFill>
+                <a:latin typeface="Arial" pitchFamily="34" charset="0"/>
+                <a:ea typeface="Arial" pitchFamily="34" charset="-122"/>
+                <a:cs typeface="Arial" pitchFamily="34" charset="-120"/>
+              </a:rPr>
+              <a:t>Claude Opus 4.6 (max)</a:t>
+            </a:r>
+            <a:endParaRPr lang="en-US" sz="1250" dirty="0"/>
+          </a:p>
+        </p:txBody>
+      </p:sp>
+      <p:sp>
+        <p:nvSpPr>
+          <p:cNvPr id="20" name="Shape 18"/>
+          <p:cNvSpPr/>
+          <p:nvPr/>
+        </p:nvSpPr>
+        <p:spPr>
+          <a:xfrm>
+            <a:off x="3776472" y="3648456"/>
+            <a:ext cx="3154680" cy="201168"/>
+          </a:xfrm>
+          <a:prstGeom prst="roundRect">
+            <a:avLst>
+              <a:gd name="adj" fmla="val 13636"/>
+            </a:avLst>
+          </a:prstGeom>
+          <a:solidFill>
+            <a:srgbClr val="ECE7DC"/>
+          </a:solidFill>
+          <a:ln w="12700">
+            <a:solidFill>
+              <a:srgbClr val="ECE7DC"/>
+            </a:solidFill>
+            <a:prstDash val="solid"/>
+          </a:ln>
+        </p:spPr>
+      </p:sp>
+      <p:sp>
+        <p:nvSpPr>
+          <p:cNvPr id="21" name="Shape 19"/>
+          <p:cNvSpPr/>
+          <p:nvPr/>
+        </p:nvSpPr>
+        <p:spPr>
+          <a:xfrm>
+            <a:off x="3776472" y="3648456"/>
+            <a:ext cx="1898538" cy="201168"/>
+          </a:xfrm>
+          <a:prstGeom prst="roundRect">
+            <a:avLst>
+              <a:gd name="adj" fmla="val 13636"/>
+            </a:avLst>
+          </a:prstGeom>
+          <a:solidFill>
+            <a:srgbClr val="3F5C6E"/>
+          </a:solidFill>
+          <a:ln w="12700">
+            <a:solidFill>
+              <a:srgbClr val="3F5C6E"/>
+            </a:solidFill>
+            <a:prstDash val="solid"/>
+          </a:ln>
+        </p:spPr>
+      </p:sp>
+      <p:sp>
+        <p:nvSpPr>
+          <p:cNvPr id="22" name="Text 20"/>
+          <p:cNvSpPr/>
+          <p:nvPr/>
+        </p:nvSpPr>
+        <p:spPr>
+          <a:xfrm>
+            <a:off x="7050024" y="3630168"/>
+            <a:ext cx="640080" cy="164592"/>
+          </a:xfrm>
+          <a:prstGeom prst="rect">
+            <a:avLst/>
+          </a:prstGeom>
+          <a:noFill/>
+          <a:ln/>
+        </p:spPr>
+        <p:txBody>
+          <a:bodyPr wrap="square" lIns="0" tIns="0" rIns="0" bIns="0" rtlCol="0" anchor="ctr"/>
+          <a:lstStyle/>
+          <a:p>
+            <a:pPr algn="r" indent="0" marL="0">
+              <a:buNone/>
+            </a:pPr>
+            <a:r>
+              <a:rPr lang="en-US" sz="1250" dirty="0">
+                <a:solidFill>
+                  <a:srgbClr val="1D232B"/>
+                </a:solidFill>
+                <a:latin typeface="Arial" pitchFamily="34" charset="0"/>
+                <a:ea typeface="Arial" pitchFamily="34" charset="-122"/>
+                <a:cs typeface="Arial" pitchFamily="34" charset="-120"/>
+              </a:rPr>
+              <a:t>22.9%</a:t>
+            </a:r>
+            <a:endParaRPr lang="en-US" sz="1250" dirty="0"/>
+          </a:p>
+        </p:txBody>
+      </p:sp>
+      <p:sp>
+        <p:nvSpPr>
+          <p:cNvPr id="23" name="Text 21"/>
+          <p:cNvSpPr/>
+          <p:nvPr/>
+        </p:nvSpPr>
+        <p:spPr>
+          <a:xfrm>
+            <a:off x="1033272" y="4160520"/>
+            <a:ext cx="2697480" cy="164592"/>
+          </a:xfrm>
+          <a:prstGeom prst="rect">
+            <a:avLst/>
+          </a:prstGeom>
+          <a:noFill/>
+          <a:ln/>
+        </p:spPr>
+        <p:txBody>
+          <a:bodyPr wrap="square" lIns="0" tIns="0" rIns="0" bIns="0" rtlCol="0" anchor="ctr">
+            <a:normAutofit/>
+          </a:bodyPr>
+          <a:lstStyle/>
+          <a:p>
+            <a:pPr indent="0" marL="0">
+              <a:buNone/>
+            </a:pPr>
+            <a:r>
+              <a:rPr lang="en-US" sz="1250" dirty="0">
+                <a:solidFill>
+                  <a:srgbClr val="1D232B"/>
+                </a:solidFill>
+                <a:latin typeface="Arial" pitchFamily="34" charset="0"/>
+                <a:ea typeface="Arial" pitchFamily="34" charset="-122"/>
+                <a:cs typeface="Arial" pitchFamily="34" charset="-120"/>
+              </a:rPr>
+              <a:t>Claude Opus 4.6 (64k thinking)</a:t>
+            </a:r>
+            <a:endParaRPr lang="en-US" sz="1250" dirty="0"/>
+          </a:p>
+        </p:txBody>
+      </p:sp>
+      <p:sp>
+        <p:nvSpPr>
+          <p:cNvPr id="24" name="Shape 22"/>
+          <p:cNvSpPr/>
+          <p:nvPr/>
+        </p:nvSpPr>
+        <p:spPr>
+          <a:xfrm>
+            <a:off x="3776472" y="4178808"/>
+            <a:ext cx="3154680" cy="201168"/>
+          </a:xfrm>
+          <a:prstGeom prst="roundRect">
+            <a:avLst>
+              <a:gd name="adj" fmla="val 13636"/>
+            </a:avLst>
+          </a:prstGeom>
+          <a:solidFill>
+            <a:srgbClr val="ECE7DC"/>
+          </a:solidFill>
+          <a:ln w="12700">
+            <a:solidFill>
+              <a:srgbClr val="ECE7DC"/>
+            </a:solidFill>
+            <a:prstDash val="solid"/>
+          </a:ln>
+        </p:spPr>
+      </p:sp>
+      <p:sp>
+        <p:nvSpPr>
+          <p:cNvPr id="25" name="Shape 23"/>
+          <p:cNvSpPr/>
+          <p:nvPr/>
+        </p:nvSpPr>
+        <p:spPr>
+          <a:xfrm>
+            <a:off x="3776472" y="4178808"/>
+            <a:ext cx="1724436" cy="201168"/>
+          </a:xfrm>
+          <a:prstGeom prst="roundRect">
+            <a:avLst>
+              <a:gd name="adj" fmla="val 13636"/>
+            </a:avLst>
+          </a:prstGeom>
+          <a:solidFill>
+            <a:srgbClr val="3F5C6E"/>
+          </a:solidFill>
+          <a:ln w="12700">
+            <a:solidFill>
+              <a:srgbClr val="3F5C6E"/>
+            </a:solidFill>
+            <a:prstDash val="solid"/>
+          </a:ln>
+        </p:spPr>
+      </p:sp>
+      <p:sp>
+        <p:nvSpPr>
+          <p:cNvPr id="26" name="Text 24"/>
+          <p:cNvSpPr/>
+          <p:nvPr/>
+        </p:nvSpPr>
+        <p:spPr>
+          <a:xfrm>
+            <a:off x="7050024" y="4160520"/>
+            <a:ext cx="640080" cy="164592"/>
+          </a:xfrm>
+          <a:prstGeom prst="rect">
+            <a:avLst/>
+          </a:prstGeom>
+          <a:noFill/>
+          <a:ln/>
+        </p:spPr>
+        <p:txBody>
+          <a:bodyPr wrap="square" lIns="0" tIns="0" rIns="0" bIns="0" rtlCol="0" anchor="ctr"/>
+          <a:lstStyle/>
+          <a:p>
+            <a:pPr algn="r" indent="0" marL="0">
+              <a:buNone/>
+            </a:pPr>
+            <a:r>
+              <a:rPr lang="en-US" sz="1250" dirty="0">
+                <a:solidFill>
+                  <a:srgbClr val="1D232B"/>
+                </a:solidFill>
+                <a:latin typeface="Arial" pitchFamily="34" charset="0"/>
+                <a:ea typeface="Arial" pitchFamily="34" charset="-122"/>
+                <a:cs typeface="Arial" pitchFamily="34" charset="-120"/>
+              </a:rPr>
+              <a:t>20.8%</a:t>
+            </a:r>
+            <a:endParaRPr lang="en-US" sz="1250" dirty="0"/>
+          </a:p>
+        </p:txBody>
+      </p:sp>
+      <p:sp>
+        <p:nvSpPr>
+          <p:cNvPr id="27" name="Text 25"/>
+          <p:cNvSpPr/>
+          <p:nvPr/>
+        </p:nvSpPr>
+        <p:spPr>
+          <a:xfrm>
+            <a:off x="1033272" y="4690872"/>
+            <a:ext cx="2697480" cy="164592"/>
+          </a:xfrm>
+          <a:prstGeom prst="rect">
+            <a:avLst/>
+          </a:prstGeom>
+          <a:noFill/>
+          <a:ln/>
+        </p:spPr>
+        <p:txBody>
+          <a:bodyPr wrap="square" lIns="0" tIns="0" rIns="0" bIns="0" rtlCol="0" anchor="ctr">
+            <a:normAutofit/>
+          </a:bodyPr>
+          <a:lstStyle/>
+          <a:p>
+            <a:pPr indent="0" marL="0">
+              <a:buNone/>
+            </a:pPr>
+            <a:r>
+              <a:rPr lang="en-US" sz="1250" dirty="0">
+                <a:solidFill>
+                  <a:srgbClr val="1D232B"/>
+                </a:solidFill>
+                <a:latin typeface="Arial" pitchFamily="34" charset="0"/>
+                <a:ea typeface="Arial" pitchFamily="34" charset="-122"/>
+                <a:cs typeface="Arial" pitchFamily="34" charset="-120"/>
+              </a:rPr>
+              <a:t>Gemini 3 Pro Preview</a:t>
+            </a:r>
+            <a:endParaRPr lang="en-US" sz="1250" dirty="0"/>
+          </a:p>
+        </p:txBody>
+      </p:sp>
+      <p:sp>
+        <p:nvSpPr>
+          <p:cNvPr id="28" name="Shape 26"/>
+          <p:cNvSpPr/>
+          <p:nvPr/>
+        </p:nvSpPr>
+        <p:spPr>
+          <a:xfrm>
+            <a:off x="3776472" y="4709160"/>
+            <a:ext cx="3154680" cy="201168"/>
+          </a:xfrm>
+          <a:prstGeom prst="roundRect">
+            <a:avLst>
+              <a:gd name="adj" fmla="val 13636"/>
+            </a:avLst>
+          </a:prstGeom>
+          <a:solidFill>
+            <a:srgbClr val="ECE7DC"/>
+          </a:solidFill>
+          <a:ln w="12700">
+            <a:solidFill>
+              <a:srgbClr val="ECE7DC"/>
+            </a:solidFill>
+            <a:prstDash val="solid"/>
+          </a:ln>
+        </p:spPr>
+      </p:sp>
+      <p:sp>
+        <p:nvSpPr>
+          <p:cNvPr id="29" name="Shape 27"/>
+          <p:cNvSpPr/>
+          <p:nvPr/>
+        </p:nvSpPr>
+        <p:spPr>
+          <a:xfrm>
+            <a:off x="3776472" y="4709160"/>
+            <a:ext cx="1558625" cy="201168"/>
+          </a:xfrm>
+          <a:prstGeom prst="roundRect">
+            <a:avLst>
+              <a:gd name="adj" fmla="val 13636"/>
+            </a:avLst>
+          </a:prstGeom>
+          <a:solidFill>
+            <a:srgbClr val="3F5C6E"/>
+          </a:solidFill>
+          <a:ln w="12700">
+            <a:solidFill>
+              <a:srgbClr val="3F5C6E"/>
+            </a:solidFill>
+            <a:prstDash val="solid"/>
+          </a:ln>
+        </p:spPr>
+      </p:sp>
+      <p:sp>
+        <p:nvSpPr>
+          <p:cNvPr id="30" name="Text 28"/>
+          <p:cNvSpPr/>
+          <p:nvPr/>
+        </p:nvSpPr>
+        <p:spPr>
+          <a:xfrm>
+            <a:off x="7050024" y="4690872"/>
+            <a:ext cx="640080" cy="164592"/>
+          </a:xfrm>
+          <a:prstGeom prst="rect">
+            <a:avLst/>
+          </a:prstGeom>
+          <a:noFill/>
+          <a:ln/>
+        </p:spPr>
+        <p:txBody>
+          <a:bodyPr wrap="square" lIns="0" tIns="0" rIns="0" bIns="0" rtlCol="0" anchor="ctr"/>
+          <a:lstStyle/>
+          <a:p>
+            <a:pPr algn="r" indent="0" marL="0">
+              <a:buNone/>
+            </a:pPr>
+            <a:r>
+              <a:rPr lang="en-US" sz="1250" dirty="0">
+                <a:solidFill>
+                  <a:srgbClr val="1D232B"/>
+                </a:solidFill>
+                <a:latin typeface="Arial" pitchFamily="34" charset="0"/>
+                <a:ea typeface="Arial" pitchFamily="34" charset="-122"/>
+                <a:cs typeface="Arial" pitchFamily="34" charset="-120"/>
+              </a:rPr>
+              <a:t>18.8%</a:t>
+            </a:r>
+            <a:endParaRPr lang="en-US" sz="1250" dirty="0"/>
+          </a:p>
+        </p:txBody>
+      </p:sp>
+      <p:sp>
+        <p:nvSpPr>
+          <p:cNvPr id="31" name="Text 29"/>
+          <p:cNvSpPr/>
+          <p:nvPr/>
+        </p:nvSpPr>
+        <p:spPr>
+          <a:xfrm>
+            <a:off x="8046720" y="1508760"/>
+            <a:ext cx="3200400" cy="2560320"/>
           </a:xfrm>
           <a:prstGeom prst="rect">
             <a:avLst/>
@@ -7757,14 +8578,16 @@
         </p:nvSpPr>
         <p:spPr>
           <a:xfrm>
-            <a:off x="6172200" y="1325880"/>
-            <a:ext cx="5074920" cy="3794760"/>
+            <a:off x="6172200" y="1417320"/>
+            <a:ext cx="5074920" cy="3246120"/>
           </a:xfrm>
           <a:prstGeom prst="roundRect">
-            <a:avLst/>
+            <a:avLst>
+              <a:gd name="adj" fmla="val 1690"/>
+            </a:avLst>
           </a:prstGeom>
           <a:solidFill>
-            <a:srgbClr val="E7EEF2"/>
+            <a:srgbClr val="F1EEE5"/>
           </a:solidFill>
           <a:ln w="12700">
             <a:solidFill>
@@ -7782,26 +8605,133 @@
         </p:nvSpPr>
         <p:spPr>
           <a:xfrm>
-            <a:off x="6336792" y="1527048"/>
-            <a:ext cx="4745736" cy="3392424"/>
-          </a:xfrm>
-          <a:prstGeom prst="rect">
-            <a:avLst/>
-          </a:prstGeom>
-          <a:noFill/>
-          <a:ln/>
-        </p:spPr>
-        <p:txBody>
-          <a:bodyPr wrap="square" lIns="635" tIns="635" rIns="635" bIns="635" rtlCol="0" anchor="ctr">
+            <a:off x="6318504" y="1545336"/>
+            <a:ext cx="4782312" cy="2990088"/>
+          </a:xfrm>
+          <a:prstGeom prst="rect">
+            <a:avLst/>
+          </a:prstGeom>
+          <a:noFill/>
+          <a:ln/>
+        </p:spPr>
+        <p:txBody>
+          <a:bodyPr wrap="square" lIns="0" tIns="0" rIns="0" bIns="0" rtlCol="0" anchor="ctr">
             <a:normAutofit/>
           </a:bodyPr>
           <a:lstStyle/>
           <a:p>
-            <a:pPr algn="ctr" indent="0" marL="0">
-              <a:buNone/>
-            </a:pPr>
-            <a:r>
-              <a:rPr lang="en-US" sz="1600" i="1" dirty="0">
+            <a:pPr indent="0" marL="0">
+              <a:buNone/>
+            </a:pPr>
+            <a:r>
+              <a:rPr lang="en-US" sz="1300" dirty="0">
+                <a:solidFill>
+                  <a:srgbClr val="1D232B"/>
+                </a:solidFill>
+                <a:latin typeface="Courier New" pitchFamily="34" charset="0"/>
+                <a:ea typeface="Courier New" pitchFamily="34" charset="-122"/>
+                <a:cs typeface="Courier New" pitchFamily="34" charset="-120"/>
+              </a:rPr>
+              <a:t>theorem continuous_image_compact</a:t>
+            </a:r>
+            <a:endParaRPr lang="en-US" sz="1300" dirty="0"/>
+          </a:p>
+          <a:p>
+            <a:pPr indent="0" marL="0">
+              <a:buNone/>
+            </a:pPr>
+            <a:r>
+              <a:rPr lang="en-US" sz="1300" dirty="0">
+                <a:solidFill>
+                  <a:srgbClr val="1D232B"/>
+                </a:solidFill>
+                <a:latin typeface="Courier New" pitchFamily="34" charset="0"/>
+                <a:ea typeface="Courier New" pitchFamily="34" charset="-122"/>
+                <a:cs typeface="Courier New" pitchFamily="34" charset="-120"/>
+              </a:rPr>
+              <a:t>    {X Y : Type*} [TopologicalSpace X] [TopologicalSpace Y]</a:t>
+            </a:r>
+            <a:endParaRPr lang="en-US" sz="1300" dirty="0"/>
+          </a:p>
+          <a:p>
+            <a:pPr indent="0" marL="0">
+              <a:buNone/>
+            </a:pPr>
+            <a:r>
+              <a:rPr lang="en-US" sz="1300" dirty="0">
+                <a:solidFill>
+                  <a:srgbClr val="1D232B"/>
+                </a:solidFill>
+                <a:latin typeface="Courier New" pitchFamily="34" charset="0"/>
+                <a:ea typeface="Courier New" pitchFamily="34" charset="-122"/>
+                <a:cs typeface="Courier New" pitchFamily="34" charset="-120"/>
+              </a:rPr>
+              <a:t>    {s : Set X} (hs : IsCompact s) {f : X → Y} (hf : Continuous f) :</a:t>
+            </a:r>
+            <a:endParaRPr lang="en-US" sz="1300" dirty="0"/>
+          </a:p>
+          <a:p>
+            <a:pPr indent="0" marL="0">
+              <a:buNone/>
+            </a:pPr>
+            <a:r>
+              <a:rPr lang="en-US" sz="1300" dirty="0">
+                <a:solidFill>
+                  <a:srgbClr val="1D232B"/>
+                </a:solidFill>
+                <a:latin typeface="Courier New" pitchFamily="34" charset="0"/>
+                <a:ea typeface="Courier New" pitchFamily="34" charset="-122"/>
+                <a:cs typeface="Courier New" pitchFamily="34" charset="-120"/>
+              </a:rPr>
+              <a:t>    IsCompact (f '' s) := by</a:t>
+            </a:r>
+            <a:endParaRPr lang="en-US" sz="1300" dirty="0"/>
+          </a:p>
+          <a:p>
+            <a:pPr indent="0" marL="0">
+              <a:buNone/>
+            </a:pPr>
+            <a:r>
+              <a:rPr lang="en-US" sz="1300" dirty="0">
+                <a:solidFill>
+                  <a:srgbClr val="1D232B"/>
+                </a:solidFill>
+                <a:latin typeface="Courier New" pitchFamily="34" charset="0"/>
+                <a:ea typeface="Courier New" pitchFamily="34" charset="-122"/>
+                <a:cs typeface="Courier New" pitchFamily="34" charset="-120"/>
+              </a:rPr>
+              <a:t>  exact hs.image hf</a:t>
+            </a:r>
+            <a:endParaRPr lang="en-US" sz="1300" dirty="0"/>
+          </a:p>
+        </p:txBody>
+      </p:sp>
+      <p:sp>
+        <p:nvSpPr>
+          <p:cNvPr id="8" name="Text 6"/>
+          <p:cNvSpPr/>
+          <p:nvPr/>
+        </p:nvSpPr>
+        <p:spPr>
+          <a:xfrm>
+            <a:off x="6309360" y="4892040"/>
+            <a:ext cx="4663440" cy="411480"/>
+          </a:xfrm>
+          <a:prstGeom prst="rect">
+            <a:avLst/>
+          </a:prstGeom>
+          <a:noFill/>
+          <a:ln/>
+        </p:spPr>
+        <p:txBody>
+          <a:bodyPr wrap="square" lIns="0" tIns="0" rIns="0" bIns="0" rtlCol="0" anchor="ctr"/>
+          <a:lstStyle/>
+          <a:p>
+            <a:pPr indent="0" marL="0">
+              <a:buNone/>
+            </a:pPr>
+            <a:r>
+              <a:rPr lang="en-US" sz="1300" i="1" dirty="0">
                 <a:solidFill>
                   <a:srgbClr val="6B7280"/>
                 </a:solidFill>
@@ -7809,9 +8739,9 @@
                 <a:ea typeface="Arial" pitchFamily="34" charset="-122"/>
                 <a:cs typeface="Arial" pitchFamily="34" charset="-120"/>
               </a:rPr>
-              <a:t>Insert a short, legible Lean snippet</a:t>
-            </a:r>
-            <a:endParaRPr lang="en-US" sz="1600" dirty="0"/>
+              <a:t>A recognizable theorem, but stated with all ambient structure made explicit.</a:t>
+            </a:r>
+            <a:endParaRPr lang="en-US" sz="1300" dirty="0"/>
           </a:p>
         </p:txBody>
       </p:sp>
@@ -9646,22 +10576,47 @@
           </a:p>
         </p:txBody>
       </p:sp>
-      <p:sp>
-        <p:nvSpPr>
-          <p:cNvPr id="5" name="Shape 3"/>
-          <p:cNvSpPr/>
-          <p:nvPr/>
-        </p:nvSpPr>
+      <p:pic>
+        <p:nvPicPr>
+          <p:cNvPr id="5" name="Image 0" descr="/home/matt.linux/talks/2026/oregon/assets/raw-images/urban-paper-01.png">    </p:cNvPr>
+          <p:cNvPicPr>
+            <a:picLocks noChangeAspect="1"/>
+          </p:cNvPicPr>
+          <p:nvPr/>
+        </p:nvPicPr>
+        <p:blipFill>
+          <a:blip r:embed="rId1"/>
+          <a:srcRect l="0" r="0" t="0" b="0"/>
+          <a:stretch/>
+        </p:blipFill>
         <p:spPr>
           <a:xfrm>
             <a:off x="868680" y="1325880"/>
             <a:ext cx="5486400" cy="3840480"/>
           </a:xfrm>
-          <a:prstGeom prst="roundRect">
+          <a:prstGeom prst="rect">
+            <a:avLst/>
+          </a:prstGeom>
+        </p:spPr>
+      </p:pic>
+      <p:sp>
+        <p:nvSpPr>
+          <p:cNvPr id="6" name="Shape 3"/>
+          <p:cNvSpPr/>
+          <p:nvPr/>
+        </p:nvSpPr>
+        <p:spPr>
+          <a:xfrm>
+            <a:off x="868680" y="1325880"/>
+            <a:ext cx="5486400" cy="3840480"/>
+          </a:xfrm>
+          <a:prstGeom prst="rect">
             <a:avLst/>
           </a:prstGeom>
           <a:solidFill>
-            <a:srgbClr val="E7EEF2"/>
+            <a:srgbClr val="FFFFFF">
+              <a:alpha val="0"/>
+            </a:srgbClr>
           </a:solidFill>
           <a:ln w="12700">
             <a:solidFill>
@@ -9673,48 +10628,7 @@
       </p:sp>
       <p:sp>
         <p:nvSpPr>
-          <p:cNvPr id="6" name="Text 4"/>
-          <p:cNvSpPr/>
-          <p:nvPr/>
-        </p:nvSpPr>
-        <p:spPr>
-          <a:xfrm>
-            <a:off x="1033272" y="1527048"/>
-            <a:ext cx="5157216" cy="3438144"/>
-          </a:xfrm>
-          <a:prstGeom prst="rect">
-            <a:avLst/>
-          </a:prstGeom>
-          <a:noFill/>
-          <a:ln/>
-        </p:spPr>
-        <p:txBody>
-          <a:bodyPr wrap="square" lIns="635" tIns="635" rIns="635" bIns="635" rtlCol="0" anchor="ctr">
-            <a:normAutofit/>
-          </a:bodyPr>
-          <a:lstStyle/>
-          <a:p>
-            <a:pPr algn="ctr" indent="0" marL="0">
-              <a:buNone/>
-            </a:pPr>
-            <a:r>
-              <a:rPr lang="en-US" sz="1600" i="1" dirty="0">
-                <a:solidFill>
-                  <a:srgbClr val="6B7280"/>
-                </a:solidFill>
-                <a:latin typeface="Arial" pitchFamily="34" charset="0"/>
-                <a:ea typeface="Arial" pitchFamily="34" charset="-122"/>
-                <a:cs typeface="Arial" pitchFamily="34" charset="-120"/>
-              </a:rPr>
-              <a:t>Insert Urban / Megalodon figure or workflow image</a:t>
-            </a:r>
-            <a:endParaRPr lang="en-US" sz="1600" dirty="0"/>
-          </a:p>
-        </p:txBody>
-      </p:sp>
-      <p:sp>
-        <p:nvSpPr>
-          <p:cNvPr id="7" name="Text 5"/>
+          <p:cNvPr id="7" name="Text 4"/>
           <p:cNvSpPr/>
           <p:nvPr/>
         </p:nvSpPr>
@@ -9784,6 +10698,45 @@
               <a:t>Strong models can now support a substantial formalization loop.</a:t>
             </a:r>
             <a:endParaRPr lang="en-US" sz="1800" dirty="0"/>
+          </a:p>
+        </p:txBody>
+      </p:sp>
+      <p:sp>
+        <p:nvSpPr>
+          <p:cNvPr id="8" name="Text 5"/>
+          <p:cNvSpPr/>
+          <p:nvPr/>
+        </p:nvSpPr>
+        <p:spPr>
+          <a:xfrm>
+            <a:off x="868680" y="5285232"/>
+            <a:ext cx="5669280" cy="219456"/>
+          </a:xfrm>
+          <a:prstGeom prst="rect">
+            <a:avLst/>
+          </a:prstGeom>
+          <a:noFill/>
+          <a:ln/>
+        </p:spPr>
+        <p:txBody>
+          <a:bodyPr wrap="square" lIns="0" tIns="0" rIns="0" bIns="0" rtlCol="0" anchor="ctr"/>
+          <a:lstStyle/>
+          <a:p>
+            <a:pPr indent="0" marL="0">
+              <a:buNone/>
+            </a:pPr>
+            <a:r>
+              <a:rPr lang="en-US" sz="1100" dirty="0">
+                <a:solidFill>
+                  <a:srgbClr val="6B7280"/>
+                </a:solidFill>
+                <a:latin typeface="Arial" pitchFamily="34" charset="0"/>
+                <a:ea typeface="Arial" pitchFamily="34" charset="-122"/>
+                <a:cs typeface="Arial" pitchFamily="34" charset="-120"/>
+              </a:rPr>
+              <a:t>Josef Urban, “130k Lines of Formal Topology in Two Weeks”</a:t>
+            </a:r>
+            <a:endParaRPr lang="en-US" sz="1100" dirty="0"/>
           </a:p>
         </p:txBody>
       </p:sp>
@@ -9920,22 +10873,47 @@
           </a:p>
         </p:txBody>
       </p:sp>
-      <p:sp>
-        <p:nvSpPr>
-          <p:cNvPr id="5" name="Shape 3"/>
-          <p:cNvSpPr/>
-          <p:nvPr/>
-        </p:nvSpPr>
+      <p:pic>
+        <p:nvPicPr>
+          <p:cNvPr id="5" name="Image 0" descr="/home/matt.linux/talks/2026/oregon/assets/raw-images/math-inc-sphere-packing-og.png">    </p:cNvPr>
+          <p:cNvPicPr>
+            <a:picLocks noChangeAspect="1"/>
+          </p:cNvPicPr>
+          <p:nvPr/>
+        </p:nvPicPr>
+        <p:blipFill>
+          <a:blip r:embed="rId1"/>
+          <a:srcRect l="0" r="0" t="0" b="0"/>
+          <a:stretch/>
+        </p:blipFill>
         <p:spPr>
           <a:xfrm>
             <a:off x="868680" y="1325880"/>
             <a:ext cx="5486400" cy="3840480"/>
           </a:xfrm>
-          <a:prstGeom prst="roundRect">
+          <a:prstGeom prst="rect">
+            <a:avLst/>
+          </a:prstGeom>
+        </p:spPr>
+      </p:pic>
+      <p:sp>
+        <p:nvSpPr>
+          <p:cNvPr id="6" name="Shape 3"/>
+          <p:cNvSpPr/>
+          <p:nvPr/>
+        </p:nvSpPr>
+        <p:spPr>
+          <a:xfrm>
+            <a:off x="868680" y="1325880"/>
+            <a:ext cx="5486400" cy="3840480"/>
+          </a:xfrm>
+          <a:prstGeom prst="rect">
             <a:avLst/>
           </a:prstGeom>
           <a:solidFill>
-            <a:srgbClr val="E7EEF2"/>
+            <a:srgbClr val="FFFFFF">
+              <a:alpha val="0"/>
+            </a:srgbClr>
           </a:solidFill>
           <a:ln w="12700">
             <a:solidFill>
@@ -9947,48 +10925,7 @@
       </p:sp>
       <p:sp>
         <p:nvSpPr>
-          <p:cNvPr id="6" name="Text 4"/>
-          <p:cNvSpPr/>
-          <p:nvPr/>
-        </p:nvSpPr>
-        <p:spPr>
-          <a:xfrm>
-            <a:off x="1033272" y="1527048"/>
-            <a:ext cx="5157216" cy="3438144"/>
-          </a:xfrm>
-          <a:prstGeom prst="rect">
-            <a:avLst/>
-          </a:prstGeom>
-          <a:noFill/>
-          <a:ln/>
-        </p:spPr>
-        <p:txBody>
-          <a:bodyPr wrap="square" lIns="635" tIns="635" rIns="635" bIns="635" rtlCol="0" anchor="ctr">
-            <a:normAutofit/>
-          </a:bodyPr>
-          <a:lstStyle/>
-          <a:p>
-            <a:pPr algn="ctr" indent="0" marL="0">
-              <a:buNone/>
-            </a:pPr>
-            <a:r>
-              <a:rPr lang="en-US" sz="1600" i="1" dirty="0">
-                <a:solidFill>
-                  <a:srgbClr val="6B7280"/>
-                </a:solidFill>
-                <a:latin typeface="Arial" pitchFamily="34" charset="0"/>
-                <a:ea typeface="Arial" pitchFamily="34" charset="-122"/>
-                <a:cs typeface="Arial" pitchFamily="34" charset="-120"/>
-              </a:rPr>
-              <a:t>Insert Gauss / sphere-packing formalization image</a:t>
-            </a:r>
-            <a:endParaRPr lang="en-US" sz="1600" dirty="0"/>
-          </a:p>
-        </p:txBody>
-      </p:sp>
-      <p:sp>
-        <p:nvSpPr>
-          <p:cNvPr id="7" name="Text 5"/>
+          <p:cNvPr id="7" name="Text 4"/>
           <p:cNvSpPr/>
           <p:nvPr/>
         </p:nvSpPr>
@@ -10058,6 +10995,45 @@
               <a:t>They make the promise of autoformalization more concrete.</a:t>
             </a:r>
             <a:endParaRPr lang="en-US" sz="1800" dirty="0"/>
+          </a:p>
+        </p:txBody>
+      </p:sp>
+      <p:sp>
+        <p:nvSpPr>
+          <p:cNvPr id="8" name="Text 5"/>
+          <p:cNvSpPr/>
+          <p:nvPr/>
+        </p:nvSpPr>
+        <p:spPr>
+          <a:xfrm>
+            <a:off x="868680" y="5285232"/>
+            <a:ext cx="5943600" cy="219456"/>
+          </a:xfrm>
+          <a:prstGeom prst="rect">
+            <a:avLst/>
+          </a:prstGeom>
+          <a:noFill/>
+          <a:ln/>
+        </p:spPr>
+        <p:txBody>
+          <a:bodyPr wrap="square" lIns="0" tIns="0" rIns="0" bIns="0" rtlCol="0" anchor="ctr"/>
+          <a:lstStyle/>
+          <a:p>
+            <a:pPr indent="0" marL="0">
+              <a:buNone/>
+            </a:pPr>
+            <a:r>
+              <a:rPr lang="en-US" sz="1100" dirty="0">
+                <a:solidFill>
+                  <a:srgbClr val="6B7280"/>
+                </a:solidFill>
+                <a:latin typeface="Arial" pitchFamily="34" charset="0"/>
+                <a:ea typeface="Arial" pitchFamily="34" charset="-122"/>
+                <a:cs typeface="Arial" pitchFamily="34" charset="-120"/>
+              </a:rPr>
+              <a:t>Math, Inc.: formal verification of sphere packing in dimensions 8 and 24</a:t>
+            </a:r>
+            <a:endParaRPr lang="en-US" sz="1100" dirty="0"/>
           </a:p>
         </p:txBody>
       </p:sp>
@@ -10194,20 +11170,120 @@
           </a:p>
         </p:txBody>
       </p:sp>
-      <p:sp>
-        <p:nvSpPr>
-          <p:cNvPr id="5" name="Shape 3"/>
-          <p:cNvSpPr/>
-          <p:nvPr/>
-        </p:nvSpPr>
-        <p:spPr>
-          <a:xfrm>
-            <a:off x="868680" y="1600200"/>
-            <a:ext cx="3337560" cy="2011680"/>
+      <p:pic>
+        <p:nvPicPr>
+          <p:cNvPr id="5" name="Image 0" descr="/home/matt.linux/talks/2026/oregon/assets/raw-images/m2f-fig1-02.png">    </p:cNvPr>
+          <p:cNvPicPr>
+            <a:picLocks noChangeAspect="1"/>
+          </p:cNvPicPr>
+          <p:nvPr/>
+        </p:nvPicPr>
+        <p:blipFill>
+          <a:blip r:embed="rId1"/>
+          <a:srcRect l="0" r="0" t="0" b="0"/>
+          <a:stretch/>
+        </p:blipFill>
+        <p:spPr>
+          <a:xfrm>
+            <a:off x="868680" y="1508760"/>
+            <a:ext cx="3474720" cy="2286000"/>
+          </a:xfrm>
+          <a:prstGeom prst="rect">
+            <a:avLst/>
+          </a:prstGeom>
+        </p:spPr>
+      </p:pic>
+      <p:sp>
+        <p:nvSpPr>
+          <p:cNvPr id="6" name="Shape 3"/>
+          <p:cNvSpPr/>
+          <p:nvPr/>
+        </p:nvSpPr>
+        <p:spPr>
+          <a:xfrm>
+            <a:off x="868680" y="1508760"/>
+            <a:ext cx="3474720" cy="2286000"/>
+          </a:xfrm>
+          <a:prstGeom prst="rect">
+            <a:avLst/>
+          </a:prstGeom>
+          <a:solidFill>
+            <a:srgbClr val="FFFFFF">
+              <a:alpha val="0"/>
+            </a:srgbClr>
+          </a:solidFill>
+          <a:ln w="12700">
+            <a:solidFill>
+              <a:srgbClr val="C8C4B7"/>
+            </a:solidFill>
+            <a:prstDash val="solid"/>
+          </a:ln>
+        </p:spPr>
+      </p:sp>
+      <p:pic>
+        <p:nvPicPr>
+          <p:cNvPr id="7" name="Image 1" descr="/home/matt.linux/talks/2026/oregon/assets/raw-images/archon-firstproof-og.jpg">    </p:cNvPr>
+          <p:cNvPicPr>
+            <a:picLocks noChangeAspect="1"/>
+          </p:cNvPicPr>
+          <p:nvPr/>
+        </p:nvPicPr>
+        <p:blipFill>
+          <a:blip r:embed="rId2"/>
+          <a:srcRect l="0" r="0" t="0" b="0"/>
+          <a:stretch/>
+        </p:blipFill>
+        <p:spPr>
+          <a:xfrm>
+            <a:off x="4553712" y="1508760"/>
+            <a:ext cx="3474720" cy="2286000"/>
+          </a:xfrm>
+          <a:prstGeom prst="rect">
+            <a:avLst/>
+          </a:prstGeom>
+        </p:spPr>
+      </p:pic>
+      <p:sp>
+        <p:nvSpPr>
+          <p:cNvPr id="8" name="Shape 4"/>
+          <p:cNvSpPr/>
+          <p:nvPr/>
+        </p:nvSpPr>
+        <p:spPr>
+          <a:xfrm>
+            <a:off x="4553712" y="1508760"/>
+            <a:ext cx="3474720" cy="2286000"/>
+          </a:xfrm>
+          <a:prstGeom prst="rect">
+            <a:avLst/>
+          </a:prstGeom>
+          <a:solidFill>
+            <a:srgbClr val="FFFFFF">
+              <a:alpha val="0"/>
+            </a:srgbClr>
+          </a:solidFill>
+          <a:ln w="12700">
+            <a:solidFill>
+              <a:srgbClr val="C8C4B7"/>
+            </a:solidFill>
+            <a:prstDash val="solid"/>
+          </a:ln>
+        </p:spPr>
+      </p:sp>
+      <p:sp>
+        <p:nvSpPr>
+          <p:cNvPr id="9" name="Shape 5"/>
+          <p:cNvSpPr/>
+          <p:nvPr/>
+        </p:nvSpPr>
+        <p:spPr>
+          <a:xfrm>
+            <a:off x="8247888" y="1508760"/>
+            <a:ext cx="2697480" cy="2286000"/>
           </a:xfrm>
           <a:prstGeom prst="roundRect">
             <a:avLst>
-              <a:gd name="adj" fmla="val 3636"/>
+              <a:gd name="adj" fmla="val 3200"/>
             </a:avLst>
           </a:prstGeom>
           <a:solidFill>
@@ -10223,14 +11299,14 @@
       </p:sp>
       <p:sp>
         <p:nvSpPr>
-          <p:cNvPr id="6" name="Text 4"/>
-          <p:cNvSpPr/>
-          <p:nvPr/>
-        </p:nvSpPr>
-        <p:spPr>
-          <a:xfrm>
-            <a:off x="1033272" y="1728216"/>
-            <a:ext cx="3008376" cy="237744"/>
+          <p:cNvPr id="10" name="Text 6"/>
+          <p:cNvSpPr/>
+          <p:nvPr/>
+        </p:nvSpPr>
+        <p:spPr>
+          <a:xfrm>
+            <a:off x="8412480" y="1636776"/>
+            <a:ext cx="2368296" cy="237744"/>
           </a:xfrm>
           <a:prstGeom prst="rect">
             <a:avLst/>
@@ -10254,7 +11330,7 @@
                 <a:ea typeface="Georgia" pitchFamily="34" charset="-122"/>
                 <a:cs typeface="Georgia" pitchFamily="34" charset="-120"/>
               </a:rPr>
-              <a:t>Recent autoformalization paper</a:t>
+              <a:t>The broader point</a:t>
             </a:r>
             <a:endParaRPr lang="en-US" sz="1600" dirty="0"/>
           </a:p>
@@ -10262,14 +11338,14 @@
       </p:sp>
       <p:sp>
         <p:nvSpPr>
-          <p:cNvPr id="7" name="Text 5"/>
-          <p:cNvSpPr/>
-          <p:nvPr/>
-        </p:nvSpPr>
-        <p:spPr>
-          <a:xfrm>
-            <a:off x="1033272" y="2039112"/>
-            <a:ext cx="3008376" cy="1481328"/>
+          <p:cNvPr id="11" name="Text 7"/>
+          <p:cNvSpPr/>
+          <p:nvPr/>
+        </p:nvSpPr>
+        <p:spPr>
+          <a:xfrm>
+            <a:off x="8412480" y="1947672"/>
+            <a:ext cx="2368296" cy="1755648"/>
           </a:xfrm>
           <a:prstGeom prst="rect">
             <a:avLst/>
@@ -10295,100 +11371,10 @@
                 <a:ea typeface="Arial" pitchFamily="34" charset="-122"/>
                 <a:cs typeface="Arial" pitchFamily="34" charset="-120"/>
               </a:rPr>
-              <a:t>Insert small figure or screenshot and one short caption.</a:t>
+              <a:t>The landscape is no longer one isolated demo.</a:t>
             </a:r>
             <a:endParaRPr lang="en-US" sz="1700" dirty="0"/>
           </a:p>
-        </p:txBody>
-      </p:sp>
-      <p:sp>
-        <p:nvSpPr>
-          <p:cNvPr id="8" name="Shape 6"/>
-          <p:cNvSpPr/>
-          <p:nvPr/>
-        </p:nvSpPr>
-        <p:spPr>
-          <a:xfrm>
-            <a:off x="4425696" y="1600200"/>
-            <a:ext cx="3337560" cy="2011680"/>
-          </a:xfrm>
-          <a:prstGeom prst="roundRect">
-            <a:avLst>
-              <a:gd name="adj" fmla="val 3636"/>
-            </a:avLst>
-          </a:prstGeom>
-          <a:solidFill>
-            <a:srgbClr val="E7EEF2"/>
-          </a:solidFill>
-          <a:ln w="12700">
-            <a:solidFill>
-              <a:srgbClr val="C8C4B7"/>
-            </a:solidFill>
-            <a:prstDash val="solid"/>
-          </a:ln>
-        </p:spPr>
-      </p:sp>
-      <p:sp>
-        <p:nvSpPr>
-          <p:cNvPr id="9" name="Text 7"/>
-          <p:cNvSpPr/>
-          <p:nvPr/>
-        </p:nvSpPr>
-        <p:spPr>
-          <a:xfrm>
-            <a:off x="4590288" y="1728216"/>
-            <a:ext cx="3008376" cy="237744"/>
-          </a:xfrm>
-          <a:prstGeom prst="rect">
-            <a:avLst/>
-          </a:prstGeom>
-          <a:noFill/>
-          <a:ln/>
-        </p:spPr>
-        <p:txBody>
-          <a:bodyPr wrap="square" lIns="0" tIns="0" rIns="0" bIns="0" rtlCol="0" anchor="ctr"/>
-          <a:lstStyle/>
-          <a:p>
-            <a:pPr indent="0" marL="0">
-              <a:buNone/>
-            </a:pPr>
-            <a:r>
-              <a:rPr lang="en-US" sz="1600" dirty="0">
-                <a:solidFill>
-                  <a:srgbClr val="3F5C6E"/>
-                </a:solidFill>
-                <a:latin typeface="Georgia" pitchFamily="34" charset="0"/>
-                <a:ea typeface="Georgia" pitchFamily="34" charset="-122"/>
-                <a:cs typeface="Georgia" pitchFamily="34" charset="-120"/>
-              </a:rPr>
-              <a:t>Archon / First Proof</a:t>
-            </a:r>
-            <a:endParaRPr lang="en-US" sz="1600" dirty="0"/>
-          </a:p>
-        </p:txBody>
-      </p:sp>
-      <p:sp>
-        <p:nvSpPr>
-          <p:cNvPr id="10" name="Text 8"/>
-          <p:cNvSpPr/>
-          <p:nvPr/>
-        </p:nvSpPr>
-        <p:spPr>
-          <a:xfrm>
-            <a:off x="4590288" y="2039112"/>
-            <a:ext cx="3008376" cy="1481328"/>
-          </a:xfrm>
-          <a:prstGeom prst="rect">
-            <a:avLst/>
-          </a:prstGeom>
-          <a:noFill/>
-          <a:ln/>
-        </p:spPr>
-        <p:txBody>
-          <a:bodyPr wrap="square" lIns="381" tIns="381" rIns="381" bIns="381" rtlCol="0" anchor="t">
-            <a:normAutofit/>
-          </a:bodyPr>
-          <a:lstStyle/>
           <a:p>
             <a:pPr indent="0" marL="0">
               <a:buNone/>
@@ -10402,7 +11388,7 @@
                 <a:ea typeface="Arial" pitchFamily="34" charset="-122"/>
                 <a:cs typeface="Arial" pitchFamily="34" charset="-120"/>
               </a:rPr>
-              <a:t>Insert small figure or screenshot and one short caption.</a:t>
+              <a:t>There are now several overlapping styles of verifier-in-the-loop formalization work.</a:t>
             </a:r>
             <a:endParaRPr lang="en-US" sz="1700" dirty="0"/>
           </a:p>
@@ -10410,114 +11396,7 @@
       </p:sp>
       <p:sp>
         <p:nvSpPr>
-          <p:cNvPr id="11" name="Shape 9"/>
-          <p:cNvSpPr/>
-          <p:nvPr/>
-        </p:nvSpPr>
-        <p:spPr>
-          <a:xfrm>
-            <a:off x="7982712" y="1600200"/>
-            <a:ext cx="2743200" cy="2011680"/>
-          </a:xfrm>
-          <a:prstGeom prst="roundRect">
-            <a:avLst>
-              <a:gd name="adj" fmla="val 3636"/>
-            </a:avLst>
-          </a:prstGeom>
-          <a:solidFill>
-            <a:srgbClr val="ECE7DC"/>
-          </a:solidFill>
-          <a:ln w="12700">
-            <a:solidFill>
-              <a:srgbClr val="C8C4B7"/>
-            </a:solidFill>
-            <a:prstDash val="solid"/>
-          </a:ln>
-        </p:spPr>
-      </p:sp>
-      <p:sp>
-        <p:nvSpPr>
-          <p:cNvPr id="12" name="Text 10"/>
-          <p:cNvSpPr/>
-          <p:nvPr/>
-        </p:nvSpPr>
-        <p:spPr>
-          <a:xfrm>
-            <a:off x="8147304" y="1728216"/>
-            <a:ext cx="2414016" cy="237744"/>
-          </a:xfrm>
-          <a:prstGeom prst="rect">
-            <a:avLst/>
-          </a:prstGeom>
-          <a:noFill/>
-          <a:ln/>
-        </p:spPr>
-        <p:txBody>
-          <a:bodyPr wrap="square" lIns="0" tIns="0" rIns="0" bIns="0" rtlCol="0" anchor="ctr"/>
-          <a:lstStyle/>
-          <a:p>
-            <a:pPr indent="0" marL="0">
-              <a:buNone/>
-            </a:pPr>
-            <a:r>
-              <a:rPr lang="en-US" sz="1600" dirty="0">
-                <a:solidFill>
-                  <a:srgbClr val="3F5C6E"/>
-                </a:solidFill>
-                <a:latin typeface="Georgia" pitchFamily="34" charset="0"/>
-                <a:ea typeface="Georgia" pitchFamily="34" charset="-122"/>
-                <a:cs typeface="Georgia" pitchFamily="34" charset="-120"/>
-              </a:rPr>
-              <a:t>Another 2026 example</a:t>
-            </a:r>
-            <a:endParaRPr lang="en-US" sz="1600" dirty="0"/>
-          </a:p>
-        </p:txBody>
-      </p:sp>
-      <p:sp>
-        <p:nvSpPr>
-          <p:cNvPr id="13" name="Text 11"/>
-          <p:cNvSpPr/>
-          <p:nvPr/>
-        </p:nvSpPr>
-        <p:spPr>
-          <a:xfrm>
-            <a:off x="8147304" y="2039112"/>
-            <a:ext cx="2414016" cy="1481328"/>
-          </a:xfrm>
-          <a:prstGeom prst="rect">
-            <a:avLst/>
-          </a:prstGeom>
-          <a:noFill/>
-          <a:ln/>
-        </p:spPr>
-        <p:txBody>
-          <a:bodyPr wrap="square" lIns="381" tIns="381" rIns="381" bIns="381" rtlCol="0" anchor="t">
-            <a:normAutofit/>
-          </a:bodyPr>
-          <a:lstStyle/>
-          <a:p>
-            <a:pPr indent="0" marL="0">
-              <a:buNone/>
-            </a:pPr>
-            <a:r>
-              <a:rPr lang="en-US" sz="1700" dirty="0">
-                <a:solidFill>
-                  <a:srgbClr val="1D232B"/>
-                </a:solidFill>
-                <a:latin typeface="Arial" pitchFamily="34" charset="0"/>
-                <a:ea typeface="Arial" pitchFamily="34" charset="-122"/>
-                <a:cs typeface="Arial" pitchFamily="34" charset="-120"/>
-              </a:rPr>
-              <a:t>Reserve space if a third small panel is useful.</a:t>
-            </a:r>
-            <a:endParaRPr lang="en-US" sz="1700" dirty="0"/>
-          </a:p>
-        </p:txBody>
-      </p:sp>
-      <p:sp>
-        <p:nvSpPr>
-          <p:cNvPr id="14" name="Text 12"/>
+          <p:cNvPr id="12" name="Text 8"/>
           <p:cNvSpPr/>
           <p:nvPr/>
         </p:nvSpPr>
@@ -10714,11 +11593,13 @@
         </p:nvSpPr>
         <p:spPr>
           <a:xfrm>
-            <a:off x="868680" y="1325880"/>
-            <a:ext cx="5212080" cy="3794760"/>
+            <a:off x="868680" y="1417320"/>
+            <a:ext cx="4983480" cy="1417320"/>
           </a:xfrm>
           <a:prstGeom prst="roundRect">
-            <a:avLst/>
+            <a:avLst>
+              <a:gd name="adj" fmla="val 5161"/>
+            </a:avLst>
           </a:prstGeom>
           <a:solidFill>
             <a:srgbClr val="E7EEF2"/>
@@ -10739,42 +11620,81 @@
         </p:nvSpPr>
         <p:spPr>
           <a:xfrm>
-            <a:off x="1033272" y="1527048"/>
-            <a:ext cx="4882896" cy="3392424"/>
-          </a:xfrm>
-          <a:prstGeom prst="rect">
-            <a:avLst/>
-          </a:prstGeom>
-          <a:noFill/>
-          <a:ln/>
-        </p:spPr>
-        <p:txBody>
-          <a:bodyPr wrap="square" lIns="635" tIns="635" rIns="635" bIns="635" rtlCol="0" anchor="ctr">
+            <a:off x="1033272" y="1545336"/>
+            <a:ext cx="4654296" cy="237744"/>
+          </a:xfrm>
+          <a:prstGeom prst="rect">
+            <a:avLst/>
+          </a:prstGeom>
+          <a:noFill/>
+          <a:ln/>
+        </p:spPr>
+        <p:txBody>
+          <a:bodyPr wrap="square" lIns="0" tIns="0" rIns="0" bIns="0" rtlCol="0" anchor="ctr"/>
+          <a:lstStyle/>
+          <a:p>
+            <a:pPr indent="0" marL="0">
+              <a:buNone/>
+            </a:pPr>
+            <a:r>
+              <a:rPr lang="en-US" sz="1600" dirty="0">
+                <a:solidFill>
+                  <a:srgbClr val="3F5C6E"/>
+                </a:solidFill>
+                <a:latin typeface="Georgia" pitchFamily="34" charset="0"/>
+                <a:ea typeface="Georgia" pitchFamily="34" charset="-122"/>
+                <a:cs typeface="Georgia" pitchFamily="34" charset="-120"/>
+              </a:rPr>
+              <a:t>What changed</a:t>
+            </a:r>
+            <a:endParaRPr lang="en-US" sz="1600" dirty="0"/>
+          </a:p>
+        </p:txBody>
+      </p:sp>
+      <p:sp>
+        <p:nvSpPr>
+          <p:cNvPr id="7" name="Text 5"/>
+          <p:cNvSpPr/>
+          <p:nvPr/>
+        </p:nvSpPr>
+        <p:spPr>
+          <a:xfrm>
+            <a:off x="1033272" y="1856232"/>
+            <a:ext cx="4654296" cy="886968"/>
+          </a:xfrm>
+          <a:prstGeom prst="rect">
+            <a:avLst/>
+          </a:prstGeom>
+          <a:noFill/>
+          <a:ln/>
+        </p:spPr>
+        <p:txBody>
+          <a:bodyPr wrap="square" lIns="381" tIns="381" rIns="381" bIns="381" rtlCol="0" anchor="t">
             <a:normAutofit/>
           </a:bodyPr>
           <a:lstStyle/>
           <a:p>
-            <a:pPr algn="ctr" indent="0" marL="0">
-              <a:buNone/>
-            </a:pPr>
-            <a:r>
-              <a:rPr lang="en-US" sz="1600" i="1" dirty="0">
-                <a:solidFill>
-                  <a:srgbClr val="6B7280"/>
-                </a:solidFill>
-                <a:latin typeface="Arial" pitchFamily="34" charset="0"/>
-                <a:ea typeface="Arial" pitchFamily="34" charset="-122"/>
-                <a:cs typeface="Arial" pitchFamily="34" charset="-120"/>
-              </a:rPr>
-              <a:t>Insert representative Claude Code screenshots or a simpler custom diagram</a:t>
-            </a:r>
-            <a:endParaRPr lang="en-US" sz="1600" dirty="0"/>
-          </a:p>
-        </p:txBody>
-      </p:sp>
-      <p:sp>
-        <p:nvSpPr>
-          <p:cNvPr id="7" name="Shape 5"/>
+            <a:pPr indent="0" marL="0">
+              <a:buNone/>
+            </a:pPr>
+            <a:r>
+              <a:rPr lang="en-US" sz="1700" dirty="0">
+                <a:solidFill>
+                  <a:srgbClr val="1D232B"/>
+                </a:solidFill>
+                <a:latin typeface="Arial" pitchFamily="34" charset="0"/>
+                <a:ea typeface="Arial" pitchFamily="34" charset="-122"/>
+                <a:cs typeface="Arial" pitchFamily="34" charset="-120"/>
+              </a:rPr>
+              <a:t>Off-the-shelf coding agents became good enough to sustain a real edit / run / repair loop.</a:t>
+            </a:r>
+            <a:endParaRPr lang="en-US" sz="1700" dirty="0"/>
+          </a:p>
+        </p:txBody>
+      </p:sp>
+      <p:sp>
+        <p:nvSpPr>
+          <p:cNvPr id="8" name="Shape 6"/>
           <p:cNvSpPr/>
           <p:nvPr/>
         </p:nvSpPr>
@@ -10801,7 +11721,7 @@
       </p:sp>
       <p:sp>
         <p:nvSpPr>
-          <p:cNvPr id="8" name="Text 6"/>
+          <p:cNvPr id="9" name="Text 7"/>
           <p:cNvSpPr/>
           <p:nvPr/>
         </p:nvSpPr>
@@ -10840,7 +11760,7 @@
       </p:sp>
       <p:sp>
         <p:nvSpPr>
-          <p:cNvPr id="9" name="Text 7"/>
+          <p:cNvPr id="10" name="Text 8"/>
           <p:cNvSpPr/>
           <p:nvPr/>
         </p:nvSpPr>
@@ -10898,13 +11818,13 @@
       </p:sp>
       <p:sp>
         <p:nvSpPr>
-          <p:cNvPr id="10" name="Shape 8"/>
-          <p:cNvSpPr/>
-          <p:nvPr/>
-        </p:nvSpPr>
-        <p:spPr>
-          <a:xfrm>
-            <a:off x="868680" y="4251960"/>
+          <p:cNvPr id="11" name="Shape 9"/>
+          <p:cNvSpPr/>
+          <p:nvPr/>
+        </p:nvSpPr>
+        <p:spPr>
+          <a:xfrm>
+            <a:off x="868680" y="3931920"/>
             <a:ext cx="1965960" cy="804672"/>
           </a:xfrm>
           <a:prstGeom prst="roundRect">
@@ -10925,13 +11845,13 @@
       </p:sp>
       <p:sp>
         <p:nvSpPr>
-          <p:cNvPr id="11" name="Text 9"/>
-          <p:cNvSpPr/>
-          <p:nvPr/>
-        </p:nvSpPr>
-        <p:spPr>
-          <a:xfrm>
-            <a:off x="978408" y="4416552"/>
+          <p:cNvPr id="12" name="Text 10"/>
+          <p:cNvSpPr/>
+          <p:nvPr/>
+        </p:nvSpPr>
+        <p:spPr>
+          <a:xfrm>
+            <a:off x="978408" y="4096512"/>
             <a:ext cx="1746504" cy="411480"/>
           </a:xfrm>
           <a:prstGeom prst="rect">
@@ -10966,13 +11886,13 @@
       </p:sp>
       <p:sp>
         <p:nvSpPr>
-          <p:cNvPr id="12" name="Text 10"/>
-          <p:cNvSpPr/>
-          <p:nvPr/>
-        </p:nvSpPr>
-        <p:spPr>
-          <a:xfrm>
-            <a:off x="2907792" y="4462272"/>
+          <p:cNvPr id="13" name="Text 11"/>
+          <p:cNvSpPr/>
+          <p:nvPr/>
+        </p:nvSpPr>
+        <p:spPr>
+          <a:xfrm>
+            <a:off x="2907792" y="4142232"/>
             <a:ext cx="256032" cy="201168"/>
           </a:xfrm>
           <a:prstGeom prst="rect">
@@ -11005,13 +11925,13 @@
       </p:sp>
       <p:sp>
         <p:nvSpPr>
-          <p:cNvPr id="13" name="Shape 11"/>
-          <p:cNvSpPr/>
-          <p:nvPr/>
-        </p:nvSpPr>
-        <p:spPr>
-          <a:xfrm>
-            <a:off x="3246120" y="4251960"/>
+          <p:cNvPr id="14" name="Shape 12"/>
+          <p:cNvSpPr/>
+          <p:nvPr/>
+        </p:nvSpPr>
+        <p:spPr>
+          <a:xfrm>
+            <a:off x="3246120" y="3931920"/>
             <a:ext cx="1965960" cy="804672"/>
           </a:xfrm>
           <a:prstGeom prst="roundRect">
@@ -11032,13 +11952,13 @@
       </p:sp>
       <p:sp>
         <p:nvSpPr>
-          <p:cNvPr id="14" name="Text 12"/>
-          <p:cNvSpPr/>
-          <p:nvPr/>
-        </p:nvSpPr>
-        <p:spPr>
-          <a:xfrm>
-            <a:off x="3355848" y="4416552"/>
+          <p:cNvPr id="15" name="Text 13"/>
+          <p:cNvSpPr/>
+          <p:nvPr/>
+        </p:nvSpPr>
+        <p:spPr>
+          <a:xfrm>
+            <a:off x="3355848" y="4096512"/>
             <a:ext cx="1746504" cy="411480"/>
           </a:xfrm>
           <a:prstGeom prst="rect">
@@ -11065,7 +11985,7 @@
                 <a:ea typeface="Arial" pitchFamily="34" charset="-122"/>
                 <a:cs typeface="Arial" pitchFamily="34" charset="-120"/>
               </a:rPr>
-              <a:t>coding loop</a:t>
+              <a:t>edit / run loop</a:t>
             </a:r>
             <a:endParaRPr lang="en-US" sz="1600" dirty="0"/>
           </a:p>
@@ -11073,13 +11993,13 @@
       </p:sp>
       <p:sp>
         <p:nvSpPr>
-          <p:cNvPr id="15" name="Text 13"/>
-          <p:cNvSpPr/>
-          <p:nvPr/>
-        </p:nvSpPr>
-        <p:spPr>
-          <a:xfrm>
-            <a:off x="5285232" y="4462272"/>
+          <p:cNvPr id="16" name="Text 14"/>
+          <p:cNvSpPr/>
+          <p:nvPr/>
+        </p:nvSpPr>
+        <p:spPr>
+          <a:xfrm>
+            <a:off x="5285232" y="4142232"/>
             <a:ext cx="256032" cy="201168"/>
           </a:xfrm>
           <a:prstGeom prst="rect">
@@ -11112,13 +12032,13 @@
       </p:sp>
       <p:sp>
         <p:nvSpPr>
-          <p:cNvPr id="16" name="Shape 14"/>
-          <p:cNvSpPr/>
-          <p:nvPr/>
-        </p:nvSpPr>
-        <p:spPr>
-          <a:xfrm>
-            <a:off x="5623560" y="4251960"/>
+          <p:cNvPr id="17" name="Shape 15"/>
+          <p:cNvSpPr/>
+          <p:nvPr/>
+        </p:nvSpPr>
+        <p:spPr>
+          <a:xfrm>
+            <a:off x="5623560" y="3931920"/>
             <a:ext cx="1965960" cy="804672"/>
           </a:xfrm>
           <a:prstGeom prst="roundRect">
@@ -11139,13 +12059,13 @@
       </p:sp>
       <p:sp>
         <p:nvSpPr>
-          <p:cNvPr id="17" name="Text 15"/>
-          <p:cNvSpPr/>
-          <p:nvPr/>
-        </p:nvSpPr>
-        <p:spPr>
-          <a:xfrm>
-            <a:off x="5733288" y="4416552"/>
+          <p:cNvPr id="18" name="Text 16"/>
+          <p:cNvSpPr/>
+          <p:nvPr/>
+        </p:nvSpPr>
+        <p:spPr>
+          <a:xfrm>
+            <a:off x="5733288" y="4096512"/>
             <a:ext cx="1746504" cy="411480"/>
           </a:xfrm>
           <a:prstGeom prst="rect">
@@ -11175,6 +12095,154 @@
               <a:t>Lean feedback</a:t>
             </a:r>
             <a:endParaRPr lang="en-US" sz="1600" dirty="0"/>
+          </a:p>
+        </p:txBody>
+      </p:sp>
+      <p:sp>
+        <p:nvSpPr>
+          <p:cNvPr id="19" name="Text 17"/>
+          <p:cNvSpPr/>
+          <p:nvPr/>
+        </p:nvSpPr>
+        <p:spPr>
+          <a:xfrm>
+            <a:off x="7662672" y="4142232"/>
+            <a:ext cx="256032" cy="201168"/>
+          </a:xfrm>
+          <a:prstGeom prst="rect">
+            <a:avLst/>
+          </a:prstGeom>
+          <a:noFill/>
+          <a:ln/>
+        </p:spPr>
+        <p:txBody>
+          <a:bodyPr wrap="square" lIns="0" tIns="0" rIns="0" bIns="0" rtlCol="0" anchor="ctr"/>
+          <a:lstStyle/>
+          <a:p>
+            <a:pPr algn="ctr" indent="0" marL="0">
+              <a:buNone/>
+            </a:pPr>
+            <a:r>
+              <a:rPr lang="en-US" sz="2200" dirty="0">
+                <a:solidFill>
+                  <a:srgbClr val="3F5C6E"/>
+                </a:solidFill>
+                <a:latin typeface="Arial" pitchFamily="34" charset="0"/>
+                <a:ea typeface="Arial" pitchFamily="34" charset="-122"/>
+                <a:cs typeface="Arial" pitchFamily="34" charset="-120"/>
+              </a:rPr>
+              <a:t>→</a:t>
+            </a:r>
+            <a:endParaRPr lang="en-US" sz="2200" dirty="0"/>
+          </a:p>
+        </p:txBody>
+      </p:sp>
+      <p:sp>
+        <p:nvSpPr>
+          <p:cNvPr id="20" name="Shape 18"/>
+          <p:cNvSpPr/>
+          <p:nvPr/>
+        </p:nvSpPr>
+        <p:spPr>
+          <a:xfrm>
+            <a:off x="8001000" y="3931920"/>
+            <a:ext cx="1965960" cy="804672"/>
+          </a:xfrm>
+          <a:prstGeom prst="roundRect">
+            <a:avLst>
+              <a:gd name="adj" fmla="val 9091"/>
+            </a:avLst>
+          </a:prstGeom>
+          <a:solidFill>
+            <a:srgbClr val="E7EEF2"/>
+          </a:solidFill>
+          <a:ln w="12700">
+            <a:solidFill>
+              <a:srgbClr val="C8C4B7"/>
+            </a:solidFill>
+            <a:prstDash val="solid"/>
+          </a:ln>
+        </p:spPr>
+      </p:sp>
+      <p:sp>
+        <p:nvSpPr>
+          <p:cNvPr id="21" name="Text 19"/>
+          <p:cNvSpPr/>
+          <p:nvPr/>
+        </p:nvSpPr>
+        <p:spPr>
+          <a:xfrm>
+            <a:off x="8110728" y="4096512"/>
+            <a:ext cx="1746504" cy="411480"/>
+          </a:xfrm>
+          <a:prstGeom prst="rect">
+            <a:avLst/>
+          </a:prstGeom>
+          <a:noFill/>
+          <a:ln/>
+        </p:spPr>
+        <p:txBody>
+          <a:bodyPr wrap="square" lIns="0" tIns="0" rIns="0" bIns="0" rtlCol="0" anchor="ctr">
+            <a:normAutofit/>
+          </a:bodyPr>
+          <a:lstStyle/>
+          <a:p>
+            <a:pPr algn="ctr" indent="0" marL="0">
+              <a:buNone/>
+            </a:pPr>
+            <a:r>
+              <a:rPr lang="en-US" sz="1600" dirty="0">
+                <a:solidFill>
+                  <a:srgbClr val="1D232B"/>
+                </a:solidFill>
+                <a:latin typeface="Arial" pitchFamily="34" charset="0"/>
+                <a:ea typeface="Arial" pitchFamily="34" charset="-122"/>
+                <a:cs typeface="Arial" pitchFamily="34" charset="-120"/>
+              </a:rPr>
+              <a:t>local repair</a:t>
+            </a:r>
+            <a:endParaRPr lang="en-US" sz="1600" dirty="0"/>
+          </a:p>
+        </p:txBody>
+      </p:sp>
+      <p:sp>
+        <p:nvSpPr>
+          <p:cNvPr id="22" name="Text 20"/>
+          <p:cNvSpPr/>
+          <p:nvPr/>
+        </p:nvSpPr>
+        <p:spPr>
+          <a:xfrm>
+            <a:off x="960120" y="3246120"/>
+            <a:ext cx="5303520" cy="685800"/>
+          </a:xfrm>
+          <a:prstGeom prst="rect">
+            <a:avLst/>
+          </a:prstGeom>
+          <a:noFill/>
+          <a:ln/>
+        </p:spPr>
+        <p:txBody>
+          <a:bodyPr wrap="square" lIns="381" tIns="381" rIns="381" bIns="381" rtlCol="0" anchor="t">
+            <a:normAutofit/>
+          </a:bodyPr>
+          <a:lstStyle/>
+          <a:p>
+            <a:pPr indent="0" marL="0">
+              <a:buNone/>
+            </a:pPr>
+            <a:r>
+              <a:rPr lang="en-US" sz="1700" i="1" dirty="0">
+                <a:solidFill>
+                  <a:srgbClr val="1D232B"/>
+                </a:solidFill>
+                <a:latin typeface="Arial" pitchFamily="34" charset="0"/>
+                <a:ea typeface="Arial" pitchFamily="34" charset="-122"/>
+                <a:cs typeface="Arial" pitchFamily="34" charset="-120"/>
+              </a:rPr>
+              <a:t>This is why Urban-style experiments suddenly became plausible for ordinary users.</a:t>
+            </a:r>
+            <a:endParaRPr lang="en-US" sz="1700" dirty="0"/>
           </a:p>
         </p:txBody>
       </p:sp>
@@ -12963,22 +14031,47 @@
           </a:ln>
         </p:spPr>
       </p:sp>
-      <p:sp>
-        <p:nvSpPr>
-          <p:cNvPr id="7" name="Shape 4"/>
-          <p:cNvSpPr/>
-          <p:nvPr/>
-        </p:nvSpPr>
+      <p:pic>
+        <p:nvPicPr>
+          <p:cNvPr id="7" name="Image 1" descr="/home/matt.linux/talks/2026/oregon/assets/raw-images/frontiermath-banner.png">    </p:cNvPr>
+          <p:cNvPicPr>
+            <a:picLocks noChangeAspect="1"/>
+          </p:cNvPicPr>
+          <p:nvPr/>
+        </p:nvPicPr>
+        <p:blipFill>
+          <a:blip r:embed="rId2"/>
+          <a:srcRect l="0" r="0" t="0" b="0"/>
+          <a:stretch/>
+        </p:blipFill>
         <p:spPr>
           <a:xfrm>
             <a:off x="5760720" y="1417320"/>
             <a:ext cx="4800600" cy="3154680"/>
           </a:xfrm>
-          <a:prstGeom prst="roundRect">
+          <a:prstGeom prst="rect">
+            <a:avLst/>
+          </a:prstGeom>
+        </p:spPr>
+      </p:pic>
+      <p:sp>
+        <p:nvSpPr>
+          <p:cNvPr id="8" name="Shape 4"/>
+          <p:cNvSpPr/>
+          <p:nvPr/>
+        </p:nvSpPr>
+        <p:spPr>
+          <a:xfrm>
+            <a:off x="5760720" y="1417320"/>
+            <a:ext cx="4800600" cy="3154680"/>
+          </a:xfrm>
+          <a:prstGeom prst="rect">
             <a:avLst/>
           </a:prstGeom>
           <a:solidFill>
-            <a:srgbClr val="E7EEF2"/>
+            <a:srgbClr val="FFFFFF">
+              <a:alpha val="0"/>
+            </a:srgbClr>
           </a:solidFill>
           <a:ln w="12700">
             <a:solidFill>
@@ -12990,48 +14083,7 @@
       </p:sp>
       <p:sp>
         <p:nvSpPr>
-          <p:cNvPr id="8" name="Text 5"/>
-          <p:cNvSpPr/>
-          <p:nvPr/>
-        </p:nvSpPr>
-        <p:spPr>
-          <a:xfrm>
-            <a:off x="5925312" y="1618488"/>
-            <a:ext cx="4471416" cy="2752344"/>
-          </a:xfrm>
-          <a:prstGeom prst="rect">
-            <a:avLst/>
-          </a:prstGeom>
-          <a:noFill/>
-          <a:ln/>
-        </p:spPr>
-        <p:txBody>
-          <a:bodyPr wrap="square" lIns="635" tIns="635" rIns="635" bIns="635" rtlCol="0" anchor="ctr">
-            <a:normAutofit/>
-          </a:bodyPr>
-          <a:lstStyle/>
-          <a:p>
-            <a:pPr algn="ctr" indent="0" marL="0">
-              <a:buNone/>
-            </a:pPr>
-            <a:r>
-              <a:rPr lang="en-US" sz="1600" i="1" dirty="0">
-                <a:solidFill>
-                  <a:srgbClr val="6B7280"/>
-                </a:solidFill>
-                <a:latin typeface="Arial" pitchFamily="34" charset="0"/>
-                <a:ea typeface="Arial" pitchFamily="34" charset="-122"/>
-                <a:cs typeface="Arial" pitchFamily="34" charset="-120"/>
-              </a:rPr>
-              <a:t>FrontierMath image or leaderboard</a:t>
-            </a:r>
-            <a:endParaRPr lang="en-US" sz="1600" dirty="0"/>
-          </a:p>
-        </p:txBody>
-      </p:sp>
-      <p:sp>
-        <p:nvSpPr>
-          <p:cNvPr id="9" name="Text 6"/>
+          <p:cNvPr id="9" name="Text 5"/>
           <p:cNvSpPr/>
           <p:nvPr/>
         </p:nvSpPr>
@@ -13478,22 +14530,47 @@
           </a:p>
         </p:txBody>
       </p:sp>
-      <p:sp>
-        <p:nvSpPr>
-          <p:cNvPr id="5" name="Shape 3"/>
-          <p:cNvSpPr/>
-          <p:nvPr/>
-        </p:nvSpPr>
+      <p:pic>
+        <p:nvPicPr>
+          <p:cNvPr id="5" name="Image 0" descr="/home/matt.linux/talks/2026/oregon/assets/raw-images/frontiermath-banner.png">    </p:cNvPr>
+          <p:cNvPicPr>
+            <a:picLocks noChangeAspect="1"/>
+          </p:cNvPicPr>
+          <p:nvPr/>
+        </p:nvPicPr>
+        <p:blipFill>
+          <a:blip r:embed="rId1"/>
+          <a:srcRect l="0" r="0" t="0" b="0"/>
+          <a:stretch/>
+        </p:blipFill>
         <p:spPr>
           <a:xfrm>
             <a:off x="868680" y="1325880"/>
             <a:ext cx="5486400" cy="3840480"/>
           </a:xfrm>
-          <a:prstGeom prst="roundRect">
+          <a:prstGeom prst="rect">
+            <a:avLst/>
+          </a:prstGeom>
+        </p:spPr>
+      </p:pic>
+      <p:sp>
+        <p:nvSpPr>
+          <p:cNvPr id="6" name="Shape 3"/>
+          <p:cNvSpPr/>
+          <p:nvPr/>
+        </p:nvSpPr>
+        <p:spPr>
+          <a:xfrm>
+            <a:off x="868680" y="1325880"/>
+            <a:ext cx="5486400" cy="3840480"/>
+          </a:xfrm>
+          <a:prstGeom prst="rect">
             <a:avLst/>
           </a:prstGeom>
           <a:solidFill>
-            <a:srgbClr val="E7EEF2"/>
+            <a:srgbClr val="FFFFFF">
+              <a:alpha val="0"/>
+            </a:srgbClr>
           </a:solidFill>
           <a:ln w="12700">
             <a:solidFill>
@@ -13505,48 +14582,7 @@
       </p:sp>
       <p:sp>
         <p:nvSpPr>
-          <p:cNvPr id="6" name="Text 4"/>
-          <p:cNvSpPr/>
-          <p:nvPr/>
-        </p:nvSpPr>
-        <p:spPr>
-          <a:xfrm>
-            <a:off x="1033272" y="1527048"/>
-            <a:ext cx="5157216" cy="3438144"/>
-          </a:xfrm>
-          <a:prstGeom prst="rect">
-            <a:avLst/>
-          </a:prstGeom>
-          <a:noFill/>
-          <a:ln/>
-        </p:spPr>
-        <p:txBody>
-          <a:bodyPr wrap="square" lIns="635" tIns="635" rIns="635" bIns="635" rtlCol="0" anchor="ctr">
-            <a:normAutofit/>
-          </a:bodyPr>
-          <a:lstStyle/>
-          <a:p>
-            <a:pPr algn="ctr" indent="0" marL="0">
-              <a:buNone/>
-            </a:pPr>
-            <a:r>
-              <a:rPr lang="en-US" sz="1600" i="1" dirty="0">
-                <a:solidFill>
-                  <a:srgbClr val="6B7280"/>
-                </a:solidFill>
-                <a:latin typeface="Arial" pitchFamily="34" charset="0"/>
-                <a:ea typeface="Arial" pitchFamily="34" charset="-122"/>
-                <a:cs typeface="Arial" pitchFamily="34" charset="-120"/>
-              </a:rPr>
-              <a:t>Insert FrontierMath figure or Tier 4 leaderboard</a:t>
-            </a:r>
-            <a:endParaRPr lang="en-US" sz="1600" dirty="0"/>
-          </a:p>
-        </p:txBody>
-      </p:sp>
-      <p:sp>
-        <p:nvSpPr>
-          <p:cNvPr id="7" name="Text 5"/>
+          <p:cNvPr id="7" name="Text 4"/>
           <p:cNvSpPr/>
           <p:nvPr/>
         </p:nvSpPr>

</xml_diff>

<commit_message>
Add formal theorem example for slide 21
</commit_message>
<xml_diff>
--- a/deck/should-you-trust-an-ai-mathematician.pptx
+++ b/deck/should-you-trust-an-ai-mathematician.pptx
@@ -9696,11 +9696,149 @@
         </p:nvSpPr>
         <p:spPr>
           <a:xfrm>
-            <a:off x="868680" y="1325880"/>
-            <a:ext cx="5349240" cy="3886200"/>
+            <a:off x="868680" y="1371600"/>
+            <a:ext cx="5349240" cy="2011680"/>
           </a:xfrm>
           <a:prstGeom prst="roundRect">
-            <a:avLst/>
+            <a:avLst>
+              <a:gd name="adj" fmla="val 2727"/>
+            </a:avLst>
+          </a:prstGeom>
+          <a:solidFill>
+            <a:srgbClr val="F1EEE5"/>
+          </a:solidFill>
+          <a:ln w="12700">
+            <a:solidFill>
+              <a:srgbClr val="C8C4B7"/>
+            </a:solidFill>
+            <a:prstDash val="solid"/>
+          </a:ln>
+        </p:spPr>
+      </p:sp>
+      <p:sp>
+        <p:nvSpPr>
+          <p:cNvPr id="6" name="Text 4"/>
+          <p:cNvSpPr/>
+          <p:nvPr/>
+        </p:nvSpPr>
+        <p:spPr>
+          <a:xfrm>
+            <a:off x="1014984" y="1499616"/>
+            <a:ext cx="5056632" cy="1755648"/>
+          </a:xfrm>
+          <a:prstGeom prst="rect">
+            <a:avLst/>
+          </a:prstGeom>
+          <a:noFill/>
+          <a:ln/>
+        </p:spPr>
+        <p:txBody>
+          <a:bodyPr wrap="square" lIns="0" tIns="0" rIns="0" bIns="0" rtlCol="0" anchor="ctr">
+            <a:normAutofit/>
+          </a:bodyPr>
+          <a:lstStyle/>
+          <a:p>
+            <a:pPr indent="0" marL="0">
+              <a:buNone/>
+            </a:pPr>
+            <a:r>
+              <a:rPr lang="en-US" sz="1300" dirty="0">
+                <a:solidFill>
+                  <a:srgbClr val="1D232B"/>
+                </a:solidFill>
+                <a:latin typeface="Courier New" pitchFamily="34" charset="0"/>
+                <a:ea typeface="Courier New" pitchFamily="34" charset="-122"/>
+                <a:cs typeface="Courier New" pitchFamily="34" charset="-120"/>
+              </a:rPr>
+              <a:t>public theorem MainTheorem :</a:t>
+            </a:r>
+            <a:endParaRPr lang="en-US" sz="1300" dirty="0"/>
+          </a:p>
+          <a:p>
+            <a:pPr indent="0" marL="0">
+              <a:buNone/>
+            </a:pPr>
+            <a:r>
+              <a:rPr lang="en-US" sz="1300" dirty="0">
+                <a:solidFill>
+                  <a:srgbClr val="1D232B"/>
+                </a:solidFill>
+                <a:latin typeface="Courier New" pitchFamily="34" charset="0"/>
+                <a:ea typeface="Courier New" pitchFamily="34" charset="-122"/>
+                <a:cs typeface="Courier New" pitchFamily="34" charset="-120"/>
+              </a:rPr>
+              <a:t>    SpherePackingConstant 24 = Dim24.LeechPacking.density ∧</a:t>
+            </a:r>
+            <a:endParaRPr lang="en-US" sz="1300" dirty="0"/>
+          </a:p>
+          <a:p>
+            <a:pPr indent="0" marL="0">
+              <a:buNone/>
+            </a:pPr>
+            <a:r>
+              <a:rPr lang="en-US" sz="1300" dirty="0">
+                <a:solidFill>
+                  <a:srgbClr val="1D232B"/>
+                </a:solidFill>
+                <a:latin typeface="Courier New" pitchFamily="34" charset="0"/>
+                <a:ea typeface="Courier New" pitchFamily="34" charset="-122"/>
+                <a:cs typeface="Courier New" pitchFamily="34" charset="-120"/>
+              </a:rPr>
+              <a:t>      ∀ S : PeriodicSpherePacking 24,</a:t>
+            </a:r>
+            <a:endParaRPr lang="en-US" sz="1300" dirty="0"/>
+          </a:p>
+          <a:p>
+            <a:pPr indent="0" marL="0">
+              <a:buNone/>
+            </a:pPr>
+            <a:r>
+              <a:rPr lang="en-US" sz="1300" dirty="0">
+                <a:solidFill>
+                  <a:srgbClr val="1D232B"/>
+                </a:solidFill>
+                <a:latin typeface="Courier New" pitchFamily="34" charset="0"/>
+                <a:ea typeface="Courier New" pitchFamily="34" charset="-122"/>
+                <a:cs typeface="Courier New" pitchFamily="34" charset="-120"/>
+              </a:rPr>
+              <a:t>        S.density = Dim24.LeechPacking.density →</a:t>
+            </a:r>
+            <a:endParaRPr lang="en-US" sz="1300" dirty="0"/>
+          </a:p>
+          <a:p>
+            <a:pPr indent="0" marL="0">
+              <a:buNone/>
+            </a:pPr>
+            <a:r>
+              <a:rPr lang="en-US" sz="1300" dirty="0">
+                <a:solidFill>
+                  <a:srgbClr val="1D232B"/>
+                </a:solidFill>
+                <a:latin typeface="Courier New" pitchFamily="34" charset="0"/>
+                <a:ea typeface="Courier New" pitchFamily="34" charset="-122"/>
+                <a:cs typeface="Courier New" pitchFamily="34" charset="-120"/>
+              </a:rPr>
+              <a:t>          Dim24.IsometricToScaledLeech S := by</a:t>
+            </a:r>
+            <a:endParaRPr lang="en-US" sz="1300" dirty="0"/>
+          </a:p>
+        </p:txBody>
+      </p:sp>
+      <p:sp>
+        <p:nvSpPr>
+          <p:cNvPr id="7" name="Shape 5"/>
+          <p:cNvSpPr/>
+          <p:nvPr/>
+        </p:nvSpPr>
+        <p:spPr>
+          <a:xfrm>
+            <a:off x="868680" y="3657600"/>
+            <a:ext cx="5349240" cy="1417320"/>
+          </a:xfrm>
+          <a:prstGeom prst="roundRect">
+            <a:avLst>
+              <a:gd name="adj" fmla="val 5161"/>
+            </a:avLst>
           </a:prstGeom>
           <a:solidFill>
             <a:srgbClr val="E7EEF2"/>
@@ -9715,40 +9853,38 @@
       </p:sp>
       <p:sp>
         <p:nvSpPr>
-          <p:cNvPr id="6" name="Text 4"/>
-          <p:cNvSpPr/>
-          <p:nvPr/>
-        </p:nvSpPr>
-        <p:spPr>
-          <a:xfrm>
-            <a:off x="1033272" y="1527048"/>
-            <a:ext cx="5020056" cy="3483864"/>
-          </a:xfrm>
-          <a:prstGeom prst="rect">
-            <a:avLst/>
-          </a:prstGeom>
-          <a:noFill/>
-          <a:ln/>
-        </p:spPr>
-        <p:txBody>
-          <a:bodyPr wrap="square" lIns="635" tIns="635" rIns="635" bIns="635" rtlCol="0" anchor="ctr">
-            <a:normAutofit/>
-          </a:bodyPr>
-          <a:lstStyle/>
-          <a:p>
-            <a:pPr algn="ctr" indent="0" marL="0">
-              <a:buNone/>
-            </a:pPr>
-            <a:r>
-              <a:rPr lang="en-US" sz="1600" i="1" dirty="0">
-                <a:solidFill>
-                  <a:srgbClr val="6B7280"/>
-                </a:solidFill>
-                <a:latin typeface="Arial" pitchFamily="34" charset="0"/>
-                <a:ea typeface="Arial" pitchFamily="34" charset="-122"/>
-                <a:cs typeface="Arial" pitchFamily="34" charset="-120"/>
-              </a:rPr>
-              <a:t>Insert formal statement / definition example whose syntax obscures its meaning</a:t>
+          <p:cNvPr id="8" name="Text 6"/>
+          <p:cNvSpPr/>
+          <p:nvPr/>
+        </p:nvSpPr>
+        <p:spPr>
+          <a:xfrm>
+            <a:off x="1033272" y="3785616"/>
+            <a:ext cx="5020056" cy="237744"/>
+          </a:xfrm>
+          <a:prstGeom prst="rect">
+            <a:avLst/>
+          </a:prstGeom>
+          <a:noFill/>
+          <a:ln/>
+        </p:spPr>
+        <p:txBody>
+          <a:bodyPr wrap="square" lIns="0" tIns="0" rIns="0" bIns="0" rtlCol="0" anchor="ctr"/>
+          <a:lstStyle/>
+          <a:p>
+            <a:pPr indent="0" marL="0">
+              <a:buNone/>
+            </a:pPr>
+            <a:r>
+              <a:rPr lang="en-US" sz="1600" dirty="0">
+                <a:solidFill>
+                  <a:srgbClr val="3F5C6E"/>
+                </a:solidFill>
+                <a:latin typeface="Georgia" pitchFamily="34" charset="0"/>
+                <a:ea typeface="Georgia" pitchFamily="34" charset="-122"/>
+                <a:cs typeface="Georgia" pitchFamily="34" charset="-120"/>
+              </a:rPr>
+              <a:t>Informal translation</a:t>
             </a:r>
             <a:endParaRPr lang="en-US" sz="1600" dirty="0"/>
           </a:p>
@@ -9756,14 +9892,14 @@
       </p:sp>
       <p:sp>
         <p:nvSpPr>
-          <p:cNvPr id="7" name="Text 5"/>
-          <p:cNvSpPr/>
-          <p:nvPr/>
-        </p:nvSpPr>
-        <p:spPr>
-          <a:xfrm>
-            <a:off x="6446520" y="1463040"/>
-            <a:ext cx="4754880" cy="2743200"/>
+          <p:cNvPr id="9" name="Text 7"/>
+          <p:cNvSpPr/>
+          <p:nvPr/>
+        </p:nvSpPr>
+        <p:spPr>
+          <a:xfrm>
+            <a:off x="1033272" y="4096512"/>
+            <a:ext cx="5020056" cy="886968"/>
           </a:xfrm>
           <a:prstGeom prst="rect">
             <a:avLst/>
@@ -9781,6 +9917,47 @@
               <a:buNone/>
             </a:pPr>
             <a:r>
+              <a:rPr lang="en-US" sz="1700" dirty="0">
+                <a:solidFill>
+                  <a:srgbClr val="1D232B"/>
+                </a:solidFill>
+                <a:latin typeface="Arial" pitchFamily="34" charset="0"/>
+                <a:ea typeface="Arial" pitchFamily="34" charset="-122"/>
+                <a:cs typeface="Arial" pitchFamily="34" charset="-120"/>
+              </a:rPr>
+              <a:t>In dimension 24, the optimal density is the Leech lattice density, and any periodic packing of that density is the same up to scaling and isometry.</a:t>
+            </a:r>
+            <a:endParaRPr lang="en-US" sz="1700" dirty="0"/>
+          </a:p>
+        </p:txBody>
+      </p:sp>
+      <p:sp>
+        <p:nvSpPr>
+          <p:cNvPr id="10" name="Text 8"/>
+          <p:cNvSpPr/>
+          <p:nvPr/>
+        </p:nvSpPr>
+        <p:spPr>
+          <a:xfrm>
+            <a:off x="6446520" y="1463040"/>
+            <a:ext cx="4754880" cy="2743200"/>
+          </a:xfrm>
+          <a:prstGeom prst="rect">
+            <a:avLst/>
+          </a:prstGeom>
+          <a:noFill/>
+          <a:ln/>
+        </p:spPr>
+        <p:txBody>
+          <a:bodyPr wrap="square" lIns="381" tIns="381" rIns="381" bIns="381" rtlCol="0" anchor="t">
+            <a:normAutofit/>
+          </a:bodyPr>
+          <a:lstStyle/>
+          <a:p>
+            <a:pPr indent="0" marL="0">
+              <a:buNone/>
+            </a:pPr>
+            <a:r>
               <a:rPr lang="en-US" sz="1800" dirty="0">
                 <a:solidFill>
                   <a:srgbClr val="1D232B"/>
@@ -9826,6 +10003,45 @@
               <a:t>Formal syntax can obscure these things rather than clarify them.</a:t>
             </a:r>
             <a:endParaRPr lang="en-US" sz="1800" dirty="0"/>
+          </a:p>
+        </p:txBody>
+      </p:sp>
+      <p:sp>
+        <p:nvSpPr>
+          <p:cNvPr id="11" name="Text 9"/>
+          <p:cNvSpPr/>
+          <p:nvPr/>
+        </p:nvSpPr>
+        <p:spPr>
+          <a:xfrm>
+            <a:off x="868680" y="5285232"/>
+            <a:ext cx="5394960" cy="201168"/>
+          </a:xfrm>
+          <a:prstGeom prst="rect">
+            <a:avLst/>
+          </a:prstGeom>
+          <a:noFill/>
+          <a:ln/>
+        </p:spPr>
+        <p:txBody>
+          <a:bodyPr wrap="square" lIns="0" tIns="0" rIns="0" bIns="0" rtlCol="0" anchor="ctr"/>
+          <a:lstStyle/>
+          <a:p>
+            <a:pPr indent="0" marL="0">
+              <a:buNone/>
+            </a:pPr>
+            <a:r>
+              <a:rPr lang="en-US" sz="1100" dirty="0">
+                <a:solidFill>
+                  <a:srgbClr val="6B7280"/>
+                </a:solidFill>
+                <a:latin typeface="Arial" pitchFamily="34" charset="0"/>
+                <a:ea typeface="Arial" pitchFamily="34" charset="-122"/>
+                <a:cs typeface="Arial" pitchFamily="34" charset="-120"/>
+              </a:rPr>
+              <a:t>Example drawn from the public Sphere-Packing-Lean repository.</a:t>
+            </a:r>
+            <a:endParaRPr lang="en-US" sz="1100" dirty="0"/>
           </a:p>
         </p:txBody>
       </p:sp>

</xml_diff>

<commit_message>
Simplify slide layouts and block figures
</commit_message>
<xml_diff>
--- a/deck/should-you-trust-an-ai-mathematician.pptx
+++ b/deck/should-you-trust-an-ai-mathematician.pptx
@@ -4696,47 +4696,97 @@
           </a:p>
         </p:txBody>
       </p:sp>
-      <p:pic>
-        <p:nvPicPr>
-          <p:cNvPr id="5" name="Image 0" descr="/home/matt.linux/talks/2026/oregon/assets/raw-images/2407-fig7-10.png">    </p:cNvPr>
-          <p:cNvPicPr>
-            <a:picLocks noChangeAspect="1"/>
-          </p:cNvPicPr>
-          <p:nvPr/>
-        </p:nvPicPr>
-        <p:blipFill>
-          <a:blip r:embed="rId1"/>
-          <a:srcRect l="0" r="0" t="0" b="0"/>
-          <a:stretch/>
-        </p:blipFill>
-        <p:spPr>
-          <a:xfrm>
-            <a:off x="868680" y="1325880"/>
-            <a:ext cx="5852160" cy="3840480"/>
-          </a:xfrm>
-          <a:prstGeom prst="rect">
-            <a:avLst/>
-          </a:prstGeom>
-        </p:spPr>
-      </p:pic>
-      <p:sp>
-        <p:nvSpPr>
-          <p:cNvPr id="6" name="Shape 3"/>
-          <p:cNvSpPr/>
-          <p:nvPr/>
-        </p:nvSpPr>
-        <p:spPr>
-          <a:xfrm>
-            <a:off x="868680" y="1325880"/>
-            <a:ext cx="5852160" cy="3840480"/>
+      <p:sp>
+        <p:nvSpPr>
+          <p:cNvPr id="5" name="Text 3"/>
+          <p:cNvSpPr/>
+          <p:nvPr/>
+        </p:nvSpPr>
+        <p:spPr>
+          <a:xfrm>
+            <a:off x="868680" y="1371600"/>
+            <a:ext cx="10058400" cy="1417320"/>
+          </a:xfrm>
+          <a:prstGeom prst="rect">
+            <a:avLst/>
+          </a:prstGeom>
+          <a:noFill/>
+          <a:ln/>
+        </p:spPr>
+        <p:txBody>
+          <a:bodyPr wrap="square" lIns="381" tIns="381" rIns="381" bIns="381" rtlCol="0" anchor="t">
+            <a:normAutofit/>
+          </a:bodyPr>
+          <a:lstStyle/>
+          <a:p>
+            <a:pPr indent="0" marL="0">
+              <a:buNone/>
+            </a:pPr>
+            <a:r>
+              <a:rPr lang="en-US" sz="1800" dirty="0">
+                <a:solidFill>
+                  <a:srgbClr val="1D232B"/>
+                </a:solidFill>
+                <a:latin typeface="Arial" pitchFamily="34" charset="0"/>
+                <a:ea typeface="Arial" pitchFamily="34" charset="-122"/>
+                <a:cs typeface="Arial" pitchFamily="34" charset="-120"/>
+              </a:rPr>
+              <a:t>If one allows many tries, success rates can rise dramatically.</a:t>
+            </a:r>
+            <a:endParaRPr lang="en-US" sz="1800" dirty="0"/>
+          </a:p>
+          <a:p>
+            <a:pPr indent="0" marL="0">
+              <a:buNone/>
+            </a:pPr>
+            <a:r>
+              <a:rPr lang="en-US" sz="1800" dirty="0">
+                <a:solidFill>
+                  <a:srgbClr val="1D232B"/>
+                </a:solidFill>
+                <a:latin typeface="Arial" pitchFamily="34" charset="0"/>
+                <a:ea typeface="Arial" pitchFamily="34" charset="-122"/>
+                <a:cs typeface="Arial" pitchFamily="34" charset="-120"/>
+              </a:rPr>
+              <a:t>But eventual success after repeated sampling is not the same thing</a:t>
+            </a:r>
+            <a:endParaRPr lang="en-US" sz="1800" dirty="0"/>
+          </a:p>
+          <a:p>
+            <a:pPr indent="0" marL="0">
+              <a:buNone/>
+            </a:pPr>
+            <a:r>
+              <a:rPr lang="en-US" sz="1800" dirty="0">
+                <a:solidFill>
+                  <a:srgbClr val="1D232B"/>
+                </a:solidFill>
+                <a:latin typeface="Arial" pitchFamily="34" charset="0"/>
+                <a:ea typeface="Arial" pitchFamily="34" charset="-122"/>
+                <a:cs typeface="Arial" pitchFamily="34" charset="-120"/>
+              </a:rPr>
+              <a:t>as a system that is reliable on the first few serious attempts.</a:t>
+            </a:r>
+            <a:endParaRPr lang="en-US" sz="1800" dirty="0"/>
+          </a:p>
+        </p:txBody>
+      </p:sp>
+      <p:sp>
+        <p:nvSpPr>
+          <p:cNvPr id="6" name="Shape 4"/>
+          <p:cNvSpPr/>
+          <p:nvPr/>
+        </p:nvSpPr>
+        <p:spPr>
+          <a:xfrm>
+            <a:off x="868680" y="2788920"/>
+            <a:ext cx="8229600" cy="2423160"/>
           </a:xfrm>
           <a:prstGeom prst="rect">
             <a:avLst/>
           </a:prstGeom>
           <a:solidFill>
-            <a:srgbClr val="FFFFFF">
-              <a:alpha val="0"/>
-            </a:srgbClr>
+            <a:srgbClr val="FFFFFF"/>
           </a:solidFill>
           <a:ln w="12700">
             <a:solidFill>
@@ -4748,89 +4798,94 @@
       </p:sp>
       <p:sp>
         <p:nvSpPr>
-          <p:cNvPr id="7" name="Text 4"/>
-          <p:cNvSpPr/>
-          <p:nvPr/>
-        </p:nvSpPr>
-        <p:spPr>
-          <a:xfrm>
-            <a:off x="6903720" y="1417320"/>
-            <a:ext cx="4434840" cy="2468880"/>
-          </a:xfrm>
-          <a:prstGeom prst="rect">
-            <a:avLst/>
-          </a:prstGeom>
-          <a:noFill/>
-          <a:ln/>
-        </p:spPr>
-        <p:txBody>
-          <a:bodyPr wrap="square" lIns="381" tIns="381" rIns="381" bIns="381" rtlCol="0" anchor="t">
+          <p:cNvPr id="7" name="Text 5"/>
+          <p:cNvSpPr/>
+          <p:nvPr/>
+        </p:nvSpPr>
+        <p:spPr>
+          <a:xfrm>
+            <a:off x="1033272" y="2935224"/>
+            <a:ext cx="7900416" cy="182880"/>
+          </a:xfrm>
+          <a:prstGeom prst="rect">
+            <a:avLst/>
+          </a:prstGeom>
+          <a:noFill/>
+          <a:ln/>
+        </p:spPr>
+        <p:txBody>
+          <a:bodyPr wrap="square" lIns="0" tIns="0" rIns="0" bIns="0" rtlCol="0" anchor="ctr"/>
+          <a:lstStyle/>
+          <a:p>
+            <a:pPr indent="0" marL="0">
+              <a:buNone/>
+            </a:pPr>
+            <a:r>
+              <a:rPr lang="en-US" sz="1100" b="1" dirty="0">
+                <a:solidFill>
+                  <a:srgbClr val="6B7280"/>
+                </a:solidFill>
+                <a:latin typeface="Arial" pitchFamily="34" charset="0"/>
+                <a:ea typeface="Arial" pitchFamily="34" charset="-122"/>
+                <a:cs typeface="Arial" pitchFamily="34" charset="-120"/>
+              </a:rPr>
+              <a:t>Figure placeholder</a:t>
+            </a:r>
+            <a:endParaRPr lang="en-US" sz="1100" dirty="0"/>
+          </a:p>
+        </p:txBody>
+      </p:sp>
+      <p:sp>
+        <p:nvSpPr>
+          <p:cNvPr id="8" name="Text 6"/>
+          <p:cNvSpPr/>
+          <p:nvPr/>
+        </p:nvSpPr>
+        <p:spPr>
+          <a:xfrm>
+            <a:off x="1033272" y="3200400"/>
+            <a:ext cx="7900416" cy="1801368"/>
+          </a:xfrm>
+          <a:prstGeom prst="rect">
+            <a:avLst/>
+          </a:prstGeom>
+          <a:noFill/>
+          <a:ln/>
+        </p:spPr>
+        <p:txBody>
+          <a:bodyPr wrap="square" lIns="635" tIns="635" rIns="635" bIns="635" rtlCol="0" anchor="ctr">
             <a:normAutofit/>
           </a:bodyPr>
           <a:lstStyle/>
           <a:p>
-            <a:pPr indent="0" marL="0">
-              <a:buNone/>
-            </a:pPr>
-            <a:r>
-              <a:rPr lang="en-US" sz="1800" dirty="0">
-                <a:solidFill>
-                  <a:srgbClr val="1D232B"/>
-                </a:solidFill>
-                <a:latin typeface="Arial" pitchFamily="34" charset="0"/>
-                <a:ea typeface="Arial" pitchFamily="34" charset="-122"/>
-                <a:cs typeface="Arial" pitchFamily="34" charset="-120"/>
-              </a:rPr>
-              <a:t>If one allows many tries, success rates can rise dramatically.</a:t>
-            </a:r>
-            <a:endParaRPr lang="en-US" sz="1800" dirty="0"/>
-          </a:p>
-          <a:p>
-            <a:pPr indent="0" marL="0">
-              <a:buNone/>
-            </a:pPr>
-            <a:r>
-              <a:rPr lang="en-US" sz="1800" dirty="0">
-                <a:solidFill>
-                  <a:srgbClr val="1D232B"/>
-                </a:solidFill>
-                <a:latin typeface="Arial" pitchFamily="34" charset="0"/>
-                <a:ea typeface="Arial" pitchFamily="34" charset="-122"/>
-                <a:cs typeface="Arial" pitchFamily="34" charset="-120"/>
-              </a:rPr>
-              <a:t>But eventual success after repeated sampling is not the same thing</a:t>
-            </a:r>
-            <a:endParaRPr lang="en-US" sz="1800" dirty="0"/>
-          </a:p>
-          <a:p>
-            <a:pPr indent="0" marL="0">
-              <a:buNone/>
-            </a:pPr>
-            <a:r>
-              <a:rPr lang="en-US" sz="1800" dirty="0">
-                <a:solidFill>
-                  <a:srgbClr val="1D232B"/>
-                </a:solidFill>
-                <a:latin typeface="Arial" pitchFamily="34" charset="0"/>
-                <a:ea typeface="Arial" pitchFamily="34" charset="-122"/>
-                <a:cs typeface="Arial" pitchFamily="34" charset="-120"/>
-              </a:rPr>
-              <a:t>as a system that is reliable on the first few serious attempts.</a:t>
-            </a:r>
-            <a:endParaRPr lang="en-US" sz="1800" dirty="0"/>
-          </a:p>
-        </p:txBody>
-      </p:sp>
-      <p:sp>
-        <p:nvSpPr>
-          <p:cNvPr id="8" name="Text 5"/>
-          <p:cNvSpPr/>
-          <p:nvPr/>
-        </p:nvSpPr>
-        <p:spPr>
-          <a:xfrm>
-            <a:off x="7498080" y="4160520"/>
-            <a:ext cx="2377440" cy="320040"/>
+            <a:pPr algn="ctr" indent="0" marL="0">
+              <a:buNone/>
+            </a:pPr>
+            <a:r>
+              <a:rPr lang="en-US" sz="1600" i="1" dirty="0">
+                <a:solidFill>
+                  <a:srgbClr val="6B7280"/>
+                </a:solidFill>
+                <a:latin typeface="Arial" pitchFamily="34" charset="0"/>
+                <a:ea typeface="Arial" pitchFamily="34" charset="-122"/>
+                <a:cs typeface="Arial" pitchFamily="34" charset="-120"/>
+              </a:rPr>
+              <a:t>Insert repeated-sampling figure from arXiv:2407.21787</a:t>
+            </a:r>
+            <a:endParaRPr lang="en-US" sz="1600" dirty="0"/>
+          </a:p>
+        </p:txBody>
+      </p:sp>
+      <p:sp>
+        <p:nvSpPr>
+          <p:cNvPr id="9" name="Text 7"/>
+          <p:cNvSpPr/>
+          <p:nvPr/>
+        </p:nvSpPr>
+        <p:spPr>
+          <a:xfrm>
+            <a:off x="9326880" y="3794760"/>
+            <a:ext cx="1783080" cy="347472"/>
           </a:xfrm>
           <a:prstGeom prst="rect">
             <a:avLst/>
@@ -6096,8 +6151,8 @@
         </p:nvSpPr>
         <p:spPr>
           <a:xfrm>
-            <a:off x="868680" y="1417320"/>
-            <a:ext cx="4892040" cy="3474720"/>
+            <a:off x="868680" y="1371600"/>
+            <a:ext cx="10058400" cy="1691640"/>
           </a:xfrm>
           <a:prstGeom prst="rect">
             <a:avLst/>
@@ -6180,47 +6235,22 @@
           </a:p>
         </p:txBody>
       </p:sp>
-      <p:pic>
-        <p:nvPicPr>
-          <p:cNvPr id="6" name="Image 0" descr="/home/matt.linux/talks/2026/oregon/assets/raw-images/2602-fig1-01.png">    </p:cNvPr>
-          <p:cNvPicPr>
-            <a:picLocks noChangeAspect="1"/>
-          </p:cNvPicPr>
-          <p:nvPr/>
-        </p:nvPicPr>
-        <p:blipFill>
-          <a:blip r:embed="rId1"/>
-          <a:srcRect l="0" r="0" t="0" b="0"/>
-          <a:stretch/>
-        </p:blipFill>
-        <p:spPr>
-          <a:xfrm>
-            <a:off x="5989320" y="1325880"/>
-            <a:ext cx="5394960" cy="3886200"/>
-          </a:xfrm>
-          <a:prstGeom prst="rect">
-            <a:avLst/>
-          </a:prstGeom>
-        </p:spPr>
-      </p:pic>
-      <p:sp>
-        <p:nvSpPr>
-          <p:cNvPr id="7" name="Shape 4"/>
-          <p:cNvSpPr/>
-          <p:nvPr/>
-        </p:nvSpPr>
-        <p:spPr>
-          <a:xfrm>
-            <a:off x="5989320" y="1325880"/>
-            <a:ext cx="5394960" cy="3886200"/>
+      <p:sp>
+        <p:nvSpPr>
+          <p:cNvPr id="6" name="Shape 4"/>
+          <p:cNvSpPr/>
+          <p:nvPr/>
+        </p:nvSpPr>
+        <p:spPr>
+          <a:xfrm>
+            <a:off x="868680" y="3246120"/>
+            <a:ext cx="10149840" cy="1965960"/>
           </a:xfrm>
           <a:prstGeom prst="rect">
             <a:avLst/>
           </a:prstGeom>
           <a:solidFill>
-            <a:srgbClr val="FFFFFF">
-              <a:alpha val="0"/>
-            </a:srgbClr>
+            <a:srgbClr val="FFFFFF"/>
           </a:solidFill>
           <a:ln w="12700">
             <a:solidFill>
@@ -6229,6 +6259,86 @@
             <a:prstDash val="solid"/>
           </a:ln>
         </p:spPr>
+      </p:sp>
+      <p:sp>
+        <p:nvSpPr>
+          <p:cNvPr id="7" name="Text 5"/>
+          <p:cNvSpPr/>
+          <p:nvPr/>
+        </p:nvSpPr>
+        <p:spPr>
+          <a:xfrm>
+            <a:off x="1033272" y="3392424"/>
+            <a:ext cx="9820656" cy="182880"/>
+          </a:xfrm>
+          <a:prstGeom prst="rect">
+            <a:avLst/>
+          </a:prstGeom>
+          <a:noFill/>
+          <a:ln/>
+        </p:spPr>
+        <p:txBody>
+          <a:bodyPr wrap="square" lIns="0" tIns="0" rIns="0" bIns="0" rtlCol="0" anchor="ctr"/>
+          <a:lstStyle/>
+          <a:p>
+            <a:pPr indent="0" marL="0">
+              <a:buNone/>
+            </a:pPr>
+            <a:r>
+              <a:rPr lang="en-US" sz="1100" b="1" dirty="0">
+                <a:solidFill>
+                  <a:srgbClr val="6B7280"/>
+                </a:solidFill>
+                <a:latin typeface="Arial" pitchFamily="34" charset="0"/>
+                <a:ea typeface="Arial" pitchFamily="34" charset="-122"/>
+                <a:cs typeface="Arial" pitchFamily="34" charset="-120"/>
+              </a:rPr>
+              <a:t>Figure placeholder</a:t>
+            </a:r>
+            <a:endParaRPr lang="en-US" sz="1100" dirty="0"/>
+          </a:p>
+        </p:txBody>
+      </p:sp>
+      <p:sp>
+        <p:nvSpPr>
+          <p:cNvPr id="8" name="Text 6"/>
+          <p:cNvSpPr/>
+          <p:nvPr/>
+        </p:nvSpPr>
+        <p:spPr>
+          <a:xfrm>
+            <a:off x="1033272" y="3657600"/>
+            <a:ext cx="9820656" cy="1344168"/>
+          </a:xfrm>
+          <a:prstGeom prst="rect">
+            <a:avLst/>
+          </a:prstGeom>
+          <a:noFill/>
+          <a:ln/>
+        </p:spPr>
+        <p:txBody>
+          <a:bodyPr wrap="square" lIns="635" tIns="635" rIns="635" bIns="635" rtlCol="0" anchor="ctr">
+            <a:normAutofit/>
+          </a:bodyPr>
+          <a:lstStyle/>
+          <a:p>
+            <a:pPr algn="ctr" indent="0" marL="0">
+              <a:buNone/>
+            </a:pPr>
+            <a:r>
+              <a:rPr lang="en-US" sz="1600" i="1" dirty="0">
+                <a:solidFill>
+                  <a:srgbClr val="6B7280"/>
+                </a:solidFill>
+                <a:latin typeface="Arial" pitchFamily="34" charset="0"/>
+                <a:ea typeface="Arial" pitchFamily="34" charset="-122"/>
+                <a:cs typeface="Arial" pitchFamily="34" charset="-120"/>
+              </a:rPr>
+              <a:t>Insert reliability figure from arXiv:2602.16666v1</a:t>
+            </a:r>
+            <a:endParaRPr lang="en-US" sz="1600" dirty="0"/>
+          </a:p>
+        </p:txBody>
       </p:sp>
     </p:spTree>
   </p:cSld>
@@ -7489,47 +7599,97 @@
           </a:p>
         </p:txBody>
       </p:sp>
-      <p:pic>
-        <p:nvPicPr>
-          <p:cNvPr id="5" name="Image 0" descr="/home/matt.linux/talks/2026/oregon/assets/raw-images/alphaevolve-fig1-03.png">    </p:cNvPr>
-          <p:cNvPicPr>
-            <a:picLocks noChangeAspect="1"/>
-          </p:cNvPicPr>
-          <p:nvPr/>
-        </p:nvPicPr>
-        <p:blipFill>
-          <a:blip r:embed="rId1"/>
-          <a:srcRect l="0" r="0" t="0" b="0"/>
-          <a:stretch/>
-        </p:blipFill>
-        <p:spPr>
-          <a:xfrm>
-            <a:off x="868680" y="1325880"/>
-            <a:ext cx="5577840" cy="3840480"/>
-          </a:xfrm>
-          <a:prstGeom prst="rect">
-            <a:avLst/>
-          </a:prstGeom>
-        </p:spPr>
-      </p:pic>
-      <p:sp>
-        <p:nvSpPr>
-          <p:cNvPr id="6" name="Shape 3"/>
-          <p:cNvSpPr/>
-          <p:nvPr/>
-        </p:nvSpPr>
-        <p:spPr>
-          <a:xfrm>
-            <a:off x="868680" y="1325880"/>
-            <a:ext cx="5577840" cy="3840480"/>
+      <p:sp>
+        <p:nvSpPr>
+          <p:cNvPr id="5" name="Text 3"/>
+          <p:cNvSpPr/>
+          <p:nvPr/>
+        </p:nvSpPr>
+        <p:spPr>
+          <a:xfrm>
+            <a:off x="868680" y="1371600"/>
+            <a:ext cx="10058400" cy="1417320"/>
+          </a:xfrm>
+          <a:prstGeom prst="rect">
+            <a:avLst/>
+          </a:prstGeom>
+          <a:noFill/>
+          <a:ln/>
+        </p:spPr>
+        <p:txBody>
+          <a:bodyPr wrap="square" lIns="381" tIns="381" rIns="381" bIns="381" rtlCol="0" anchor="t">
+            <a:normAutofit/>
+          </a:bodyPr>
+          <a:lstStyle/>
+          <a:p>
+            <a:pPr indent="0" marL="0">
+              <a:buNone/>
+            </a:pPr>
+            <a:r>
+              <a:rPr lang="en-US" sz="1800" dirty="0">
+                <a:solidFill>
+                  <a:srgbClr val="1D232B"/>
+                </a:solidFill>
+                <a:latin typeface="Arial" pitchFamily="34" charset="0"/>
+                <a:ea typeface="Arial" pitchFamily="34" charset="-122"/>
+                <a:cs typeface="Arial" pitchFamily="34" charset="-120"/>
+              </a:rPr>
+              <a:t>The most impressive current systems do not ignore unreliability.</a:t>
+            </a:r>
+            <a:endParaRPr lang="en-US" sz="1800" dirty="0"/>
+          </a:p>
+          <a:p>
+            <a:pPr indent="0" marL="0">
+              <a:buNone/>
+            </a:pPr>
+            <a:r>
+              <a:rPr lang="en-US" sz="1800" dirty="0">
+                <a:solidFill>
+                  <a:srgbClr val="1D232B"/>
+                </a:solidFill>
+                <a:latin typeface="Arial" pitchFamily="34" charset="0"/>
+                <a:ea typeface="Arial" pitchFamily="34" charset="-122"/>
+                <a:cs typeface="Arial" pitchFamily="34" charset="-120"/>
+              </a:rPr>
+              <a:t>They put generation inside a loop of testing, scoring, and selection.</a:t>
+            </a:r>
+            <a:endParaRPr lang="en-US" sz="1800" dirty="0"/>
+          </a:p>
+          <a:p>
+            <a:pPr indent="0" marL="0">
+              <a:buNone/>
+            </a:pPr>
+            <a:r>
+              <a:rPr lang="en-US" sz="1800" dirty="0">
+                <a:solidFill>
+                  <a:srgbClr val="1D232B"/>
+                </a:solidFill>
+                <a:latin typeface="Arial" pitchFamily="34" charset="0"/>
+                <a:ea typeface="Arial" pitchFamily="34" charset="-122"/>
+                <a:cs typeface="Arial" pitchFamily="34" charset="-120"/>
+              </a:rPr>
+              <a:t>AlphaEvolve is a good example of this.</a:t>
+            </a:r>
+            <a:endParaRPr lang="en-US" sz="1800" dirty="0"/>
+          </a:p>
+        </p:txBody>
+      </p:sp>
+      <p:sp>
+        <p:nvSpPr>
+          <p:cNvPr id="6" name="Shape 4"/>
+          <p:cNvSpPr/>
+          <p:nvPr/>
+        </p:nvSpPr>
+        <p:spPr>
+          <a:xfrm>
+            <a:off x="868680" y="3017520"/>
+            <a:ext cx="10149840" cy="2377440"/>
           </a:xfrm>
           <a:prstGeom prst="rect">
             <a:avLst/>
           </a:prstGeom>
           <a:solidFill>
-            <a:srgbClr val="FFFFFF">
-              <a:alpha val="0"/>
-            </a:srgbClr>
+            <a:srgbClr val="FFFFFF"/>
           </a:solidFill>
           <a:ln w="12700">
             <a:solidFill>
@@ -7541,76 +7701,81 @@
       </p:sp>
       <p:sp>
         <p:nvSpPr>
-          <p:cNvPr id="7" name="Text 4"/>
-          <p:cNvSpPr/>
-          <p:nvPr/>
-        </p:nvSpPr>
-        <p:spPr>
-          <a:xfrm>
-            <a:off x="6629400" y="1463040"/>
-            <a:ext cx="4572000" cy="2834640"/>
-          </a:xfrm>
-          <a:prstGeom prst="rect">
-            <a:avLst/>
-          </a:prstGeom>
-          <a:noFill/>
-          <a:ln/>
-        </p:spPr>
-        <p:txBody>
-          <a:bodyPr wrap="square" lIns="381" tIns="381" rIns="381" bIns="381" rtlCol="0" anchor="t">
+          <p:cNvPr id="7" name="Text 5"/>
+          <p:cNvSpPr/>
+          <p:nvPr/>
+        </p:nvSpPr>
+        <p:spPr>
+          <a:xfrm>
+            <a:off x="1033272" y="3163824"/>
+            <a:ext cx="9820656" cy="182880"/>
+          </a:xfrm>
+          <a:prstGeom prst="rect">
+            <a:avLst/>
+          </a:prstGeom>
+          <a:noFill/>
+          <a:ln/>
+        </p:spPr>
+        <p:txBody>
+          <a:bodyPr wrap="square" lIns="0" tIns="0" rIns="0" bIns="0" rtlCol="0" anchor="ctr"/>
+          <a:lstStyle/>
+          <a:p>
+            <a:pPr indent="0" marL="0">
+              <a:buNone/>
+            </a:pPr>
+            <a:r>
+              <a:rPr lang="en-US" sz="1100" b="1" dirty="0">
+                <a:solidFill>
+                  <a:srgbClr val="6B7280"/>
+                </a:solidFill>
+                <a:latin typeface="Arial" pitchFamily="34" charset="0"/>
+                <a:ea typeface="Arial" pitchFamily="34" charset="-122"/>
+                <a:cs typeface="Arial" pitchFamily="34" charset="-120"/>
+              </a:rPr>
+              <a:t>Figure placeholder</a:t>
+            </a:r>
+            <a:endParaRPr lang="en-US" sz="1100" dirty="0"/>
+          </a:p>
+        </p:txBody>
+      </p:sp>
+      <p:sp>
+        <p:nvSpPr>
+          <p:cNvPr id="8" name="Text 6"/>
+          <p:cNvSpPr/>
+          <p:nvPr/>
+        </p:nvSpPr>
+        <p:spPr>
+          <a:xfrm>
+            <a:off x="1033272" y="3429000"/>
+            <a:ext cx="9820656" cy="1755648"/>
+          </a:xfrm>
+          <a:prstGeom prst="rect">
+            <a:avLst/>
+          </a:prstGeom>
+          <a:noFill/>
+          <a:ln/>
+        </p:spPr>
+        <p:txBody>
+          <a:bodyPr wrap="square" lIns="635" tIns="635" rIns="635" bIns="635" rtlCol="0" anchor="ctr">
             <a:normAutofit/>
           </a:bodyPr>
           <a:lstStyle/>
           <a:p>
-            <a:pPr indent="0" marL="0">
-              <a:buNone/>
-            </a:pPr>
-            <a:r>
-              <a:rPr lang="en-US" sz="1800" dirty="0">
-                <a:solidFill>
-                  <a:srgbClr val="1D232B"/>
-                </a:solidFill>
-                <a:latin typeface="Arial" pitchFamily="34" charset="0"/>
-                <a:ea typeface="Arial" pitchFamily="34" charset="-122"/>
-                <a:cs typeface="Arial" pitchFamily="34" charset="-120"/>
-              </a:rPr>
-              <a:t>The most impressive current systems do not ignore unreliability.</a:t>
-            </a:r>
-            <a:endParaRPr lang="en-US" sz="1800" dirty="0"/>
-          </a:p>
-          <a:p>
-            <a:pPr indent="0" marL="0">
-              <a:buNone/>
-            </a:pPr>
-            <a:r>
-              <a:rPr lang="en-US" sz="1800" dirty="0">
-                <a:solidFill>
-                  <a:srgbClr val="1D232B"/>
-                </a:solidFill>
-                <a:latin typeface="Arial" pitchFamily="34" charset="0"/>
-                <a:ea typeface="Arial" pitchFamily="34" charset="-122"/>
-                <a:cs typeface="Arial" pitchFamily="34" charset="-120"/>
-              </a:rPr>
-              <a:t>They put generation inside a loop of testing, scoring, and selection.</a:t>
-            </a:r>
-            <a:endParaRPr lang="en-US" sz="1800" dirty="0"/>
-          </a:p>
-          <a:p>
-            <a:pPr indent="0" marL="0">
-              <a:buNone/>
-            </a:pPr>
-            <a:r>
-              <a:rPr lang="en-US" sz="1800" dirty="0">
-                <a:solidFill>
-                  <a:srgbClr val="1D232B"/>
-                </a:solidFill>
-                <a:latin typeface="Arial" pitchFamily="34" charset="0"/>
-                <a:ea typeface="Arial" pitchFamily="34" charset="-122"/>
-                <a:cs typeface="Arial" pitchFamily="34" charset="-120"/>
-              </a:rPr>
-              <a:t>AlphaEvolve is a good example of this.</a:t>
-            </a:r>
-            <a:endParaRPr lang="en-US" sz="1800" dirty="0"/>
+            <a:pPr algn="ctr" indent="0" marL="0">
+              <a:buNone/>
+            </a:pPr>
+            <a:r>
+              <a:rPr lang="en-US" sz="1600" i="1" dirty="0">
+                <a:solidFill>
+                  <a:srgbClr val="6B7280"/>
+                </a:solidFill>
+                <a:latin typeface="Arial" pitchFamily="34" charset="0"/>
+                <a:ea typeface="Arial" pitchFamily="34" charset="-122"/>
+                <a:cs typeface="Arial" pitchFamily="34" charset="-120"/>
+              </a:rPr>
+              <a:t>Insert AlphaEvolve setup figure</a:t>
+            </a:r>
+            <a:endParaRPr lang="en-US" sz="1600" dirty="0"/>
           </a:p>
         </p:txBody>
       </p:sp>
@@ -7747,47 +7912,80 @@
           </a:p>
         </p:txBody>
       </p:sp>
-      <p:pic>
-        <p:nvPicPr>
-          <p:cNvPr id="5" name="Image 0" descr="/home/matt.linux/talks/2026/oregon/assets/raw-images/alphaevolve-fig5-12.png">    </p:cNvPr>
-          <p:cNvPicPr>
-            <a:picLocks noChangeAspect="1"/>
-          </p:cNvPicPr>
-          <p:nvPr/>
-        </p:nvPicPr>
-        <p:blipFill>
-          <a:blip r:embed="rId1"/>
-          <a:srcRect l="0" r="0" t="0" b="0"/>
-          <a:stretch/>
-        </p:blipFill>
-        <p:spPr>
-          <a:xfrm>
-            <a:off x="868680" y="1325880"/>
-            <a:ext cx="5349240" cy="3840480"/>
-          </a:xfrm>
-          <a:prstGeom prst="rect">
-            <a:avLst/>
-          </a:prstGeom>
-        </p:spPr>
-      </p:pic>
-      <p:sp>
-        <p:nvSpPr>
-          <p:cNvPr id="6" name="Shape 3"/>
-          <p:cNvSpPr/>
-          <p:nvPr/>
-        </p:nvSpPr>
-        <p:spPr>
-          <a:xfrm>
-            <a:off x="868680" y="1325880"/>
-            <a:ext cx="5349240" cy="3840480"/>
+      <p:sp>
+        <p:nvSpPr>
+          <p:cNvPr id="5" name="Text 3"/>
+          <p:cNvSpPr/>
+          <p:nvPr/>
+        </p:nvSpPr>
+        <p:spPr>
+          <a:xfrm>
+            <a:off x="868680" y="1371600"/>
+            <a:ext cx="10058400" cy="1188720"/>
+          </a:xfrm>
+          <a:prstGeom prst="rect">
+            <a:avLst/>
+          </a:prstGeom>
+          <a:noFill/>
+          <a:ln/>
+        </p:spPr>
+        <p:txBody>
+          <a:bodyPr wrap="square" lIns="381" tIns="381" rIns="381" bIns="381" rtlCol="0" anchor="t">
+            <a:normAutofit/>
+          </a:bodyPr>
+          <a:lstStyle/>
+          <a:p>
+            <a:pPr indent="0" marL="0">
+              <a:buNone/>
+            </a:pPr>
+            <a:r>
+              <a:rPr lang="en-US" sz="1800" dirty="0">
+                <a:solidFill>
+                  <a:srgbClr val="1D232B"/>
+                </a:solidFill>
+                <a:latin typeface="Arial" pitchFamily="34" charset="0"/>
+                <a:ea typeface="Arial" pitchFamily="34" charset="-122"/>
+                <a:cs typeface="Arial" pitchFamily="34" charset="-120"/>
+              </a:rPr>
+              <a:t>This approach is strongest when progress can be automatically evaluated.</a:t>
+            </a:r>
+            <a:endParaRPr lang="en-US" sz="1800" dirty="0"/>
+          </a:p>
+          <a:p>
+            <a:pPr indent="0" marL="0">
+              <a:buNone/>
+            </a:pPr>
+            <a:r>
+              <a:rPr lang="en-US" sz="1800" dirty="0">
+                <a:solidFill>
+                  <a:srgbClr val="1D232B"/>
+                </a:solidFill>
+                <a:latin typeface="Arial" pitchFamily="34" charset="0"/>
+                <a:ea typeface="Arial" pitchFamily="34" charset="-122"/>
+                <a:cs typeface="Arial" pitchFamily="34" charset="-120"/>
+              </a:rPr>
+              <a:t>The most interesting feature is not generation by itself, but generation inside a loop of testing and selection.</a:t>
+            </a:r>
+            <a:endParaRPr lang="en-US" sz="1800" dirty="0"/>
+          </a:p>
+        </p:txBody>
+      </p:sp>
+      <p:sp>
+        <p:nvSpPr>
+          <p:cNvPr id="6" name="Shape 4"/>
+          <p:cNvSpPr/>
+          <p:nvPr/>
+        </p:nvSpPr>
+        <p:spPr>
+          <a:xfrm>
+            <a:off x="868680" y="2788920"/>
+            <a:ext cx="5577840" cy="2514600"/>
           </a:xfrm>
           <a:prstGeom prst="rect">
             <a:avLst/>
           </a:prstGeom>
           <a:solidFill>
-            <a:srgbClr val="FFFFFF">
-              <a:alpha val="0"/>
-            </a:srgbClr>
+            <a:srgbClr val="FFFFFF"/>
           </a:solidFill>
           <a:ln w="12700">
             <a:solidFill>
@@ -7799,18 +7997,98 @@
       </p:sp>
       <p:sp>
         <p:nvSpPr>
-          <p:cNvPr id="7" name="Shape 4"/>
-          <p:cNvSpPr/>
-          <p:nvPr/>
-        </p:nvSpPr>
-        <p:spPr>
-          <a:xfrm>
-            <a:off x="6446520" y="1463040"/>
-            <a:ext cx="4800600" cy="2468880"/>
+          <p:cNvPr id="7" name="Text 5"/>
+          <p:cNvSpPr/>
+          <p:nvPr/>
+        </p:nvSpPr>
+        <p:spPr>
+          <a:xfrm>
+            <a:off x="1033272" y="2935224"/>
+            <a:ext cx="5248656" cy="182880"/>
+          </a:xfrm>
+          <a:prstGeom prst="rect">
+            <a:avLst/>
+          </a:prstGeom>
+          <a:noFill/>
+          <a:ln/>
+        </p:spPr>
+        <p:txBody>
+          <a:bodyPr wrap="square" lIns="0" tIns="0" rIns="0" bIns="0" rtlCol="0" anchor="ctr"/>
+          <a:lstStyle/>
+          <a:p>
+            <a:pPr indent="0" marL="0">
+              <a:buNone/>
+            </a:pPr>
+            <a:r>
+              <a:rPr lang="en-US" sz="1100" b="1" dirty="0">
+                <a:solidFill>
+                  <a:srgbClr val="6B7280"/>
+                </a:solidFill>
+                <a:latin typeface="Arial" pitchFamily="34" charset="0"/>
+                <a:ea typeface="Arial" pitchFamily="34" charset="-122"/>
+                <a:cs typeface="Arial" pitchFamily="34" charset="-120"/>
+              </a:rPr>
+              <a:t>Figure placeholder</a:t>
+            </a:r>
+            <a:endParaRPr lang="en-US" sz="1100" dirty="0"/>
+          </a:p>
+        </p:txBody>
+      </p:sp>
+      <p:sp>
+        <p:nvSpPr>
+          <p:cNvPr id="8" name="Text 6"/>
+          <p:cNvSpPr/>
+          <p:nvPr/>
+        </p:nvSpPr>
+        <p:spPr>
+          <a:xfrm>
+            <a:off x="1033272" y="3200400"/>
+            <a:ext cx="5248656" cy="1892808"/>
+          </a:xfrm>
+          <a:prstGeom prst="rect">
+            <a:avLst/>
+          </a:prstGeom>
+          <a:noFill/>
+          <a:ln/>
+        </p:spPr>
+        <p:txBody>
+          <a:bodyPr wrap="square" lIns="635" tIns="635" rIns="635" bIns="635" rtlCol="0" anchor="ctr">
+            <a:normAutofit/>
+          </a:bodyPr>
+          <a:lstStyle/>
+          <a:p>
+            <a:pPr algn="ctr" indent="0" marL="0">
+              <a:buNone/>
+            </a:pPr>
+            <a:r>
+              <a:rPr lang="en-US" sz="1600" i="1" dirty="0">
+                <a:solidFill>
+                  <a:srgbClr val="6B7280"/>
+                </a:solidFill>
+                <a:latin typeface="Arial" pitchFamily="34" charset="0"/>
+                <a:ea typeface="Arial" pitchFamily="34" charset="-122"/>
+                <a:cs typeface="Arial" pitchFamily="34" charset="-120"/>
+              </a:rPr>
+              <a:t>Insert AlphaEvolve results figure</a:t>
+            </a:r>
+            <a:endParaRPr lang="en-US" sz="1600" dirty="0"/>
+          </a:p>
+        </p:txBody>
+      </p:sp>
+      <p:sp>
+        <p:nvSpPr>
+          <p:cNvPr id="9" name="Shape 7"/>
+          <p:cNvSpPr/>
+          <p:nvPr/>
+        </p:nvSpPr>
+        <p:spPr>
+          <a:xfrm>
+            <a:off x="6720840" y="2788920"/>
+            <a:ext cx="4297680" cy="2514600"/>
           </a:xfrm>
           <a:prstGeom prst="roundRect">
             <a:avLst>
-              <a:gd name="adj" fmla="val 2963"/>
+              <a:gd name="adj" fmla="val 2909"/>
             </a:avLst>
           </a:prstGeom>
           <a:solidFill>
@@ -7826,14 +8104,14 @@
       </p:sp>
       <p:sp>
         <p:nvSpPr>
-          <p:cNvPr id="8" name="Text 5"/>
-          <p:cNvSpPr/>
-          <p:nvPr/>
-        </p:nvSpPr>
-        <p:spPr>
-          <a:xfrm>
-            <a:off x="6611112" y="1591056"/>
-            <a:ext cx="4471416" cy="237744"/>
+          <p:cNvPr id="10" name="Text 8"/>
+          <p:cNvSpPr/>
+          <p:nvPr/>
+        </p:nvSpPr>
+        <p:spPr>
+          <a:xfrm>
+            <a:off x="6885432" y="2916936"/>
+            <a:ext cx="3968496" cy="237744"/>
           </a:xfrm>
           <a:prstGeom prst="rect">
             <a:avLst/>
@@ -7865,14 +8143,14 @@
       </p:sp>
       <p:sp>
         <p:nvSpPr>
-          <p:cNvPr id="9" name="Text 6"/>
-          <p:cNvSpPr/>
-          <p:nvPr/>
-        </p:nvSpPr>
-        <p:spPr>
-          <a:xfrm>
-            <a:off x="6611112" y="1901952"/>
-            <a:ext cx="4471416" cy="1938528"/>
+          <p:cNvPr id="11" name="Text 9"/>
+          <p:cNvSpPr/>
+          <p:nvPr/>
+        </p:nvSpPr>
+        <p:spPr>
+          <a:xfrm>
+            <a:off x="6885432" y="3227832"/>
+            <a:ext cx="3968496" cy="1984248"/>
           </a:xfrm>
           <a:prstGeom prst="rect">
             <a:avLst/>
@@ -7940,14 +8218,14 @@
       </p:sp>
       <p:sp>
         <p:nvSpPr>
-          <p:cNvPr id="10" name="Text 7"/>
-          <p:cNvSpPr/>
-          <p:nvPr/>
-        </p:nvSpPr>
-        <p:spPr>
-          <a:xfrm>
-            <a:off x="6537960" y="4251960"/>
-            <a:ext cx="4480560" cy="822960"/>
+          <p:cNvPr id="12" name="Text 10"/>
+          <p:cNvSpPr/>
+          <p:nvPr/>
+        </p:nvSpPr>
+        <p:spPr>
+          <a:xfrm>
+            <a:off x="868680" y="5440680"/>
+            <a:ext cx="9966960" cy="411480"/>
           </a:xfrm>
           <a:prstGeom prst="rect">
             <a:avLst/>
@@ -8886,8 +9164,8 @@
         </p:nvSpPr>
         <p:spPr>
           <a:xfrm>
-            <a:off x="868680" y="1371600"/>
-            <a:ext cx="7406640" cy="2560320"/>
+            <a:off x="868680" y="1417320"/>
+            <a:ext cx="9784080" cy="2560320"/>
           </a:xfrm>
           <a:prstGeom prst="rect">
             <a:avLst/>
@@ -10792,47 +11070,97 @@
           </a:p>
         </p:txBody>
       </p:sp>
-      <p:pic>
-        <p:nvPicPr>
-          <p:cNvPr id="5" name="Image 0" descr="/home/matt.linux/talks/2026/oregon/assets/raw-images/urban-paper-01.png">    </p:cNvPr>
-          <p:cNvPicPr>
-            <a:picLocks noChangeAspect="1"/>
-          </p:cNvPicPr>
-          <p:nvPr/>
-        </p:nvPicPr>
-        <p:blipFill>
-          <a:blip r:embed="rId1"/>
-          <a:srcRect l="0" r="0" t="0" b="0"/>
-          <a:stretch/>
-        </p:blipFill>
-        <p:spPr>
-          <a:xfrm>
-            <a:off x="868680" y="1325880"/>
-            <a:ext cx="5486400" cy="3840480"/>
-          </a:xfrm>
-          <a:prstGeom prst="rect">
-            <a:avLst/>
-          </a:prstGeom>
-        </p:spPr>
-      </p:pic>
-      <p:sp>
-        <p:nvSpPr>
-          <p:cNvPr id="6" name="Shape 3"/>
-          <p:cNvSpPr/>
-          <p:nvPr/>
-        </p:nvSpPr>
-        <p:spPr>
-          <a:xfrm>
-            <a:off x="868680" y="1325880"/>
-            <a:ext cx="5486400" cy="3840480"/>
+      <p:sp>
+        <p:nvSpPr>
+          <p:cNvPr id="5" name="Text 3"/>
+          <p:cNvSpPr/>
+          <p:nvPr/>
+        </p:nvSpPr>
+        <p:spPr>
+          <a:xfrm>
+            <a:off x="868680" y="1371600"/>
+            <a:ext cx="10058400" cy="1417320"/>
+          </a:xfrm>
+          <a:prstGeom prst="rect">
+            <a:avLst/>
+          </a:prstGeom>
+          <a:noFill/>
+          <a:ln/>
+        </p:spPr>
+        <p:txBody>
+          <a:bodyPr wrap="square" lIns="381" tIns="381" rIns="381" bIns="381" rtlCol="0" anchor="t">
+            <a:normAutofit/>
+          </a:bodyPr>
+          <a:lstStyle/>
+          <a:p>
+            <a:pPr indent="0" marL="0">
+              <a:buNone/>
+            </a:pPr>
+            <a:r>
+              <a:rPr lang="en-US" sz="1800" dirty="0">
+                <a:solidFill>
+                  <a:srgbClr val="1D232B"/>
+                </a:solidFill>
+                <a:latin typeface="Arial" pitchFamily="34" charset="0"/>
+                <a:ea typeface="Arial" pitchFamily="34" charset="-122"/>
+                <a:cs typeface="Arial" pitchFamily="34" charset="-120"/>
+              </a:rPr>
+              <a:t>This is one of the clearest recent demonstrations of serious autoformalization.</a:t>
+            </a:r>
+            <a:endParaRPr lang="en-US" sz="1800" dirty="0"/>
+          </a:p>
+          <a:p>
+            <a:pPr indent="0" marL="0">
+              <a:buNone/>
+            </a:pPr>
+            <a:r>
+              <a:rPr lang="en-US" sz="1800" dirty="0">
+                <a:solidFill>
+                  <a:srgbClr val="1D232B"/>
+                </a:solidFill>
+                <a:latin typeface="Arial" pitchFamily="34" charset="0"/>
+                <a:ea typeface="Arial" pitchFamily="34" charset="-122"/>
+                <a:cs typeface="Arial" pitchFamily="34" charset="-120"/>
+              </a:rPr>
+              <a:t>The workflow is no longer merely aspirational.</a:t>
+            </a:r>
+            <a:endParaRPr lang="en-US" sz="1800" dirty="0"/>
+          </a:p>
+          <a:p>
+            <a:pPr indent="0" marL="0">
+              <a:buNone/>
+            </a:pPr>
+            <a:r>
+              <a:rPr lang="en-US" sz="1800" dirty="0">
+                <a:solidFill>
+                  <a:srgbClr val="1D232B"/>
+                </a:solidFill>
+                <a:latin typeface="Arial" pitchFamily="34" charset="0"/>
+                <a:ea typeface="Arial" pitchFamily="34" charset="-122"/>
+                <a:cs typeface="Arial" pitchFamily="34" charset="-120"/>
+              </a:rPr>
+              <a:t>Strong models can now support a substantial formalization loop.</a:t>
+            </a:r>
+            <a:endParaRPr lang="en-US" sz="1800" dirty="0"/>
+          </a:p>
+        </p:txBody>
+      </p:sp>
+      <p:sp>
+        <p:nvSpPr>
+          <p:cNvPr id="6" name="Shape 4"/>
+          <p:cNvSpPr/>
+          <p:nvPr/>
+        </p:nvSpPr>
+        <p:spPr>
+          <a:xfrm>
+            <a:off x="868680" y="3017520"/>
+            <a:ext cx="10149840" cy="2148840"/>
           </a:xfrm>
           <a:prstGeom prst="rect">
             <a:avLst/>
           </a:prstGeom>
           <a:solidFill>
-            <a:srgbClr val="FFFFFF">
-              <a:alpha val="0"/>
-            </a:srgbClr>
+            <a:srgbClr val="FFFFFF"/>
           </a:solidFill>
           <a:ln w="12700">
             <a:solidFill>
@@ -10844,89 +11172,94 @@
       </p:sp>
       <p:sp>
         <p:nvSpPr>
-          <p:cNvPr id="7" name="Text 4"/>
-          <p:cNvSpPr/>
-          <p:nvPr/>
-        </p:nvSpPr>
-        <p:spPr>
-          <a:xfrm>
-            <a:off x="6583680" y="1463040"/>
-            <a:ext cx="4617720" cy="2743200"/>
-          </a:xfrm>
-          <a:prstGeom prst="rect">
-            <a:avLst/>
-          </a:prstGeom>
-          <a:noFill/>
-          <a:ln/>
-        </p:spPr>
-        <p:txBody>
-          <a:bodyPr wrap="square" lIns="381" tIns="381" rIns="381" bIns="381" rtlCol="0" anchor="t">
+          <p:cNvPr id="7" name="Text 5"/>
+          <p:cNvSpPr/>
+          <p:nvPr/>
+        </p:nvSpPr>
+        <p:spPr>
+          <a:xfrm>
+            <a:off x="1033272" y="3163824"/>
+            <a:ext cx="9820656" cy="182880"/>
+          </a:xfrm>
+          <a:prstGeom prst="rect">
+            <a:avLst/>
+          </a:prstGeom>
+          <a:noFill/>
+          <a:ln/>
+        </p:spPr>
+        <p:txBody>
+          <a:bodyPr wrap="square" lIns="0" tIns="0" rIns="0" bIns="0" rtlCol="0" anchor="ctr"/>
+          <a:lstStyle/>
+          <a:p>
+            <a:pPr indent="0" marL="0">
+              <a:buNone/>
+            </a:pPr>
+            <a:r>
+              <a:rPr lang="en-US" sz="1100" b="1" dirty="0">
+                <a:solidFill>
+                  <a:srgbClr val="6B7280"/>
+                </a:solidFill>
+                <a:latin typeface="Arial" pitchFamily="34" charset="0"/>
+                <a:ea typeface="Arial" pitchFamily="34" charset="-122"/>
+                <a:cs typeface="Arial" pitchFamily="34" charset="-120"/>
+              </a:rPr>
+              <a:t>Figure placeholder</a:t>
+            </a:r>
+            <a:endParaRPr lang="en-US" sz="1100" dirty="0"/>
+          </a:p>
+        </p:txBody>
+      </p:sp>
+      <p:sp>
+        <p:nvSpPr>
+          <p:cNvPr id="8" name="Text 6"/>
+          <p:cNvSpPr/>
+          <p:nvPr/>
+        </p:nvSpPr>
+        <p:spPr>
+          <a:xfrm>
+            <a:off x="1033272" y="3429000"/>
+            <a:ext cx="9820656" cy="1527048"/>
+          </a:xfrm>
+          <a:prstGeom prst="rect">
+            <a:avLst/>
+          </a:prstGeom>
+          <a:noFill/>
+          <a:ln/>
+        </p:spPr>
+        <p:txBody>
+          <a:bodyPr wrap="square" lIns="635" tIns="635" rIns="635" bIns="635" rtlCol="0" anchor="ctr">
             <a:normAutofit/>
           </a:bodyPr>
           <a:lstStyle/>
           <a:p>
-            <a:pPr indent="0" marL="0">
-              <a:buNone/>
-            </a:pPr>
-            <a:r>
-              <a:rPr lang="en-US" sz="1800" dirty="0">
-                <a:solidFill>
-                  <a:srgbClr val="1D232B"/>
-                </a:solidFill>
-                <a:latin typeface="Arial" pitchFamily="34" charset="0"/>
-                <a:ea typeface="Arial" pitchFamily="34" charset="-122"/>
-                <a:cs typeface="Arial" pitchFamily="34" charset="-120"/>
-              </a:rPr>
-              <a:t>This is one of the clearest recent demonstrations of serious autoformalization.</a:t>
-            </a:r>
-            <a:endParaRPr lang="en-US" sz="1800" dirty="0"/>
-          </a:p>
-          <a:p>
-            <a:pPr indent="0" marL="0">
-              <a:buNone/>
-            </a:pPr>
-            <a:r>
-              <a:rPr lang="en-US" sz="1800" dirty="0">
-                <a:solidFill>
-                  <a:srgbClr val="1D232B"/>
-                </a:solidFill>
-                <a:latin typeface="Arial" pitchFamily="34" charset="0"/>
-                <a:ea typeface="Arial" pitchFamily="34" charset="-122"/>
-                <a:cs typeface="Arial" pitchFamily="34" charset="-120"/>
-              </a:rPr>
-              <a:t>The workflow is no longer merely aspirational.</a:t>
-            </a:r>
-            <a:endParaRPr lang="en-US" sz="1800" dirty="0"/>
-          </a:p>
-          <a:p>
-            <a:pPr indent="0" marL="0">
-              <a:buNone/>
-            </a:pPr>
-            <a:r>
-              <a:rPr lang="en-US" sz="1800" dirty="0">
-                <a:solidFill>
-                  <a:srgbClr val="1D232B"/>
-                </a:solidFill>
-                <a:latin typeface="Arial" pitchFamily="34" charset="0"/>
-                <a:ea typeface="Arial" pitchFamily="34" charset="-122"/>
-                <a:cs typeface="Arial" pitchFamily="34" charset="-120"/>
-              </a:rPr>
-              <a:t>Strong models can now support a substantial formalization loop.</a:t>
-            </a:r>
-            <a:endParaRPr lang="en-US" sz="1800" dirty="0"/>
-          </a:p>
-        </p:txBody>
-      </p:sp>
-      <p:sp>
-        <p:nvSpPr>
-          <p:cNvPr id="8" name="Text 5"/>
-          <p:cNvSpPr/>
-          <p:nvPr/>
-        </p:nvSpPr>
-        <p:spPr>
-          <a:xfrm>
-            <a:off x="868680" y="5285232"/>
-            <a:ext cx="5669280" cy="219456"/>
+            <a:pPr algn="ctr" indent="0" marL="0">
+              <a:buNone/>
+            </a:pPr>
+            <a:r>
+              <a:rPr lang="en-US" sz="1600" i="1" dirty="0">
+                <a:solidFill>
+                  <a:srgbClr val="6B7280"/>
+                </a:solidFill>
+                <a:latin typeface="Arial" pitchFamily="34" charset="0"/>
+                <a:ea typeface="Arial" pitchFamily="34" charset="-122"/>
+                <a:cs typeface="Arial" pitchFamily="34" charset="-120"/>
+              </a:rPr>
+              <a:t>Insert Urban / Megalodon figure or workflow image</a:t>
+            </a:r>
+            <a:endParaRPr lang="en-US" sz="1600" dirty="0"/>
+          </a:p>
+        </p:txBody>
+      </p:sp>
+      <p:sp>
+        <p:nvSpPr>
+          <p:cNvPr id="9" name="Text 7"/>
+          <p:cNvSpPr/>
+          <p:nvPr/>
+        </p:nvSpPr>
+        <p:spPr>
+          <a:xfrm>
+            <a:off x="868680" y="5413248"/>
+            <a:ext cx="6400800" cy="219456"/>
           </a:xfrm>
           <a:prstGeom prst="rect">
             <a:avLst/>
@@ -11089,47 +11422,97 @@
           </a:p>
         </p:txBody>
       </p:sp>
-      <p:pic>
-        <p:nvPicPr>
-          <p:cNvPr id="5" name="Image 0" descr="/home/matt.linux/talks/2026/oregon/assets/raw-images/math-inc-sphere-packing-og.png">    </p:cNvPr>
-          <p:cNvPicPr>
-            <a:picLocks noChangeAspect="1"/>
-          </p:cNvPicPr>
-          <p:nvPr/>
-        </p:nvPicPr>
-        <p:blipFill>
-          <a:blip r:embed="rId1"/>
-          <a:srcRect l="0" r="0" t="0" b="0"/>
-          <a:stretch/>
-        </p:blipFill>
-        <p:spPr>
-          <a:xfrm>
-            <a:off x="868680" y="1325880"/>
-            <a:ext cx="5486400" cy="3840480"/>
-          </a:xfrm>
-          <a:prstGeom prst="rect">
-            <a:avLst/>
-          </a:prstGeom>
-        </p:spPr>
-      </p:pic>
-      <p:sp>
-        <p:nvSpPr>
-          <p:cNvPr id="6" name="Shape 3"/>
-          <p:cNvSpPr/>
-          <p:nvPr/>
-        </p:nvSpPr>
-        <p:spPr>
-          <a:xfrm>
-            <a:off x="868680" y="1325880"/>
-            <a:ext cx="5486400" cy="3840480"/>
+      <p:sp>
+        <p:nvSpPr>
+          <p:cNvPr id="5" name="Text 3"/>
+          <p:cNvSpPr/>
+          <p:nvPr/>
+        </p:nvSpPr>
+        <p:spPr>
+          <a:xfrm>
+            <a:off x="868680" y="1371600"/>
+            <a:ext cx="10058400" cy="1417320"/>
+          </a:xfrm>
+          <a:prstGeom prst="rect">
+            <a:avLst/>
+          </a:prstGeom>
+          <a:noFill/>
+          <a:ln/>
+        </p:spPr>
+        <p:txBody>
+          <a:bodyPr wrap="square" lIns="381" tIns="381" rIns="381" bIns="381" rtlCol="0" anchor="t">
+            <a:normAutofit/>
+          </a:bodyPr>
+          <a:lstStyle/>
+          <a:p>
+            <a:pPr indent="0" marL="0">
+              <a:buNone/>
+            </a:pPr>
+            <a:r>
+              <a:rPr lang="en-US" sz="1800" dirty="0">
+                <a:solidFill>
+                  <a:srgbClr val="1D232B"/>
+                </a:solidFill>
+                <a:latin typeface="Arial" pitchFamily="34" charset="0"/>
+                <a:ea typeface="Arial" pitchFamily="34" charset="-122"/>
+                <a:cs typeface="Arial" pitchFamily="34" charset="-120"/>
+              </a:rPr>
+              <a:t>These examples are striking because they are mathematically recognizable</a:t>
+            </a:r>
+            <a:endParaRPr lang="en-US" sz="1800" dirty="0"/>
+          </a:p>
+          <a:p>
+            <a:pPr indent="0" marL="0">
+              <a:buNone/>
+            </a:pPr>
+            <a:r>
+              <a:rPr lang="en-US" sz="1800" dirty="0">
+                <a:solidFill>
+                  <a:srgbClr val="1D232B"/>
+                </a:solidFill>
+                <a:latin typeface="Arial" pitchFamily="34" charset="0"/>
+                <a:ea typeface="Arial" pitchFamily="34" charset="-122"/>
+                <a:cs typeface="Arial" pitchFamily="34" charset="-120"/>
+              </a:rPr>
+              <a:t>and because the outputs are not just prose but formal artifacts.</a:t>
+            </a:r>
+            <a:endParaRPr lang="en-US" sz="1800" dirty="0"/>
+          </a:p>
+          <a:p>
+            <a:pPr indent="0" marL="0">
+              <a:buNone/>
+            </a:pPr>
+            <a:r>
+              <a:rPr lang="en-US" sz="1800" dirty="0">
+                <a:solidFill>
+                  <a:srgbClr val="1D232B"/>
+                </a:solidFill>
+                <a:latin typeface="Arial" pitchFamily="34" charset="0"/>
+                <a:ea typeface="Arial" pitchFamily="34" charset="-122"/>
+                <a:cs typeface="Arial" pitchFamily="34" charset="-120"/>
+              </a:rPr>
+              <a:t>They make the promise of autoformalization more concrete.</a:t>
+            </a:r>
+            <a:endParaRPr lang="en-US" sz="1800" dirty="0"/>
+          </a:p>
+        </p:txBody>
+      </p:sp>
+      <p:sp>
+        <p:nvSpPr>
+          <p:cNvPr id="6" name="Shape 4"/>
+          <p:cNvSpPr/>
+          <p:nvPr/>
+        </p:nvSpPr>
+        <p:spPr>
+          <a:xfrm>
+            <a:off x="868680" y="3017520"/>
+            <a:ext cx="10149840" cy="2148840"/>
           </a:xfrm>
           <a:prstGeom prst="rect">
             <a:avLst/>
           </a:prstGeom>
           <a:solidFill>
-            <a:srgbClr val="FFFFFF">
-              <a:alpha val="0"/>
-            </a:srgbClr>
+            <a:srgbClr val="FFFFFF"/>
           </a:solidFill>
           <a:ln w="12700">
             <a:solidFill>
@@ -11141,89 +11524,94 @@
       </p:sp>
       <p:sp>
         <p:nvSpPr>
-          <p:cNvPr id="7" name="Text 4"/>
-          <p:cNvSpPr/>
-          <p:nvPr/>
-        </p:nvSpPr>
-        <p:spPr>
-          <a:xfrm>
-            <a:off x="6583680" y="1463040"/>
-            <a:ext cx="4617720" cy="2743200"/>
-          </a:xfrm>
-          <a:prstGeom prst="rect">
-            <a:avLst/>
-          </a:prstGeom>
-          <a:noFill/>
-          <a:ln/>
-        </p:spPr>
-        <p:txBody>
-          <a:bodyPr wrap="square" lIns="381" tIns="381" rIns="381" bIns="381" rtlCol="0" anchor="t">
+          <p:cNvPr id="7" name="Text 5"/>
+          <p:cNvSpPr/>
+          <p:nvPr/>
+        </p:nvSpPr>
+        <p:spPr>
+          <a:xfrm>
+            <a:off x="1033272" y="3163824"/>
+            <a:ext cx="9820656" cy="182880"/>
+          </a:xfrm>
+          <a:prstGeom prst="rect">
+            <a:avLst/>
+          </a:prstGeom>
+          <a:noFill/>
+          <a:ln/>
+        </p:spPr>
+        <p:txBody>
+          <a:bodyPr wrap="square" lIns="0" tIns="0" rIns="0" bIns="0" rtlCol="0" anchor="ctr"/>
+          <a:lstStyle/>
+          <a:p>
+            <a:pPr indent="0" marL="0">
+              <a:buNone/>
+            </a:pPr>
+            <a:r>
+              <a:rPr lang="en-US" sz="1100" b="1" dirty="0">
+                <a:solidFill>
+                  <a:srgbClr val="6B7280"/>
+                </a:solidFill>
+                <a:latin typeface="Arial" pitchFamily="34" charset="0"/>
+                <a:ea typeface="Arial" pitchFamily="34" charset="-122"/>
+                <a:cs typeface="Arial" pitchFamily="34" charset="-120"/>
+              </a:rPr>
+              <a:t>Figure placeholder</a:t>
+            </a:r>
+            <a:endParaRPr lang="en-US" sz="1100" dirty="0"/>
+          </a:p>
+        </p:txBody>
+      </p:sp>
+      <p:sp>
+        <p:nvSpPr>
+          <p:cNvPr id="8" name="Text 6"/>
+          <p:cNvSpPr/>
+          <p:nvPr/>
+        </p:nvSpPr>
+        <p:spPr>
+          <a:xfrm>
+            <a:off x="1033272" y="3429000"/>
+            <a:ext cx="9820656" cy="1527048"/>
+          </a:xfrm>
+          <a:prstGeom prst="rect">
+            <a:avLst/>
+          </a:prstGeom>
+          <a:noFill/>
+          <a:ln/>
+        </p:spPr>
+        <p:txBody>
+          <a:bodyPr wrap="square" lIns="635" tIns="635" rIns="635" bIns="635" rtlCol="0" anchor="ctr">
             <a:normAutofit/>
           </a:bodyPr>
           <a:lstStyle/>
           <a:p>
-            <a:pPr indent="0" marL="0">
-              <a:buNone/>
-            </a:pPr>
-            <a:r>
-              <a:rPr lang="en-US" sz="1800" dirty="0">
-                <a:solidFill>
-                  <a:srgbClr val="1D232B"/>
-                </a:solidFill>
-                <a:latin typeface="Arial" pitchFamily="34" charset="0"/>
-                <a:ea typeface="Arial" pitchFamily="34" charset="-122"/>
-                <a:cs typeface="Arial" pitchFamily="34" charset="-120"/>
-              </a:rPr>
-              <a:t>These examples are striking because they are mathematically recognizable</a:t>
-            </a:r>
-            <a:endParaRPr lang="en-US" sz="1800" dirty="0"/>
-          </a:p>
-          <a:p>
-            <a:pPr indent="0" marL="0">
-              <a:buNone/>
-            </a:pPr>
-            <a:r>
-              <a:rPr lang="en-US" sz="1800" dirty="0">
-                <a:solidFill>
-                  <a:srgbClr val="1D232B"/>
-                </a:solidFill>
-                <a:latin typeface="Arial" pitchFamily="34" charset="0"/>
-                <a:ea typeface="Arial" pitchFamily="34" charset="-122"/>
-                <a:cs typeface="Arial" pitchFamily="34" charset="-120"/>
-              </a:rPr>
-              <a:t>and because the outputs are not just prose but formal artifacts.</a:t>
-            </a:r>
-            <a:endParaRPr lang="en-US" sz="1800" dirty="0"/>
-          </a:p>
-          <a:p>
-            <a:pPr indent="0" marL="0">
-              <a:buNone/>
-            </a:pPr>
-            <a:r>
-              <a:rPr lang="en-US" sz="1800" dirty="0">
-                <a:solidFill>
-                  <a:srgbClr val="1D232B"/>
-                </a:solidFill>
-                <a:latin typeface="Arial" pitchFamily="34" charset="0"/>
-                <a:ea typeface="Arial" pitchFamily="34" charset="-122"/>
-                <a:cs typeface="Arial" pitchFamily="34" charset="-120"/>
-              </a:rPr>
-              <a:t>They make the promise of autoformalization more concrete.</a:t>
-            </a:r>
-            <a:endParaRPr lang="en-US" sz="1800" dirty="0"/>
-          </a:p>
-        </p:txBody>
-      </p:sp>
-      <p:sp>
-        <p:nvSpPr>
-          <p:cNvPr id="8" name="Text 5"/>
-          <p:cNvSpPr/>
-          <p:nvPr/>
-        </p:nvSpPr>
-        <p:spPr>
-          <a:xfrm>
-            <a:off x="868680" y="5285232"/>
-            <a:ext cx="5943600" cy="219456"/>
+            <a:pPr algn="ctr" indent="0" marL="0">
+              <a:buNone/>
+            </a:pPr>
+            <a:r>
+              <a:rPr lang="en-US" sz="1600" i="1" dirty="0">
+                <a:solidFill>
+                  <a:srgbClr val="6B7280"/>
+                </a:solidFill>
+                <a:latin typeface="Arial" pitchFamily="34" charset="0"/>
+                <a:ea typeface="Arial" pitchFamily="34" charset="-122"/>
+                <a:cs typeface="Arial" pitchFamily="34" charset="-120"/>
+              </a:rPr>
+              <a:t>Insert Gauss / sphere-packing formalization image</a:t>
+            </a:r>
+            <a:endParaRPr lang="en-US" sz="1600" dirty="0"/>
+          </a:p>
+        </p:txBody>
+      </p:sp>
+      <p:sp>
+        <p:nvSpPr>
+          <p:cNvPr id="9" name="Text 7"/>
+          <p:cNvSpPr/>
+          <p:nvPr/>
+        </p:nvSpPr>
+        <p:spPr>
+          <a:xfrm>
+            <a:off x="868680" y="5413248"/>
+            <a:ext cx="6583680" cy="219456"/>
           </a:xfrm>
           <a:prstGeom prst="rect">
             <a:avLst/>
@@ -11386,47 +11774,22 @@
           </a:p>
         </p:txBody>
       </p:sp>
-      <p:pic>
-        <p:nvPicPr>
-          <p:cNvPr id="5" name="Image 0" descr="/home/matt.linux/talks/2026/oregon/assets/raw-images/m2f-fig1-02.png">    </p:cNvPr>
-          <p:cNvPicPr>
-            <a:picLocks noChangeAspect="1"/>
-          </p:cNvPicPr>
-          <p:nvPr/>
-        </p:nvPicPr>
-        <p:blipFill>
-          <a:blip r:embed="rId1"/>
-          <a:srcRect l="0" r="0" t="0" b="0"/>
-          <a:stretch/>
-        </p:blipFill>
-        <p:spPr>
-          <a:xfrm>
-            <a:off x="868680" y="1508760"/>
+      <p:sp>
+        <p:nvSpPr>
+          <p:cNvPr id="5" name="Shape 3"/>
+          <p:cNvSpPr/>
+          <p:nvPr/>
+        </p:nvSpPr>
+        <p:spPr>
+          <a:xfrm>
+            <a:off x="868680" y="1645920"/>
             <a:ext cx="3474720" cy="2286000"/>
           </a:xfrm>
           <a:prstGeom prst="rect">
             <a:avLst/>
           </a:prstGeom>
-        </p:spPr>
-      </p:pic>
-      <p:sp>
-        <p:nvSpPr>
-          <p:cNvPr id="6" name="Shape 3"/>
-          <p:cNvSpPr/>
-          <p:nvPr/>
-        </p:nvSpPr>
-        <p:spPr>
-          <a:xfrm>
-            <a:off x="868680" y="1508760"/>
-            <a:ext cx="3474720" cy="2286000"/>
-          </a:xfrm>
-          <a:prstGeom prst="rect">
-            <a:avLst/>
-          </a:prstGeom>
           <a:solidFill>
-            <a:srgbClr val="FFFFFF">
-              <a:alpha val="0"/>
-            </a:srgbClr>
+            <a:srgbClr val="FFFFFF"/>
           </a:solidFill>
           <a:ln w="12700">
             <a:solidFill>
@@ -11436,47 +11799,102 @@
           </a:ln>
         </p:spPr>
       </p:sp>
-      <p:pic>
-        <p:nvPicPr>
-          <p:cNvPr id="7" name="Image 1" descr="/home/matt.linux/talks/2026/oregon/assets/raw-images/archon-firstproof-og.jpg">    </p:cNvPr>
-          <p:cNvPicPr>
-            <a:picLocks noChangeAspect="1"/>
-          </p:cNvPicPr>
-          <p:nvPr/>
-        </p:nvPicPr>
-        <p:blipFill>
-          <a:blip r:embed="rId2"/>
-          <a:srcRect l="0" r="0" t="0" b="0"/>
-          <a:stretch/>
-        </p:blipFill>
-        <p:spPr>
-          <a:xfrm>
-            <a:off x="4553712" y="1508760"/>
+      <p:sp>
+        <p:nvSpPr>
+          <p:cNvPr id="6" name="Text 4"/>
+          <p:cNvSpPr/>
+          <p:nvPr/>
+        </p:nvSpPr>
+        <p:spPr>
+          <a:xfrm>
+            <a:off x="1033272" y="1792224"/>
+            <a:ext cx="3145536" cy="182880"/>
+          </a:xfrm>
+          <a:prstGeom prst="rect">
+            <a:avLst/>
+          </a:prstGeom>
+          <a:noFill/>
+          <a:ln/>
+        </p:spPr>
+        <p:txBody>
+          <a:bodyPr wrap="square" lIns="0" tIns="0" rIns="0" bIns="0" rtlCol="0" anchor="ctr"/>
+          <a:lstStyle/>
+          <a:p>
+            <a:pPr indent="0" marL="0">
+              <a:buNone/>
+            </a:pPr>
+            <a:r>
+              <a:rPr lang="en-US" sz="1100" b="1" dirty="0">
+                <a:solidFill>
+                  <a:srgbClr val="6B7280"/>
+                </a:solidFill>
+                <a:latin typeface="Arial" pitchFamily="34" charset="0"/>
+                <a:ea typeface="Arial" pitchFamily="34" charset="-122"/>
+                <a:cs typeface="Arial" pitchFamily="34" charset="-120"/>
+              </a:rPr>
+              <a:t>Figure placeholder</a:t>
+            </a:r>
+            <a:endParaRPr lang="en-US" sz="1100" dirty="0"/>
+          </a:p>
+        </p:txBody>
+      </p:sp>
+      <p:sp>
+        <p:nvSpPr>
+          <p:cNvPr id="7" name="Text 5"/>
+          <p:cNvSpPr/>
+          <p:nvPr/>
+        </p:nvSpPr>
+        <p:spPr>
+          <a:xfrm>
+            <a:off x="1033272" y="2057400"/>
+            <a:ext cx="3145536" cy="1664208"/>
+          </a:xfrm>
+          <a:prstGeom prst="rect">
+            <a:avLst/>
+          </a:prstGeom>
+          <a:noFill/>
+          <a:ln/>
+        </p:spPr>
+        <p:txBody>
+          <a:bodyPr wrap="square" lIns="635" tIns="635" rIns="635" bIns="635" rtlCol="0" anchor="ctr">
+            <a:normAutofit/>
+          </a:bodyPr>
+          <a:lstStyle/>
+          <a:p>
+            <a:pPr algn="ctr" indent="0" marL="0">
+              <a:buNone/>
+            </a:pPr>
+            <a:r>
+              <a:rPr lang="en-US" sz="1600" i="1" dirty="0">
+                <a:solidFill>
+                  <a:srgbClr val="6B7280"/>
+                </a:solidFill>
+                <a:latin typeface="Arial" pitchFamily="34" charset="0"/>
+                <a:ea typeface="Arial" pitchFamily="34" charset="-122"/>
+                <a:cs typeface="Arial" pitchFamily="34" charset="-120"/>
+              </a:rPr>
+              <a:t>Insert M2F figure</a:t>
+            </a:r>
+            <a:endParaRPr lang="en-US" sz="1600" dirty="0"/>
+          </a:p>
+        </p:txBody>
+      </p:sp>
+      <p:sp>
+        <p:nvSpPr>
+          <p:cNvPr id="8" name="Shape 6"/>
+          <p:cNvSpPr/>
+          <p:nvPr/>
+        </p:nvSpPr>
+        <p:spPr>
+          <a:xfrm>
+            <a:off x="4572000" y="1645920"/>
             <a:ext cx="3474720" cy="2286000"/>
           </a:xfrm>
           <a:prstGeom prst="rect">
             <a:avLst/>
           </a:prstGeom>
-        </p:spPr>
-      </p:pic>
-      <p:sp>
-        <p:nvSpPr>
-          <p:cNvPr id="8" name="Shape 4"/>
-          <p:cNvSpPr/>
-          <p:nvPr/>
-        </p:nvSpPr>
-        <p:spPr>
-          <a:xfrm>
-            <a:off x="4553712" y="1508760"/>
-            <a:ext cx="3474720" cy="2286000"/>
-          </a:xfrm>
-          <a:prstGeom prst="rect">
-            <a:avLst/>
-          </a:prstGeom>
           <a:solidFill>
-            <a:srgbClr val="FFFFFF">
-              <a:alpha val="0"/>
-            </a:srgbClr>
+            <a:srgbClr val="FFFFFF"/>
           </a:solidFill>
           <a:ln w="12700">
             <a:solidFill>
@@ -11488,14 +11906,94 @@
       </p:sp>
       <p:sp>
         <p:nvSpPr>
-          <p:cNvPr id="9" name="Shape 5"/>
-          <p:cNvSpPr/>
-          <p:nvPr/>
-        </p:nvSpPr>
-        <p:spPr>
-          <a:xfrm>
-            <a:off x="8247888" y="1508760"/>
-            <a:ext cx="2697480" cy="2286000"/>
+          <p:cNvPr id="9" name="Text 7"/>
+          <p:cNvSpPr/>
+          <p:nvPr/>
+        </p:nvSpPr>
+        <p:spPr>
+          <a:xfrm>
+            <a:off x="4736592" y="1792224"/>
+            <a:ext cx="3145536" cy="182880"/>
+          </a:xfrm>
+          <a:prstGeom prst="rect">
+            <a:avLst/>
+          </a:prstGeom>
+          <a:noFill/>
+          <a:ln/>
+        </p:spPr>
+        <p:txBody>
+          <a:bodyPr wrap="square" lIns="0" tIns="0" rIns="0" bIns="0" rtlCol="0" anchor="ctr"/>
+          <a:lstStyle/>
+          <a:p>
+            <a:pPr indent="0" marL="0">
+              <a:buNone/>
+            </a:pPr>
+            <a:r>
+              <a:rPr lang="en-US" sz="1100" b="1" dirty="0">
+                <a:solidFill>
+                  <a:srgbClr val="6B7280"/>
+                </a:solidFill>
+                <a:latin typeface="Arial" pitchFamily="34" charset="0"/>
+                <a:ea typeface="Arial" pitchFamily="34" charset="-122"/>
+                <a:cs typeface="Arial" pitchFamily="34" charset="-120"/>
+              </a:rPr>
+              <a:t>Figure placeholder</a:t>
+            </a:r>
+            <a:endParaRPr lang="en-US" sz="1100" dirty="0"/>
+          </a:p>
+        </p:txBody>
+      </p:sp>
+      <p:sp>
+        <p:nvSpPr>
+          <p:cNvPr id="10" name="Text 8"/>
+          <p:cNvSpPr/>
+          <p:nvPr/>
+        </p:nvSpPr>
+        <p:spPr>
+          <a:xfrm>
+            <a:off x="4736592" y="2057400"/>
+            <a:ext cx="3145536" cy="1664208"/>
+          </a:xfrm>
+          <a:prstGeom prst="rect">
+            <a:avLst/>
+          </a:prstGeom>
+          <a:noFill/>
+          <a:ln/>
+        </p:spPr>
+        <p:txBody>
+          <a:bodyPr wrap="square" lIns="635" tIns="635" rIns="635" bIns="635" rtlCol="0" anchor="ctr">
+            <a:normAutofit/>
+          </a:bodyPr>
+          <a:lstStyle/>
+          <a:p>
+            <a:pPr algn="ctr" indent="0" marL="0">
+              <a:buNone/>
+            </a:pPr>
+            <a:r>
+              <a:rPr lang="en-US" sz="1600" i="1" dirty="0">
+                <a:solidFill>
+                  <a:srgbClr val="6B7280"/>
+                </a:solidFill>
+                <a:latin typeface="Arial" pitchFamily="34" charset="0"/>
+                <a:ea typeface="Arial" pitchFamily="34" charset="-122"/>
+                <a:cs typeface="Arial" pitchFamily="34" charset="-120"/>
+              </a:rPr>
+              <a:t>Insert Archon / First Proof figure</a:t>
+            </a:r>
+            <a:endParaRPr lang="en-US" sz="1600" dirty="0"/>
+          </a:p>
+        </p:txBody>
+      </p:sp>
+      <p:sp>
+        <p:nvSpPr>
+          <p:cNvPr id="11" name="Shape 9"/>
+          <p:cNvSpPr/>
+          <p:nvPr/>
+        </p:nvSpPr>
+        <p:spPr>
+          <a:xfrm>
+            <a:off x="8275320" y="1645920"/>
+            <a:ext cx="2743200" cy="2286000"/>
           </a:xfrm>
           <a:prstGeom prst="roundRect">
             <a:avLst>
@@ -11515,14 +12013,14 @@
       </p:sp>
       <p:sp>
         <p:nvSpPr>
-          <p:cNvPr id="10" name="Text 6"/>
-          <p:cNvSpPr/>
-          <p:nvPr/>
-        </p:nvSpPr>
-        <p:spPr>
-          <a:xfrm>
-            <a:off x="8412480" y="1636776"/>
-            <a:ext cx="2368296" cy="237744"/>
+          <p:cNvPr id="12" name="Text 10"/>
+          <p:cNvSpPr/>
+          <p:nvPr/>
+        </p:nvSpPr>
+        <p:spPr>
+          <a:xfrm>
+            <a:off x="8439912" y="1773936"/>
+            <a:ext cx="2414016" cy="237744"/>
           </a:xfrm>
           <a:prstGeom prst="rect">
             <a:avLst/>
@@ -11554,14 +12052,14 @@
       </p:sp>
       <p:sp>
         <p:nvSpPr>
-          <p:cNvPr id="11" name="Text 7"/>
-          <p:cNvSpPr/>
-          <p:nvPr/>
-        </p:nvSpPr>
-        <p:spPr>
-          <a:xfrm>
-            <a:off x="8412480" y="1947672"/>
-            <a:ext cx="2368296" cy="1755648"/>
+          <p:cNvPr id="13" name="Text 11"/>
+          <p:cNvSpPr/>
+          <p:nvPr/>
+        </p:nvSpPr>
+        <p:spPr>
+          <a:xfrm>
+            <a:off x="8439912" y="2084832"/>
+            <a:ext cx="2414016" cy="1755648"/>
           </a:xfrm>
           <a:prstGeom prst="rect">
             <a:avLst/>
@@ -11612,14 +12110,14 @@
       </p:sp>
       <p:sp>
         <p:nvSpPr>
-          <p:cNvPr id="12" name="Text 8"/>
-          <p:cNvSpPr/>
-          <p:nvPr/>
-        </p:nvSpPr>
-        <p:spPr>
-          <a:xfrm>
-            <a:off x="960120" y="4343400"/>
-            <a:ext cx="8046720" cy="868680"/>
+          <p:cNvPr id="14" name="Text 12"/>
+          <p:cNvSpPr/>
+          <p:nvPr/>
+        </p:nvSpPr>
+        <p:spPr>
+          <a:xfrm>
+            <a:off x="868680" y="4343400"/>
+            <a:ext cx="9875520" cy="868680"/>
           </a:xfrm>
           <a:prstGeom prst="rect">
             <a:avLst/>
@@ -12604,13 +13102,13 @@
         <p:spPr>
           <a:xfrm>
             <a:off x="868680" y="1325880"/>
-            <a:ext cx="5806440" cy="3703320"/>
-          </a:xfrm>
-          <a:prstGeom prst="roundRect">
+            <a:ext cx="10149840" cy="2514600"/>
+          </a:xfrm>
+          <a:prstGeom prst="rect">
             <a:avLst/>
           </a:prstGeom>
           <a:solidFill>
-            <a:srgbClr val="E7EEF2"/>
+            <a:srgbClr val="FFFFFF"/>
           </a:solidFill>
           <a:ln w="12700">
             <a:solidFill>
@@ -12628,8 +13126,47 @@
         </p:nvSpPr>
         <p:spPr>
           <a:xfrm>
-            <a:off x="1033272" y="1527048"/>
-            <a:ext cx="5477256" cy="3300984"/>
+            <a:off x="1033272" y="1472184"/>
+            <a:ext cx="9820656" cy="182880"/>
+          </a:xfrm>
+          <a:prstGeom prst="rect">
+            <a:avLst/>
+          </a:prstGeom>
+          <a:noFill/>
+          <a:ln/>
+        </p:spPr>
+        <p:txBody>
+          <a:bodyPr wrap="square" lIns="0" tIns="0" rIns="0" bIns="0" rtlCol="0" anchor="ctr"/>
+          <a:lstStyle/>
+          <a:p>
+            <a:pPr indent="0" marL="0">
+              <a:buNone/>
+            </a:pPr>
+            <a:r>
+              <a:rPr lang="en-US" sz="1100" b="1" dirty="0">
+                <a:solidFill>
+                  <a:srgbClr val="6B7280"/>
+                </a:solidFill>
+                <a:latin typeface="Arial" pitchFamily="34" charset="0"/>
+                <a:ea typeface="Arial" pitchFamily="34" charset="-122"/>
+                <a:cs typeface="Arial" pitchFamily="34" charset="-120"/>
+              </a:rPr>
+              <a:t>Figure placeholder</a:t>
+            </a:r>
+            <a:endParaRPr lang="en-US" sz="1100" dirty="0"/>
+          </a:p>
+        </p:txBody>
+      </p:sp>
+      <p:sp>
+        <p:nvSpPr>
+          <p:cNvPr id="7" name="Text 5"/>
+          <p:cNvSpPr/>
+          <p:nvPr/>
+        </p:nvSpPr>
+        <p:spPr>
+          <a:xfrm>
+            <a:off x="1033272" y="1737360"/>
+            <a:ext cx="9820656" cy="1892808"/>
           </a:xfrm>
           <a:prstGeom prst="rect">
             <a:avLst/>
@@ -12663,14 +13200,14 @@
       </p:sp>
       <p:sp>
         <p:nvSpPr>
-          <p:cNvPr id="7" name="Text 5"/>
-          <p:cNvSpPr/>
-          <p:nvPr/>
-        </p:nvSpPr>
-        <p:spPr>
-          <a:xfrm>
-            <a:off x="6903720" y="1463040"/>
-            <a:ext cx="4297680" cy="2743200"/>
+          <p:cNvPr id="8" name="Text 6"/>
+          <p:cNvSpPr/>
+          <p:nvPr/>
+        </p:nvSpPr>
+        <p:spPr>
+          <a:xfrm>
+            <a:off x="868680" y="4069080"/>
+            <a:ext cx="10058400" cy="1051560"/>
           </a:xfrm>
           <a:prstGeom prst="rect">
             <a:avLst/>
@@ -12738,13 +13275,13 @@
       </p:sp>
       <p:sp>
         <p:nvSpPr>
-          <p:cNvPr id="8" name="Shape 6"/>
-          <p:cNvSpPr/>
-          <p:nvPr/>
-        </p:nvSpPr>
-        <p:spPr>
-          <a:xfrm>
-            <a:off x="868680" y="5349240"/>
+          <p:cNvPr id="9" name="Shape 7"/>
+          <p:cNvSpPr/>
+          <p:nvPr/>
+        </p:nvSpPr>
+        <p:spPr>
+          <a:xfrm>
+            <a:off x="868680" y="5230368"/>
             <a:ext cx="10378440" cy="822960"/>
           </a:xfrm>
           <a:prstGeom prst="roundRect">
@@ -12765,13 +13302,13 @@
       </p:sp>
       <p:sp>
         <p:nvSpPr>
-          <p:cNvPr id="9" name="Text 7"/>
-          <p:cNvSpPr/>
-          <p:nvPr/>
-        </p:nvSpPr>
-        <p:spPr>
-          <a:xfrm>
-            <a:off x="1033272" y="5513832"/>
+          <p:cNvPr id="10" name="Text 8"/>
+          <p:cNvSpPr/>
+          <p:nvPr/>
+        </p:nvSpPr>
+        <p:spPr>
+          <a:xfrm>
+            <a:off x="1033272" y="5394960"/>
             <a:ext cx="10049256" cy="493776"/>
           </a:xfrm>
           <a:prstGeom prst="rect">
@@ -12945,8 +13482,8 @@
         </p:nvSpPr>
         <p:spPr>
           <a:xfrm>
-            <a:off x="868680" y="1371600"/>
-            <a:ext cx="8046720" cy="2743200"/>
+            <a:off x="868680" y="1417320"/>
+            <a:ext cx="9829800" cy="2560320"/>
           </a:xfrm>
           <a:prstGeom prst="rect">
             <a:avLst/>
@@ -13020,12 +13557,12 @@
         </p:nvSpPr>
         <p:spPr>
           <a:xfrm>
-            <a:off x="868680" y="5074920"/>
-            <a:ext cx="6035040" cy="822960"/>
+            <a:off x="868680" y="4434840"/>
+            <a:ext cx="8046720" cy="914400"/>
           </a:xfrm>
           <a:prstGeom prst="roundRect">
             <a:avLst>
-              <a:gd name="adj" fmla="val 8889"/>
+              <a:gd name="adj" fmla="val 8000"/>
             </a:avLst>
           </a:prstGeom>
           <a:solidFill>
@@ -13047,8 +13584,8 @@
         </p:nvSpPr>
         <p:spPr>
           <a:xfrm>
-            <a:off x="1033272" y="5239512"/>
-            <a:ext cx="5705856" cy="493776"/>
+            <a:off x="1033272" y="4599432"/>
+            <a:ext cx="7717536" cy="585216"/>
           </a:xfrm>
           <a:prstGeom prst="rect">
             <a:avLst/>
@@ -13222,7 +13759,7 @@
         <p:spPr>
           <a:xfrm>
             <a:off x="868680" y="1417320"/>
-            <a:ext cx="8138160" cy="2743200"/>
+            <a:ext cx="9875520" cy="2743200"/>
           </a:xfrm>
           <a:prstGeom prst="rect">
             <a:avLst/>
@@ -14197,47 +14734,22 @@
           </a:p>
         </p:txBody>
       </p:sp>
-      <p:pic>
-        <p:nvPicPr>
-          <p:cNvPr id="5" name="Image 0" descr="/home/matt.linux/talks/2026/oregon/assets/raw-images/archon-firstproof-og.jpg">    </p:cNvPr>
-          <p:cNvPicPr>
-            <a:picLocks noChangeAspect="1"/>
-          </p:cNvPicPr>
-          <p:nvPr/>
-        </p:nvPicPr>
-        <p:blipFill>
-          <a:blip r:embed="rId1"/>
-          <a:srcRect l="0" r="0" t="0" b="0"/>
-          <a:stretch/>
-        </p:blipFill>
-        <p:spPr>
-          <a:xfrm>
-            <a:off x="868680" y="1417320"/>
-            <a:ext cx="4709160" cy="3154680"/>
-          </a:xfrm>
-          <a:prstGeom prst="rect">
-            <a:avLst/>
-          </a:prstGeom>
-        </p:spPr>
-      </p:pic>
-      <p:sp>
-        <p:nvSpPr>
-          <p:cNvPr id="6" name="Shape 3"/>
-          <p:cNvSpPr/>
-          <p:nvPr/>
-        </p:nvSpPr>
-        <p:spPr>
-          <a:xfrm>
-            <a:off x="868680" y="1417320"/>
-            <a:ext cx="4709160" cy="3154680"/>
+      <p:sp>
+        <p:nvSpPr>
+          <p:cNvPr id="5" name="Shape 3"/>
+          <p:cNvSpPr/>
+          <p:nvPr/>
+        </p:nvSpPr>
+        <p:spPr>
+          <a:xfrm>
+            <a:off x="868680" y="1554480"/>
+            <a:ext cx="4892040" cy="3246120"/>
           </a:xfrm>
           <a:prstGeom prst="rect">
             <a:avLst/>
           </a:prstGeom>
           <a:solidFill>
-            <a:srgbClr val="FFFFFF">
-              <a:alpha val="0"/>
-            </a:srgbClr>
+            <a:srgbClr val="FFFFFF"/>
           </a:solidFill>
           <a:ln w="12700">
             <a:solidFill>
@@ -14247,47 +14759,102 @@
           </a:ln>
         </p:spPr>
       </p:sp>
-      <p:pic>
-        <p:nvPicPr>
-          <p:cNvPr id="7" name="Image 1" descr="/home/matt.linux/talks/2026/oregon/assets/raw-images/frontiermath-banner.png">    </p:cNvPr>
-          <p:cNvPicPr>
-            <a:picLocks noChangeAspect="1"/>
-          </p:cNvPicPr>
-          <p:nvPr/>
-        </p:nvPicPr>
-        <p:blipFill>
-          <a:blip r:embed="rId2"/>
-          <a:srcRect l="0" r="0" t="0" b="0"/>
-          <a:stretch/>
-        </p:blipFill>
-        <p:spPr>
-          <a:xfrm>
-            <a:off x="5760720" y="1417320"/>
-            <a:ext cx="4800600" cy="3154680"/>
-          </a:xfrm>
-          <a:prstGeom prst="rect">
-            <a:avLst/>
-          </a:prstGeom>
-        </p:spPr>
-      </p:pic>
-      <p:sp>
-        <p:nvSpPr>
-          <p:cNvPr id="8" name="Shape 4"/>
-          <p:cNvSpPr/>
-          <p:nvPr/>
-        </p:nvSpPr>
-        <p:spPr>
-          <a:xfrm>
-            <a:off x="5760720" y="1417320"/>
-            <a:ext cx="4800600" cy="3154680"/>
+      <p:sp>
+        <p:nvSpPr>
+          <p:cNvPr id="6" name="Text 4"/>
+          <p:cNvSpPr/>
+          <p:nvPr/>
+        </p:nvSpPr>
+        <p:spPr>
+          <a:xfrm>
+            <a:off x="1033272" y="1700784"/>
+            <a:ext cx="4562856" cy="182880"/>
+          </a:xfrm>
+          <a:prstGeom prst="rect">
+            <a:avLst/>
+          </a:prstGeom>
+          <a:noFill/>
+          <a:ln/>
+        </p:spPr>
+        <p:txBody>
+          <a:bodyPr wrap="square" lIns="0" tIns="0" rIns="0" bIns="0" rtlCol="0" anchor="ctr"/>
+          <a:lstStyle/>
+          <a:p>
+            <a:pPr indent="0" marL="0">
+              <a:buNone/>
+            </a:pPr>
+            <a:r>
+              <a:rPr lang="en-US" sz="1100" b="1" dirty="0">
+                <a:solidFill>
+                  <a:srgbClr val="6B7280"/>
+                </a:solidFill>
+                <a:latin typeface="Arial" pitchFamily="34" charset="0"/>
+                <a:ea typeface="Arial" pitchFamily="34" charset="-122"/>
+                <a:cs typeface="Arial" pitchFamily="34" charset="-120"/>
+              </a:rPr>
+              <a:t>Figure placeholder</a:t>
+            </a:r>
+            <a:endParaRPr lang="en-US" sz="1100" dirty="0"/>
+          </a:p>
+        </p:txBody>
+      </p:sp>
+      <p:sp>
+        <p:nvSpPr>
+          <p:cNvPr id="7" name="Text 5"/>
+          <p:cNvSpPr/>
+          <p:nvPr/>
+        </p:nvSpPr>
+        <p:spPr>
+          <a:xfrm>
+            <a:off x="1033272" y="1965960"/>
+            <a:ext cx="4562856" cy="2624328"/>
+          </a:xfrm>
+          <a:prstGeom prst="rect">
+            <a:avLst/>
+          </a:prstGeom>
+          <a:noFill/>
+          <a:ln/>
+        </p:spPr>
+        <p:txBody>
+          <a:bodyPr wrap="square" lIns="635" tIns="635" rIns="635" bIns="635" rtlCol="0" anchor="ctr">
+            <a:normAutofit/>
+          </a:bodyPr>
+          <a:lstStyle/>
+          <a:p>
+            <a:pPr algn="ctr" indent="0" marL="0">
+              <a:buNone/>
+            </a:pPr>
+            <a:r>
+              <a:rPr lang="en-US" sz="1600" i="1" dirty="0">
+                <a:solidFill>
+                  <a:srgbClr val="6B7280"/>
+                </a:solidFill>
+                <a:latin typeface="Arial" pitchFamily="34" charset="0"/>
+                <a:ea typeface="Arial" pitchFamily="34" charset="-122"/>
+                <a:cs typeface="Arial" pitchFamily="34" charset="-120"/>
+              </a:rPr>
+              <a:t>First Proof figure</a:t>
+            </a:r>
+            <a:endParaRPr lang="en-US" sz="1600" dirty="0"/>
+          </a:p>
+        </p:txBody>
+      </p:sp>
+      <p:sp>
+        <p:nvSpPr>
+          <p:cNvPr id="8" name="Shape 6"/>
+          <p:cNvSpPr/>
+          <p:nvPr/>
+        </p:nvSpPr>
+        <p:spPr>
+          <a:xfrm>
+            <a:off x="5897880" y="1554480"/>
+            <a:ext cx="4892040" cy="3246120"/>
           </a:xfrm>
           <a:prstGeom prst="rect">
             <a:avLst/>
           </a:prstGeom>
           <a:solidFill>
-            <a:srgbClr val="FFFFFF">
-              <a:alpha val="0"/>
-            </a:srgbClr>
+            <a:srgbClr val="FFFFFF"/>
           </a:solidFill>
           <a:ln w="12700">
             <a:solidFill>
@@ -14299,14 +14866,94 @@
       </p:sp>
       <p:sp>
         <p:nvSpPr>
-          <p:cNvPr id="9" name="Text 5"/>
-          <p:cNvSpPr/>
-          <p:nvPr/>
-        </p:nvSpPr>
-        <p:spPr>
-          <a:xfrm>
-            <a:off x="868680" y="4846320"/>
-            <a:ext cx="7772400" cy="731520"/>
+          <p:cNvPr id="9" name="Text 7"/>
+          <p:cNvSpPr/>
+          <p:nvPr/>
+        </p:nvSpPr>
+        <p:spPr>
+          <a:xfrm>
+            <a:off x="6062472" y="1700784"/>
+            <a:ext cx="4562856" cy="182880"/>
+          </a:xfrm>
+          <a:prstGeom prst="rect">
+            <a:avLst/>
+          </a:prstGeom>
+          <a:noFill/>
+          <a:ln/>
+        </p:spPr>
+        <p:txBody>
+          <a:bodyPr wrap="square" lIns="0" tIns="0" rIns="0" bIns="0" rtlCol="0" anchor="ctr"/>
+          <a:lstStyle/>
+          <a:p>
+            <a:pPr indent="0" marL="0">
+              <a:buNone/>
+            </a:pPr>
+            <a:r>
+              <a:rPr lang="en-US" sz="1100" b="1" dirty="0">
+                <a:solidFill>
+                  <a:srgbClr val="6B7280"/>
+                </a:solidFill>
+                <a:latin typeface="Arial" pitchFamily="34" charset="0"/>
+                <a:ea typeface="Arial" pitchFamily="34" charset="-122"/>
+                <a:cs typeface="Arial" pitchFamily="34" charset="-120"/>
+              </a:rPr>
+              <a:t>Figure placeholder</a:t>
+            </a:r>
+            <a:endParaRPr lang="en-US" sz="1100" dirty="0"/>
+          </a:p>
+        </p:txBody>
+      </p:sp>
+      <p:sp>
+        <p:nvSpPr>
+          <p:cNvPr id="10" name="Text 8"/>
+          <p:cNvSpPr/>
+          <p:nvPr/>
+        </p:nvSpPr>
+        <p:spPr>
+          <a:xfrm>
+            <a:off x="6062472" y="1965960"/>
+            <a:ext cx="4562856" cy="2624328"/>
+          </a:xfrm>
+          <a:prstGeom prst="rect">
+            <a:avLst/>
+          </a:prstGeom>
+          <a:noFill/>
+          <a:ln/>
+        </p:spPr>
+        <p:txBody>
+          <a:bodyPr wrap="square" lIns="635" tIns="635" rIns="635" bIns="635" rtlCol="0" anchor="ctr">
+            <a:normAutofit/>
+          </a:bodyPr>
+          <a:lstStyle/>
+          <a:p>
+            <a:pPr algn="ctr" indent="0" marL="0">
+              <a:buNone/>
+            </a:pPr>
+            <a:r>
+              <a:rPr lang="en-US" sz="1600" i="1" dirty="0">
+                <a:solidFill>
+                  <a:srgbClr val="6B7280"/>
+                </a:solidFill>
+                <a:latin typeface="Arial" pitchFamily="34" charset="0"/>
+                <a:ea typeface="Arial" pitchFamily="34" charset="-122"/>
+                <a:cs typeface="Arial" pitchFamily="34" charset="-120"/>
+              </a:rPr>
+              <a:t>FrontierMath figure</a:t>
+            </a:r>
+            <a:endParaRPr lang="en-US" sz="1600" dirty="0"/>
+          </a:p>
+        </p:txBody>
+      </p:sp>
+      <p:sp>
+        <p:nvSpPr>
+          <p:cNvPr id="11" name="Text 9"/>
+          <p:cNvSpPr/>
+          <p:nvPr/>
+        </p:nvSpPr>
+        <p:spPr>
+          <a:xfrm>
+            <a:off x="868680" y="5074920"/>
+            <a:ext cx="9875520" cy="640080"/>
           </a:xfrm>
           <a:prstGeom prst="rect">
             <a:avLst/>
@@ -14488,47 +15135,97 @@
           </a:p>
         </p:txBody>
       </p:sp>
-      <p:pic>
-        <p:nvPicPr>
-          <p:cNvPr id="5" name="Image 0" descr="/home/matt.linux/talks/2026/oregon/assets/raw-images/archon-firstproof-og.jpg">    </p:cNvPr>
-          <p:cNvPicPr>
-            <a:picLocks noChangeAspect="1"/>
-          </p:cNvPicPr>
-          <p:nvPr/>
-        </p:nvPicPr>
-        <p:blipFill>
-          <a:blip r:embed="rId1"/>
-          <a:srcRect l="0" r="0" t="0" b="0"/>
-          <a:stretch/>
-        </p:blipFill>
-        <p:spPr>
-          <a:xfrm>
-            <a:off x="868680" y="1325880"/>
-            <a:ext cx="5486400" cy="3840480"/>
-          </a:xfrm>
-          <a:prstGeom prst="rect">
-            <a:avLst/>
-          </a:prstGeom>
-        </p:spPr>
-      </p:pic>
-      <p:sp>
-        <p:nvSpPr>
-          <p:cNvPr id="6" name="Shape 3"/>
-          <p:cNvSpPr/>
-          <p:nvPr/>
-        </p:nvSpPr>
-        <p:spPr>
-          <a:xfrm>
-            <a:off x="868680" y="1325880"/>
-            <a:ext cx="5486400" cy="3840480"/>
+      <p:sp>
+        <p:nvSpPr>
+          <p:cNvPr id="5" name="Text 3"/>
+          <p:cNvSpPr/>
+          <p:nvPr/>
+        </p:nvSpPr>
+        <p:spPr>
+          <a:xfrm>
+            <a:off x="868680" y="1371600"/>
+            <a:ext cx="10149840" cy="1417320"/>
+          </a:xfrm>
+          <a:prstGeom prst="rect">
+            <a:avLst/>
+          </a:prstGeom>
+          <a:noFill/>
+          <a:ln/>
+        </p:spPr>
+        <p:txBody>
+          <a:bodyPr wrap="square" lIns="381" tIns="381" rIns="381" bIns="381" rtlCol="0" anchor="t">
+            <a:normAutofit/>
+          </a:bodyPr>
+          <a:lstStyle/>
+          <a:p>
+            <a:pPr indent="0" marL="0">
+              <a:buNone/>
+            </a:pPr>
+            <a:r>
+              <a:rPr lang="en-US" sz="1800" dirty="0">
+                <a:solidFill>
+                  <a:srgbClr val="1D232B"/>
+                </a:solidFill>
+                <a:latin typeface="Arial" pitchFamily="34" charset="0"/>
+                <a:ea typeface="Arial" pitchFamily="34" charset="-122"/>
+                <a:cs typeface="Arial" pitchFamily="34" charset="-120"/>
+              </a:rPr>
+              <a:t>First Proof evaluates olympiad-style proof generation.</a:t>
+            </a:r>
+            <a:endParaRPr lang="en-US" sz="1800" dirty="0"/>
+          </a:p>
+          <a:p>
+            <a:pPr indent="0" marL="0">
+              <a:buNone/>
+            </a:pPr>
+            <a:r>
+              <a:rPr lang="en-US" sz="1800" dirty="0">
+                <a:solidFill>
+                  <a:srgbClr val="1D232B"/>
+                </a:solidFill>
+                <a:latin typeface="Arial" pitchFamily="34" charset="0"/>
+                <a:ea typeface="Arial" pitchFamily="34" charset="-122"/>
+                <a:cs typeface="Arial" pitchFamily="34" charset="-120"/>
+              </a:rPr>
+              <a:t>This is still an artificial setting, but it is at least recognizable mathematics.</a:t>
+            </a:r>
+            <a:endParaRPr lang="en-US" sz="1800" dirty="0"/>
+          </a:p>
+          <a:p>
+            <a:pPr indent="0" marL="0">
+              <a:buNone/>
+            </a:pPr>
+            <a:r>
+              <a:rPr lang="en-US" sz="1800" dirty="0">
+                <a:solidFill>
+                  <a:srgbClr val="1D232B"/>
+                </a:solidFill>
+                <a:latin typeface="Arial" pitchFamily="34" charset="0"/>
+                <a:ea typeface="Arial" pitchFamily="34" charset="-122"/>
+                <a:cs typeface="Arial" pitchFamily="34" charset="-120"/>
+              </a:rPr>
+              <a:t>It asks for sustained reasoning, not just short-answer pattern matching.</a:t>
+            </a:r>
+            <a:endParaRPr lang="en-US" sz="1800" dirty="0"/>
+          </a:p>
+        </p:txBody>
+      </p:sp>
+      <p:sp>
+        <p:nvSpPr>
+          <p:cNvPr id="6" name="Shape 4"/>
+          <p:cNvSpPr/>
+          <p:nvPr/>
+        </p:nvSpPr>
+        <p:spPr>
+          <a:xfrm>
+            <a:off x="868680" y="3063240"/>
+            <a:ext cx="10149840" cy="2286000"/>
           </a:xfrm>
           <a:prstGeom prst="rect">
             <a:avLst/>
           </a:prstGeom>
           <a:solidFill>
-            <a:srgbClr val="FFFFFF">
-              <a:alpha val="0"/>
-            </a:srgbClr>
+            <a:srgbClr val="FFFFFF"/>
           </a:solidFill>
           <a:ln w="12700">
             <a:solidFill>
@@ -14540,76 +15237,81 @@
       </p:sp>
       <p:sp>
         <p:nvSpPr>
-          <p:cNvPr id="7" name="Text 4"/>
-          <p:cNvSpPr/>
-          <p:nvPr/>
-        </p:nvSpPr>
-        <p:spPr>
-          <a:xfrm>
-            <a:off x="6675120" y="1417320"/>
-            <a:ext cx="4572000" cy="3291840"/>
-          </a:xfrm>
-          <a:prstGeom prst="rect">
-            <a:avLst/>
-          </a:prstGeom>
-          <a:noFill/>
-          <a:ln/>
-        </p:spPr>
-        <p:txBody>
-          <a:bodyPr wrap="square" lIns="381" tIns="381" rIns="381" bIns="381" rtlCol="0" anchor="t">
+          <p:cNvPr id="7" name="Text 5"/>
+          <p:cNvSpPr/>
+          <p:nvPr/>
+        </p:nvSpPr>
+        <p:spPr>
+          <a:xfrm>
+            <a:off x="1033272" y="3209544"/>
+            <a:ext cx="9820656" cy="182880"/>
+          </a:xfrm>
+          <a:prstGeom prst="rect">
+            <a:avLst/>
+          </a:prstGeom>
+          <a:noFill/>
+          <a:ln/>
+        </p:spPr>
+        <p:txBody>
+          <a:bodyPr wrap="square" lIns="0" tIns="0" rIns="0" bIns="0" rtlCol="0" anchor="ctr"/>
+          <a:lstStyle/>
+          <a:p>
+            <a:pPr indent="0" marL="0">
+              <a:buNone/>
+            </a:pPr>
+            <a:r>
+              <a:rPr lang="en-US" sz="1100" b="1" dirty="0">
+                <a:solidFill>
+                  <a:srgbClr val="6B7280"/>
+                </a:solidFill>
+                <a:latin typeface="Arial" pitchFamily="34" charset="0"/>
+                <a:ea typeface="Arial" pitchFamily="34" charset="-122"/>
+                <a:cs typeface="Arial" pitchFamily="34" charset="-120"/>
+              </a:rPr>
+              <a:t>Figure placeholder</a:t>
+            </a:r>
+            <a:endParaRPr lang="en-US" sz="1100" dirty="0"/>
+          </a:p>
+        </p:txBody>
+      </p:sp>
+      <p:sp>
+        <p:nvSpPr>
+          <p:cNvPr id="8" name="Text 6"/>
+          <p:cNvSpPr/>
+          <p:nvPr/>
+        </p:nvSpPr>
+        <p:spPr>
+          <a:xfrm>
+            <a:off x="1033272" y="3474720"/>
+            <a:ext cx="9820656" cy="1664208"/>
+          </a:xfrm>
+          <a:prstGeom prst="rect">
+            <a:avLst/>
+          </a:prstGeom>
+          <a:noFill/>
+          <a:ln/>
+        </p:spPr>
+        <p:txBody>
+          <a:bodyPr wrap="square" lIns="635" tIns="635" rIns="635" bIns="635" rtlCol="0" anchor="ctr">
             <a:normAutofit/>
           </a:bodyPr>
           <a:lstStyle/>
           <a:p>
-            <a:pPr indent="0" marL="0">
-              <a:buNone/>
-            </a:pPr>
-            <a:r>
-              <a:rPr lang="en-US" sz="1800" dirty="0">
-                <a:solidFill>
-                  <a:srgbClr val="1D232B"/>
-                </a:solidFill>
-                <a:latin typeface="Arial" pitchFamily="34" charset="0"/>
-                <a:ea typeface="Arial" pitchFamily="34" charset="-122"/>
-                <a:cs typeface="Arial" pitchFamily="34" charset="-120"/>
-              </a:rPr>
-              <a:t>First Proof evaluates olympiad-style proof generation.</a:t>
-            </a:r>
-            <a:endParaRPr lang="en-US" sz="1800" dirty="0"/>
-          </a:p>
-          <a:p>
-            <a:pPr indent="0" marL="0">
-              <a:buNone/>
-            </a:pPr>
-            <a:r>
-              <a:rPr lang="en-US" sz="1800" dirty="0">
-                <a:solidFill>
-                  <a:srgbClr val="1D232B"/>
-                </a:solidFill>
-                <a:latin typeface="Arial" pitchFamily="34" charset="0"/>
-                <a:ea typeface="Arial" pitchFamily="34" charset="-122"/>
-                <a:cs typeface="Arial" pitchFamily="34" charset="-120"/>
-              </a:rPr>
-              <a:t>This is still an artificial setting, but it is at least recognizable mathematics.</a:t>
-            </a:r>
-            <a:endParaRPr lang="en-US" sz="1800" dirty="0"/>
-          </a:p>
-          <a:p>
-            <a:pPr indent="0" marL="0">
-              <a:buNone/>
-            </a:pPr>
-            <a:r>
-              <a:rPr lang="en-US" sz="1800" dirty="0">
-                <a:solidFill>
-                  <a:srgbClr val="1D232B"/>
-                </a:solidFill>
-                <a:latin typeface="Arial" pitchFamily="34" charset="0"/>
-                <a:ea typeface="Arial" pitchFamily="34" charset="-122"/>
-                <a:cs typeface="Arial" pitchFamily="34" charset="-120"/>
-              </a:rPr>
-              <a:t>It asks for sustained reasoning, not just short-answer pattern matching.</a:t>
-            </a:r>
-            <a:endParaRPr lang="en-US" sz="1800" dirty="0"/>
+            <a:pPr algn="ctr" indent="0" marL="0">
+              <a:buNone/>
+            </a:pPr>
+            <a:r>
+              <a:rPr lang="en-US" sz="1600" i="1" dirty="0">
+                <a:solidFill>
+                  <a:srgbClr val="6B7280"/>
+                </a:solidFill>
+                <a:latin typeface="Arial" pitchFamily="34" charset="0"/>
+                <a:ea typeface="Arial" pitchFamily="34" charset="-122"/>
+                <a:cs typeface="Arial" pitchFamily="34" charset="-120"/>
+              </a:rPr>
+              <a:t>Insert First Proof figure</a:t>
+            </a:r>
+            <a:endParaRPr lang="en-US" sz="1600" dirty="0"/>
           </a:p>
         </p:txBody>
       </p:sp>
@@ -14746,47 +15448,97 @@
           </a:p>
         </p:txBody>
       </p:sp>
-      <p:pic>
-        <p:nvPicPr>
-          <p:cNvPr id="5" name="Image 0" descr="/home/matt.linux/talks/2026/oregon/assets/raw-images/frontiermath-banner.png">    </p:cNvPr>
-          <p:cNvPicPr>
-            <a:picLocks noChangeAspect="1"/>
-          </p:cNvPicPr>
-          <p:nvPr/>
-        </p:nvPicPr>
-        <p:blipFill>
-          <a:blip r:embed="rId1"/>
-          <a:srcRect l="0" r="0" t="0" b="0"/>
-          <a:stretch/>
-        </p:blipFill>
-        <p:spPr>
-          <a:xfrm>
-            <a:off x="868680" y="1325880"/>
-            <a:ext cx="5486400" cy="3840480"/>
-          </a:xfrm>
-          <a:prstGeom prst="rect">
-            <a:avLst/>
-          </a:prstGeom>
-        </p:spPr>
-      </p:pic>
-      <p:sp>
-        <p:nvSpPr>
-          <p:cNvPr id="6" name="Shape 3"/>
-          <p:cNvSpPr/>
-          <p:nvPr/>
-        </p:nvSpPr>
-        <p:spPr>
-          <a:xfrm>
-            <a:off x="868680" y="1325880"/>
-            <a:ext cx="5486400" cy="3840480"/>
+      <p:sp>
+        <p:nvSpPr>
+          <p:cNvPr id="5" name="Text 3"/>
+          <p:cNvSpPr/>
+          <p:nvPr/>
+        </p:nvSpPr>
+        <p:spPr>
+          <a:xfrm>
+            <a:off x="868680" y="1371600"/>
+            <a:ext cx="10149840" cy="1417320"/>
+          </a:xfrm>
+          <a:prstGeom prst="rect">
+            <a:avLst/>
+          </a:prstGeom>
+          <a:noFill/>
+          <a:ln/>
+        </p:spPr>
+        <p:txBody>
+          <a:bodyPr wrap="square" lIns="381" tIns="381" rIns="381" bIns="381" rtlCol="0" anchor="t">
+            <a:normAutofit/>
+          </a:bodyPr>
+          <a:lstStyle/>
+          <a:p>
+            <a:pPr indent="0" marL="0">
+              <a:buNone/>
+            </a:pPr>
+            <a:r>
+              <a:rPr lang="en-US" sz="1800" dirty="0">
+                <a:solidFill>
+                  <a:srgbClr val="1D232B"/>
+                </a:solidFill>
+                <a:latin typeface="Arial" pitchFamily="34" charset="0"/>
+                <a:ea typeface="Arial" pitchFamily="34" charset="-122"/>
+                <a:cs typeface="Arial" pitchFamily="34" charset="-120"/>
+              </a:rPr>
+              <a:t>FrontierMath was designed to probe much harder mathematics.</a:t>
+            </a:r>
+            <a:endParaRPr lang="en-US" sz="1800" dirty="0"/>
+          </a:p>
+          <a:p>
+            <a:pPr indent="0" marL="0">
+              <a:buNone/>
+            </a:pPr>
+            <a:r>
+              <a:rPr lang="en-US" sz="1800" dirty="0">
+                <a:solidFill>
+                  <a:srgbClr val="1D232B"/>
+                </a:solidFill>
+                <a:latin typeface="Arial" pitchFamily="34" charset="0"/>
+                <a:ea typeface="Arial" pitchFamily="34" charset="-122"/>
+                <a:cs typeface="Arial" pitchFamily="34" charset="-120"/>
+              </a:rPr>
+              <a:t>Its harder tiers aim beyond standard benchmark questions</a:t>
+            </a:r>
+            <a:endParaRPr lang="en-US" sz="1800" dirty="0"/>
+          </a:p>
+          <a:p>
+            <a:pPr indent="0" marL="0">
+              <a:buNone/>
+            </a:pPr>
+            <a:r>
+              <a:rPr lang="en-US" sz="1800" dirty="0">
+                <a:solidFill>
+                  <a:srgbClr val="1D232B"/>
+                </a:solidFill>
+                <a:latin typeface="Arial" pitchFamily="34" charset="0"/>
+                <a:ea typeface="Arial" pitchFamily="34" charset="-122"/>
+                <a:cs typeface="Arial" pitchFamily="34" charset="-120"/>
+              </a:rPr>
+              <a:t>and are meant to resist superficial pattern matching.</a:t>
+            </a:r>
+            <a:endParaRPr lang="en-US" sz="1800" dirty="0"/>
+          </a:p>
+        </p:txBody>
+      </p:sp>
+      <p:sp>
+        <p:nvSpPr>
+          <p:cNvPr id="6" name="Shape 4"/>
+          <p:cNvSpPr/>
+          <p:nvPr/>
+        </p:nvSpPr>
+        <p:spPr>
+          <a:xfrm>
+            <a:off x="868680" y="3063240"/>
+            <a:ext cx="10149840" cy="2286000"/>
           </a:xfrm>
           <a:prstGeom prst="rect">
             <a:avLst/>
           </a:prstGeom>
           <a:solidFill>
-            <a:srgbClr val="FFFFFF">
-              <a:alpha val="0"/>
-            </a:srgbClr>
+            <a:srgbClr val="FFFFFF"/>
           </a:solidFill>
           <a:ln w="12700">
             <a:solidFill>
@@ -14798,76 +15550,81 @@
       </p:sp>
       <p:sp>
         <p:nvSpPr>
-          <p:cNvPr id="7" name="Text 4"/>
-          <p:cNvSpPr/>
-          <p:nvPr/>
-        </p:nvSpPr>
-        <p:spPr>
-          <a:xfrm>
-            <a:off x="6675120" y="1417320"/>
-            <a:ext cx="4572000" cy="3291840"/>
-          </a:xfrm>
-          <a:prstGeom prst="rect">
-            <a:avLst/>
-          </a:prstGeom>
-          <a:noFill/>
-          <a:ln/>
-        </p:spPr>
-        <p:txBody>
-          <a:bodyPr wrap="square" lIns="381" tIns="381" rIns="381" bIns="381" rtlCol="0" anchor="t">
+          <p:cNvPr id="7" name="Text 5"/>
+          <p:cNvSpPr/>
+          <p:nvPr/>
+        </p:nvSpPr>
+        <p:spPr>
+          <a:xfrm>
+            <a:off x="1033272" y="3209544"/>
+            <a:ext cx="9820656" cy="182880"/>
+          </a:xfrm>
+          <a:prstGeom prst="rect">
+            <a:avLst/>
+          </a:prstGeom>
+          <a:noFill/>
+          <a:ln/>
+        </p:spPr>
+        <p:txBody>
+          <a:bodyPr wrap="square" lIns="0" tIns="0" rIns="0" bIns="0" rtlCol="0" anchor="ctr"/>
+          <a:lstStyle/>
+          <a:p>
+            <a:pPr indent="0" marL="0">
+              <a:buNone/>
+            </a:pPr>
+            <a:r>
+              <a:rPr lang="en-US" sz="1100" b="1" dirty="0">
+                <a:solidFill>
+                  <a:srgbClr val="6B7280"/>
+                </a:solidFill>
+                <a:latin typeface="Arial" pitchFamily="34" charset="0"/>
+                <a:ea typeface="Arial" pitchFamily="34" charset="-122"/>
+                <a:cs typeface="Arial" pitchFamily="34" charset="-120"/>
+              </a:rPr>
+              <a:t>Figure placeholder</a:t>
+            </a:r>
+            <a:endParaRPr lang="en-US" sz="1100" dirty="0"/>
+          </a:p>
+        </p:txBody>
+      </p:sp>
+      <p:sp>
+        <p:nvSpPr>
+          <p:cNvPr id="8" name="Text 6"/>
+          <p:cNvSpPr/>
+          <p:nvPr/>
+        </p:nvSpPr>
+        <p:spPr>
+          <a:xfrm>
+            <a:off x="1033272" y="3474720"/>
+            <a:ext cx="9820656" cy="1664208"/>
+          </a:xfrm>
+          <a:prstGeom prst="rect">
+            <a:avLst/>
+          </a:prstGeom>
+          <a:noFill/>
+          <a:ln/>
+        </p:spPr>
+        <p:txBody>
+          <a:bodyPr wrap="square" lIns="635" tIns="635" rIns="635" bIns="635" rtlCol="0" anchor="ctr">
             <a:normAutofit/>
           </a:bodyPr>
           <a:lstStyle/>
           <a:p>
-            <a:pPr indent="0" marL="0">
-              <a:buNone/>
-            </a:pPr>
-            <a:r>
-              <a:rPr lang="en-US" sz="1800" dirty="0">
-                <a:solidFill>
-                  <a:srgbClr val="1D232B"/>
-                </a:solidFill>
-                <a:latin typeface="Arial" pitchFamily="34" charset="0"/>
-                <a:ea typeface="Arial" pitchFamily="34" charset="-122"/>
-                <a:cs typeface="Arial" pitchFamily="34" charset="-120"/>
-              </a:rPr>
-              <a:t>FrontierMath was designed to probe much harder mathematics.</a:t>
-            </a:r>
-            <a:endParaRPr lang="en-US" sz="1800" dirty="0"/>
-          </a:p>
-          <a:p>
-            <a:pPr indent="0" marL="0">
-              <a:buNone/>
-            </a:pPr>
-            <a:r>
-              <a:rPr lang="en-US" sz="1800" dirty="0">
-                <a:solidFill>
-                  <a:srgbClr val="1D232B"/>
-                </a:solidFill>
-                <a:latin typeface="Arial" pitchFamily="34" charset="0"/>
-                <a:ea typeface="Arial" pitchFamily="34" charset="-122"/>
-                <a:cs typeface="Arial" pitchFamily="34" charset="-120"/>
-              </a:rPr>
-              <a:t>Its harder tiers aim beyond standard benchmark questions</a:t>
-            </a:r>
-            <a:endParaRPr lang="en-US" sz="1800" dirty="0"/>
-          </a:p>
-          <a:p>
-            <a:pPr indent="0" marL="0">
-              <a:buNone/>
-            </a:pPr>
-            <a:r>
-              <a:rPr lang="en-US" sz="1800" dirty="0">
-                <a:solidFill>
-                  <a:srgbClr val="1D232B"/>
-                </a:solidFill>
-                <a:latin typeface="Arial" pitchFamily="34" charset="0"/>
-                <a:ea typeface="Arial" pitchFamily="34" charset="-122"/>
-                <a:cs typeface="Arial" pitchFamily="34" charset="-120"/>
-              </a:rPr>
-              <a:t>and are meant to resist superficial pattern matching.</a:t>
-            </a:r>
-            <a:endParaRPr lang="en-US" sz="1800" dirty="0"/>
+            <a:pPr algn="ctr" indent="0" marL="0">
+              <a:buNone/>
+            </a:pPr>
+            <a:r>
+              <a:rPr lang="en-US" sz="1600" i="1" dirty="0">
+                <a:solidFill>
+                  <a:srgbClr val="6B7280"/>
+                </a:solidFill>
+                <a:latin typeface="Arial" pitchFamily="34" charset="0"/>
+                <a:ea typeface="Arial" pitchFamily="34" charset="-122"/>
+                <a:cs typeface="Arial" pitchFamily="34" charset="-120"/>
+              </a:rPr>
+              <a:t>Insert FrontierMath figure or Tier 4 leaderboard</a:t>
+            </a:r>
+            <a:endParaRPr lang="en-US" sz="1600" dirty="0"/>
           </a:p>
         </p:txBody>
       </p:sp>

</xml_diff>